<commit_message>
Update hallucination dataset and add bar chart image
Expanded test/gpt-4o_mutation_outputs_dataset20250926_hallucination.csv with new columns and updated entries, improving data structure and clarity. Added bar_chart_square.png to test/stat/. Made updates to test/stat/calculate2.py, data.xlsx, and figure.py, and modified test/llm_prompts/prompts.py and its compiled cache. Updated slides/20251113.pptx with new content.
</commit_message>
<xml_diff>
--- a/slides/20251113.pptx
+++ b/slides/20251113.pptx
@@ -265,7 +265,7 @@
           <a:p>
             <a:fld id="{3F567BA6-CBC2-4FF0-810E-3ED1BF2C4381}" type="datetimeFigureOut">
               <a:rPr lang="zh-CN" altLang="en-US" smtClean="0"/>
-              <a:t>2025/11/12</a:t>
+              <a:t>2025/11/17</a:t>
             </a:fld>
             <a:endParaRPr lang="zh-CN" altLang="en-US"/>
           </a:p>
@@ -463,7 +463,7 @@
           <a:p>
             <a:fld id="{3F567BA6-CBC2-4FF0-810E-3ED1BF2C4381}" type="datetimeFigureOut">
               <a:rPr lang="zh-CN" altLang="en-US" smtClean="0"/>
-              <a:t>2025/11/12</a:t>
+              <a:t>2025/11/17</a:t>
             </a:fld>
             <a:endParaRPr lang="zh-CN" altLang="en-US"/>
           </a:p>
@@ -671,7 +671,7 @@
           <a:p>
             <a:fld id="{3F567BA6-CBC2-4FF0-810E-3ED1BF2C4381}" type="datetimeFigureOut">
               <a:rPr lang="zh-CN" altLang="en-US" smtClean="0"/>
-              <a:t>2025/11/12</a:t>
+              <a:t>2025/11/17</a:t>
             </a:fld>
             <a:endParaRPr lang="zh-CN" altLang="en-US"/>
           </a:p>
@@ -869,7 +869,7 @@
           <a:p>
             <a:fld id="{3F567BA6-CBC2-4FF0-810E-3ED1BF2C4381}" type="datetimeFigureOut">
               <a:rPr lang="zh-CN" altLang="en-US" smtClean="0"/>
-              <a:t>2025/11/12</a:t>
+              <a:t>2025/11/17</a:t>
             </a:fld>
             <a:endParaRPr lang="zh-CN" altLang="en-US"/>
           </a:p>
@@ -1144,7 +1144,7 @@
           <a:p>
             <a:fld id="{3F567BA6-CBC2-4FF0-810E-3ED1BF2C4381}" type="datetimeFigureOut">
               <a:rPr lang="zh-CN" altLang="en-US" smtClean="0"/>
-              <a:t>2025/11/12</a:t>
+              <a:t>2025/11/17</a:t>
             </a:fld>
             <a:endParaRPr lang="zh-CN" altLang="en-US"/>
           </a:p>
@@ -1409,7 +1409,7 @@
           <a:p>
             <a:fld id="{3F567BA6-CBC2-4FF0-810E-3ED1BF2C4381}" type="datetimeFigureOut">
               <a:rPr lang="zh-CN" altLang="en-US" smtClean="0"/>
-              <a:t>2025/11/12</a:t>
+              <a:t>2025/11/17</a:t>
             </a:fld>
             <a:endParaRPr lang="zh-CN" altLang="en-US"/>
           </a:p>
@@ -1821,7 +1821,7 @@
           <a:p>
             <a:fld id="{3F567BA6-CBC2-4FF0-810E-3ED1BF2C4381}" type="datetimeFigureOut">
               <a:rPr lang="zh-CN" altLang="en-US" smtClean="0"/>
-              <a:t>2025/11/12</a:t>
+              <a:t>2025/11/17</a:t>
             </a:fld>
             <a:endParaRPr lang="zh-CN" altLang="en-US"/>
           </a:p>
@@ -1962,7 +1962,7 @@
           <a:p>
             <a:fld id="{3F567BA6-CBC2-4FF0-810E-3ED1BF2C4381}" type="datetimeFigureOut">
               <a:rPr lang="zh-CN" altLang="en-US" smtClean="0"/>
-              <a:t>2025/11/12</a:t>
+              <a:t>2025/11/17</a:t>
             </a:fld>
             <a:endParaRPr lang="zh-CN" altLang="en-US"/>
           </a:p>
@@ -2075,7 +2075,7 @@
           <a:p>
             <a:fld id="{3F567BA6-CBC2-4FF0-810E-3ED1BF2C4381}" type="datetimeFigureOut">
               <a:rPr lang="zh-CN" altLang="en-US" smtClean="0"/>
-              <a:t>2025/11/12</a:t>
+              <a:t>2025/11/17</a:t>
             </a:fld>
             <a:endParaRPr lang="zh-CN" altLang="en-US"/>
           </a:p>
@@ -2386,7 +2386,7 @@
           <a:p>
             <a:fld id="{3F567BA6-CBC2-4FF0-810E-3ED1BF2C4381}" type="datetimeFigureOut">
               <a:rPr lang="zh-CN" altLang="en-US" smtClean="0"/>
-              <a:t>2025/11/12</a:t>
+              <a:t>2025/11/17</a:t>
             </a:fld>
             <a:endParaRPr lang="zh-CN" altLang="en-US"/>
           </a:p>
@@ -2674,7 +2674,7 @@
           <a:p>
             <a:fld id="{3F567BA6-CBC2-4FF0-810E-3ED1BF2C4381}" type="datetimeFigureOut">
               <a:rPr lang="zh-CN" altLang="en-US" smtClean="0"/>
-              <a:t>2025/11/12</a:t>
+              <a:t>2025/11/17</a:t>
             </a:fld>
             <a:endParaRPr lang="zh-CN" altLang="en-US"/>
           </a:p>
@@ -2915,7 +2915,7 @@
           <a:p>
             <a:fld id="{3F567BA6-CBC2-4FF0-810E-3ED1BF2C4381}" type="datetimeFigureOut">
               <a:rPr lang="zh-CN" altLang="en-US" smtClean="0"/>
-              <a:t>2025/11/12</a:t>
+              <a:t>2025/11/17</a:t>
             </a:fld>
             <a:endParaRPr lang="zh-CN" altLang="en-US"/>
           </a:p>
@@ -4235,7 +4235,7 @@
 </file>
 
 <file path=ppt/slides/slide5.xml><?xml version="1.0" encoding="utf-8"?>
-<p:sld xmlns:a="http://schemas.openxmlformats.org/drawingml/2006/main" xmlns:r="http://schemas.openxmlformats.org/officeDocument/2006/relationships" xmlns:p="http://schemas.openxmlformats.org/presentationml/2006/main">
+<p:sld xmlns:a="http://schemas.openxmlformats.org/drawingml/2006/main" xmlns:r="http://schemas.openxmlformats.org/officeDocument/2006/relationships" xmlns:p="http://schemas.openxmlformats.org/presentationml/2006/main" show="0">
   <p:cSld>
     <p:spTree>
       <p:nvGrpSpPr>
@@ -4522,7 +4522,7 @@
 </file>
 
 <file path=ppt/slides/slide6.xml><?xml version="1.0" encoding="utf-8"?>
-<p:sld xmlns:a="http://schemas.openxmlformats.org/drawingml/2006/main" xmlns:r="http://schemas.openxmlformats.org/officeDocument/2006/relationships" xmlns:p="http://schemas.openxmlformats.org/presentationml/2006/main">
+<p:sld xmlns:a="http://schemas.openxmlformats.org/drawingml/2006/main" xmlns:r="http://schemas.openxmlformats.org/officeDocument/2006/relationships" xmlns:p="http://schemas.openxmlformats.org/presentationml/2006/main" show="0">
   <p:cSld>
     <p:spTree>
       <p:nvGrpSpPr>

</xml_diff>

<commit_message>
Add accuracy and overcorrection figures and scripts
Added new Python scripts and generated PNGs for accuracy and overcorrection bar charts in test/stat/. Renamed bar_chart_square.png and figure.py to recheck_hallucination.png and recheck_hallucination_figure.py, updating the script to match. Updated data.xlsx and slides/20251113.pptx to reflect new results.
</commit_message>
<xml_diff>
--- a/slides/20251113.pptx
+++ b/slides/20251113.pptx
@@ -265,7 +265,7 @@
           <a:p>
             <a:fld id="{3F567BA6-CBC2-4FF0-810E-3ED1BF2C4381}" type="datetimeFigureOut">
               <a:rPr lang="zh-CN" altLang="en-US" smtClean="0"/>
-              <a:t>2025/11/17</a:t>
+              <a:t>2025/11/19</a:t>
             </a:fld>
             <a:endParaRPr lang="zh-CN" altLang="en-US"/>
           </a:p>
@@ -463,7 +463,7 @@
           <a:p>
             <a:fld id="{3F567BA6-CBC2-4FF0-810E-3ED1BF2C4381}" type="datetimeFigureOut">
               <a:rPr lang="zh-CN" altLang="en-US" smtClean="0"/>
-              <a:t>2025/11/17</a:t>
+              <a:t>2025/11/19</a:t>
             </a:fld>
             <a:endParaRPr lang="zh-CN" altLang="en-US"/>
           </a:p>
@@ -671,7 +671,7 @@
           <a:p>
             <a:fld id="{3F567BA6-CBC2-4FF0-810E-3ED1BF2C4381}" type="datetimeFigureOut">
               <a:rPr lang="zh-CN" altLang="en-US" smtClean="0"/>
-              <a:t>2025/11/17</a:t>
+              <a:t>2025/11/19</a:t>
             </a:fld>
             <a:endParaRPr lang="zh-CN" altLang="en-US"/>
           </a:p>
@@ -869,7 +869,7 @@
           <a:p>
             <a:fld id="{3F567BA6-CBC2-4FF0-810E-3ED1BF2C4381}" type="datetimeFigureOut">
               <a:rPr lang="zh-CN" altLang="en-US" smtClean="0"/>
-              <a:t>2025/11/17</a:t>
+              <a:t>2025/11/19</a:t>
             </a:fld>
             <a:endParaRPr lang="zh-CN" altLang="en-US"/>
           </a:p>
@@ -1144,7 +1144,7 @@
           <a:p>
             <a:fld id="{3F567BA6-CBC2-4FF0-810E-3ED1BF2C4381}" type="datetimeFigureOut">
               <a:rPr lang="zh-CN" altLang="en-US" smtClean="0"/>
-              <a:t>2025/11/17</a:t>
+              <a:t>2025/11/19</a:t>
             </a:fld>
             <a:endParaRPr lang="zh-CN" altLang="en-US"/>
           </a:p>
@@ -1409,7 +1409,7 @@
           <a:p>
             <a:fld id="{3F567BA6-CBC2-4FF0-810E-3ED1BF2C4381}" type="datetimeFigureOut">
               <a:rPr lang="zh-CN" altLang="en-US" smtClean="0"/>
-              <a:t>2025/11/17</a:t>
+              <a:t>2025/11/19</a:t>
             </a:fld>
             <a:endParaRPr lang="zh-CN" altLang="en-US"/>
           </a:p>
@@ -1821,7 +1821,7 @@
           <a:p>
             <a:fld id="{3F567BA6-CBC2-4FF0-810E-3ED1BF2C4381}" type="datetimeFigureOut">
               <a:rPr lang="zh-CN" altLang="en-US" smtClean="0"/>
-              <a:t>2025/11/17</a:t>
+              <a:t>2025/11/19</a:t>
             </a:fld>
             <a:endParaRPr lang="zh-CN" altLang="en-US"/>
           </a:p>
@@ -1962,7 +1962,7 @@
           <a:p>
             <a:fld id="{3F567BA6-CBC2-4FF0-810E-3ED1BF2C4381}" type="datetimeFigureOut">
               <a:rPr lang="zh-CN" altLang="en-US" smtClean="0"/>
-              <a:t>2025/11/17</a:t>
+              <a:t>2025/11/19</a:t>
             </a:fld>
             <a:endParaRPr lang="zh-CN" altLang="en-US"/>
           </a:p>
@@ -2075,7 +2075,7 @@
           <a:p>
             <a:fld id="{3F567BA6-CBC2-4FF0-810E-3ED1BF2C4381}" type="datetimeFigureOut">
               <a:rPr lang="zh-CN" altLang="en-US" smtClean="0"/>
-              <a:t>2025/11/17</a:t>
+              <a:t>2025/11/19</a:t>
             </a:fld>
             <a:endParaRPr lang="zh-CN" altLang="en-US"/>
           </a:p>
@@ -2386,7 +2386,7 @@
           <a:p>
             <a:fld id="{3F567BA6-CBC2-4FF0-810E-3ED1BF2C4381}" type="datetimeFigureOut">
               <a:rPr lang="zh-CN" altLang="en-US" smtClean="0"/>
-              <a:t>2025/11/17</a:t>
+              <a:t>2025/11/19</a:t>
             </a:fld>
             <a:endParaRPr lang="zh-CN" altLang="en-US"/>
           </a:p>
@@ -2674,7 +2674,7 @@
           <a:p>
             <a:fld id="{3F567BA6-CBC2-4FF0-810E-3ED1BF2C4381}" type="datetimeFigureOut">
               <a:rPr lang="zh-CN" altLang="en-US" smtClean="0"/>
-              <a:t>2025/11/17</a:t>
+              <a:t>2025/11/19</a:t>
             </a:fld>
             <a:endParaRPr lang="zh-CN" altLang="en-US"/>
           </a:p>
@@ -2915,7 +2915,7 @@
           <a:p>
             <a:fld id="{3F567BA6-CBC2-4FF0-810E-3ED1BF2C4381}" type="datetimeFigureOut">
               <a:rPr lang="zh-CN" altLang="en-US" smtClean="0"/>
-              <a:t>2025/11/17</a:t>
+              <a:t>2025/11/19</a:t>
             </a:fld>
             <a:endParaRPr lang="zh-CN" altLang="en-US"/>
           </a:p>
@@ -4093,7 +4093,7 @@
                 <a:latin typeface="Arial" panose="020B0604020202020204" pitchFamily="34" charset="0"/>
                 <a:cs typeface="Arial" panose="020B0604020202020204" pitchFamily="34" charset="0"/>
               </a:rPr>
-              <a:t>unnecessary repair: </a:t>
+              <a:t>overcorrection: </a:t>
             </a:r>
             <a:r>
               <a:rPr lang="en-US" altLang="zh-CN" sz="2000" b="1" dirty="0" err="1">
@@ -4221,6 +4221,1167 @@
           <a:chExt cx="0" cy="0"/>
         </a:xfrm>
       </p:grpSpPr>
+      <p:pic>
+        <p:nvPicPr>
+          <p:cNvPr id="3" name="图片 2" descr="图表, 条形图&#10;&#10;AI 生成的内容可能不正确。">
+            <a:extLst>
+              <a:ext uri="{FF2B5EF4-FFF2-40B4-BE49-F238E27FC236}">
+                <a16:creationId xmlns:a16="http://schemas.microsoft.com/office/drawing/2014/main" id="{1BCD90D5-6BBB-175A-4E6B-1BD618247186}"/>
+              </a:ext>
+            </a:extLst>
+          </p:cNvPr>
+          <p:cNvPicPr>
+            <a:picLocks noChangeAspect="1"/>
+          </p:cNvPicPr>
+          <p:nvPr/>
+        </p:nvPicPr>
+        <p:blipFill>
+          <a:blip r:embed="rId2">
+            <a:extLst>
+              <a:ext uri="{28A0092B-C50C-407E-A947-70E740481C1C}">
+                <a14:useLocalDpi xmlns:a14="http://schemas.microsoft.com/office/drawing/2010/main" val="0"/>
+              </a:ext>
+            </a:extLst>
+          </a:blip>
+          <a:stretch>
+            <a:fillRect/>
+          </a:stretch>
+        </p:blipFill>
+        <p:spPr>
+          <a:xfrm>
+            <a:off x="1613573" y="59230"/>
+            <a:ext cx="3924978" cy="3210648"/>
+          </a:xfrm>
+          <a:prstGeom prst="rect">
+            <a:avLst/>
+          </a:prstGeom>
+        </p:spPr>
+      </p:pic>
+      <p:pic>
+        <p:nvPicPr>
+          <p:cNvPr id="5" name="图片 4" descr="图表, 条形图&#10;&#10;AI 生成的内容可能不正确。">
+            <a:extLst>
+              <a:ext uri="{FF2B5EF4-FFF2-40B4-BE49-F238E27FC236}">
+                <a16:creationId xmlns:a16="http://schemas.microsoft.com/office/drawing/2014/main" id="{33944433-05EC-4E5C-2432-96D536C1AC06}"/>
+              </a:ext>
+            </a:extLst>
+          </p:cNvPr>
+          <p:cNvPicPr>
+            <a:picLocks noChangeAspect="1"/>
+          </p:cNvPicPr>
+          <p:nvPr/>
+        </p:nvPicPr>
+        <p:blipFill>
+          <a:blip r:embed="rId3">
+            <a:extLst>
+              <a:ext uri="{28A0092B-C50C-407E-A947-70E740481C1C}">
+                <a14:useLocalDpi xmlns:a14="http://schemas.microsoft.com/office/drawing/2010/main" val="0"/>
+              </a:ext>
+            </a:extLst>
+          </a:blip>
+          <a:stretch>
+            <a:fillRect/>
+          </a:stretch>
+        </p:blipFill>
+        <p:spPr>
+          <a:xfrm>
+            <a:off x="6653451" y="59230"/>
+            <a:ext cx="3924978" cy="3210648"/>
+          </a:xfrm>
+          <a:prstGeom prst="rect">
+            <a:avLst/>
+          </a:prstGeom>
+        </p:spPr>
+      </p:pic>
+      <p:pic>
+        <p:nvPicPr>
+          <p:cNvPr id="7" name="图片 6" descr="图表, 条形图&#10;&#10;AI 生成的内容可能不正确。">
+            <a:extLst>
+              <a:ext uri="{FF2B5EF4-FFF2-40B4-BE49-F238E27FC236}">
+                <a16:creationId xmlns:a16="http://schemas.microsoft.com/office/drawing/2014/main" id="{8C50FD57-46EA-4B78-D86C-7E8E4FBD7136}"/>
+              </a:ext>
+            </a:extLst>
+          </p:cNvPr>
+          <p:cNvPicPr>
+            <a:picLocks noChangeAspect="1"/>
+          </p:cNvPicPr>
+          <p:nvPr/>
+        </p:nvPicPr>
+        <p:blipFill>
+          <a:blip r:embed="rId4">
+            <a:extLst>
+              <a:ext uri="{28A0092B-C50C-407E-A947-70E740481C1C}">
+                <a14:useLocalDpi xmlns:a14="http://schemas.microsoft.com/office/drawing/2010/main" val="0"/>
+              </a:ext>
+            </a:extLst>
+          </a:blip>
+          <a:stretch>
+            <a:fillRect/>
+          </a:stretch>
+        </p:blipFill>
+        <p:spPr>
+          <a:xfrm>
+            <a:off x="1613573" y="3429000"/>
+            <a:ext cx="3924978" cy="3210648"/>
+          </a:xfrm>
+          <a:prstGeom prst="rect">
+            <a:avLst/>
+          </a:prstGeom>
+        </p:spPr>
+      </p:pic>
+      <p:graphicFrame>
+        <p:nvGraphicFramePr>
+          <p:cNvPr id="12" name="表格 11">
+            <a:extLst>
+              <a:ext uri="{FF2B5EF4-FFF2-40B4-BE49-F238E27FC236}">
+                <a16:creationId xmlns:a16="http://schemas.microsoft.com/office/drawing/2014/main" id="{DCC2F5A7-2FAD-0E56-694F-3D8F18AB4417}"/>
+              </a:ext>
+            </a:extLst>
+          </p:cNvPr>
+          <p:cNvGraphicFramePr>
+            <a:graphicFrameLocks noGrp="1"/>
+          </p:cNvGraphicFramePr>
+          <p:nvPr>
+            <p:extLst>
+              <p:ext uri="{D42A27DB-BD31-4B8C-83A1-F6EECF244321}">
+                <p14:modId xmlns:p14="http://schemas.microsoft.com/office/powerpoint/2010/main" val="3729296982"/>
+              </p:ext>
+            </p:extLst>
+          </p:nvPr>
+        </p:nvGraphicFramePr>
+        <p:xfrm>
+          <a:off x="6096000" y="3429000"/>
+          <a:ext cx="6096000" cy="1341120"/>
+        </p:xfrm>
+        <a:graphic>
+          <a:graphicData uri="http://schemas.openxmlformats.org/drawingml/2006/table">
+            <a:tbl>
+              <a:tblPr firstRow="1" bandRow="1">
+                <a:tableStyleId>{5C22544A-7EE6-4342-B048-85BDC9FD1C3A}</a:tableStyleId>
+              </a:tblPr>
+              <a:tblGrid>
+                <a:gridCol w="1219200">
+                  <a:extLst>
+                    <a:ext uri="{9D8B030D-6E8A-4147-A177-3AD203B41FA5}">
+                      <a16:colId xmlns:a16="http://schemas.microsoft.com/office/drawing/2014/main" val="4101249701"/>
+                    </a:ext>
+                  </a:extLst>
+                </a:gridCol>
+                <a:gridCol w="1219200">
+                  <a:extLst>
+                    <a:ext uri="{9D8B030D-6E8A-4147-A177-3AD203B41FA5}">
+                      <a16:colId xmlns:a16="http://schemas.microsoft.com/office/drawing/2014/main" val="64436008"/>
+                    </a:ext>
+                  </a:extLst>
+                </a:gridCol>
+                <a:gridCol w="1219200">
+                  <a:extLst>
+                    <a:ext uri="{9D8B030D-6E8A-4147-A177-3AD203B41FA5}">
+                      <a16:colId xmlns:a16="http://schemas.microsoft.com/office/drawing/2014/main" val="2870068380"/>
+                    </a:ext>
+                  </a:extLst>
+                </a:gridCol>
+                <a:gridCol w="1219200">
+                  <a:extLst>
+                    <a:ext uri="{9D8B030D-6E8A-4147-A177-3AD203B41FA5}">
+                      <a16:colId xmlns:a16="http://schemas.microsoft.com/office/drawing/2014/main" val="2903000029"/>
+                    </a:ext>
+                  </a:extLst>
+                </a:gridCol>
+                <a:gridCol w="1219200">
+                  <a:extLst>
+                    <a:ext uri="{9D8B030D-6E8A-4147-A177-3AD203B41FA5}">
+                      <a16:colId xmlns:a16="http://schemas.microsoft.com/office/drawing/2014/main" val="3141391406"/>
+                    </a:ext>
+                  </a:extLst>
+                </a:gridCol>
+              </a:tblGrid>
+              <a:tr h="249025">
+                <a:tc>
+                  <a:txBody>
+                    <a:bodyPr/>
+                    <a:lstStyle/>
+                    <a:p>
+                      <a:r>
+                        <a:rPr lang="en-US" altLang="zh-CN" sz="1400" dirty="0">
+                          <a:latin typeface="Arial" panose="020B0604020202020204" pitchFamily="34" charset="0"/>
+                          <a:cs typeface="Arial" panose="020B0604020202020204" pitchFamily="34" charset="0"/>
+                        </a:rPr>
+                        <a:t>Average Token Cost</a:t>
+                      </a:r>
+                      <a:endParaRPr lang="zh-CN" altLang="en-US" sz="1400" dirty="0">
+                        <a:latin typeface="Arial" panose="020B0604020202020204" pitchFamily="34" charset="0"/>
+                        <a:cs typeface="Arial" panose="020B0604020202020204" pitchFamily="34" charset="0"/>
+                      </a:endParaRPr>
+                    </a:p>
+                  </a:txBody>
+                  <a:tcPr/>
+                </a:tc>
+                <a:tc>
+                  <a:txBody>
+                    <a:bodyPr/>
+                    <a:lstStyle/>
+                    <a:p>
+                      <a:pPr marL="0" marR="0" lvl="0" indent="0" algn="l" defTabSz="914400" rtl="0" eaLnBrk="1" fontAlgn="auto" latinLnBrk="0" hangingPunct="1">
+                        <a:lnSpc>
+                          <a:spcPct val="100000"/>
+                        </a:lnSpc>
+                        <a:spcBef>
+                          <a:spcPts val="0"/>
+                        </a:spcBef>
+                        <a:spcAft>
+                          <a:spcPts val="0"/>
+                        </a:spcAft>
+                        <a:buClrTx/>
+                        <a:buSzTx/>
+                        <a:buFontTx/>
+                        <a:buNone/>
+                        <a:tabLst/>
+                        <a:defRPr/>
+                      </a:pPr>
+                      <a:r>
+                        <a:rPr lang="en-US" altLang="zh-CN" sz="1400" dirty="0">
+                          <a:latin typeface="Arial" panose="020B0604020202020204" pitchFamily="34" charset="0"/>
+                          <a:cs typeface="Arial" panose="020B0604020202020204" pitchFamily="34" charset="0"/>
+                        </a:rPr>
+                        <a:t>Chain-of-Thought (</a:t>
+                      </a:r>
+                      <a:r>
+                        <a:rPr lang="en-US" altLang="zh-CN" sz="1400" dirty="0" err="1">
+                          <a:latin typeface="Arial" panose="020B0604020202020204" pitchFamily="34" charset="0"/>
+                          <a:cs typeface="Arial" panose="020B0604020202020204" pitchFamily="34" charset="0"/>
+                        </a:rPr>
+                        <a:t>CoT</a:t>
+                      </a:r>
+                      <a:r>
+                        <a:rPr lang="en-US" altLang="zh-CN" sz="1400" dirty="0">
+                          <a:latin typeface="Arial" panose="020B0604020202020204" pitchFamily="34" charset="0"/>
+                          <a:cs typeface="Arial" panose="020B0604020202020204" pitchFamily="34" charset="0"/>
+                        </a:rPr>
+                        <a:t>)</a:t>
+                      </a:r>
+                      <a:endParaRPr lang="zh-CN" altLang="en-US" sz="1400" dirty="0">
+                        <a:latin typeface="Arial" panose="020B0604020202020204" pitchFamily="34" charset="0"/>
+                        <a:cs typeface="Arial" panose="020B0604020202020204" pitchFamily="34" charset="0"/>
+                      </a:endParaRPr>
+                    </a:p>
+                  </a:txBody>
+                  <a:tcPr/>
+                </a:tc>
+                <a:tc>
+                  <a:txBody>
+                    <a:bodyPr/>
+                    <a:lstStyle/>
+                    <a:p>
+                      <a:pPr marL="0" marR="0" lvl="0" indent="0" algn="l" defTabSz="914400" rtl="0" eaLnBrk="1" fontAlgn="auto" latinLnBrk="0" hangingPunct="1">
+                        <a:lnSpc>
+                          <a:spcPct val="100000"/>
+                        </a:lnSpc>
+                        <a:spcBef>
+                          <a:spcPts val="0"/>
+                        </a:spcBef>
+                        <a:spcAft>
+                          <a:spcPts val="0"/>
+                        </a:spcAft>
+                        <a:buClrTx/>
+                        <a:buSzTx/>
+                        <a:buFontTx/>
+                        <a:buNone/>
+                        <a:tabLst/>
+                        <a:defRPr/>
+                      </a:pPr>
+                      <a:r>
+                        <a:rPr lang="en-US" altLang="zh-CN" sz="1400" dirty="0">
+                          <a:latin typeface="Arial" panose="020B0604020202020204" pitchFamily="34" charset="0"/>
+                          <a:cs typeface="Arial" panose="020B0604020202020204" pitchFamily="34" charset="0"/>
+                        </a:rPr>
+                        <a:t>Chain-of-Verification (</a:t>
+                      </a:r>
+                      <a:r>
+                        <a:rPr lang="en-US" altLang="zh-CN" sz="1400" dirty="0" err="1">
+                          <a:latin typeface="Arial" panose="020B0604020202020204" pitchFamily="34" charset="0"/>
+                          <a:cs typeface="Arial" panose="020B0604020202020204" pitchFamily="34" charset="0"/>
+                        </a:rPr>
+                        <a:t>CoVe</a:t>
+                      </a:r>
+                      <a:r>
+                        <a:rPr lang="en-US" altLang="zh-CN" sz="1400" dirty="0">
+                          <a:latin typeface="Arial" panose="020B0604020202020204" pitchFamily="34" charset="0"/>
+                          <a:cs typeface="Arial" panose="020B0604020202020204" pitchFamily="34" charset="0"/>
+                        </a:rPr>
+                        <a:t>)</a:t>
+                      </a:r>
+                      <a:endParaRPr lang="zh-CN" altLang="en-US" sz="1400" dirty="0">
+                        <a:latin typeface="Arial" panose="020B0604020202020204" pitchFamily="34" charset="0"/>
+                        <a:cs typeface="Arial" panose="020B0604020202020204" pitchFamily="34" charset="0"/>
+                      </a:endParaRPr>
+                    </a:p>
+                  </a:txBody>
+                  <a:tcPr/>
+                </a:tc>
+                <a:tc>
+                  <a:txBody>
+                    <a:bodyPr/>
+                    <a:lstStyle/>
+                    <a:p>
+                      <a:pPr marL="0" marR="0" lvl="0" indent="0" algn="l" defTabSz="914400" rtl="0" eaLnBrk="1" fontAlgn="auto" latinLnBrk="0" hangingPunct="1">
+                        <a:lnSpc>
+                          <a:spcPct val="100000"/>
+                        </a:lnSpc>
+                        <a:spcBef>
+                          <a:spcPts val="0"/>
+                        </a:spcBef>
+                        <a:spcAft>
+                          <a:spcPts val="0"/>
+                        </a:spcAft>
+                        <a:buClrTx/>
+                        <a:buSzTx/>
+                        <a:buFontTx/>
+                        <a:buNone/>
+                        <a:tabLst/>
+                        <a:defRPr/>
+                      </a:pPr>
+                      <a:r>
+                        <a:rPr lang="en-US" altLang="zh-CN" sz="1400" dirty="0">
+                          <a:latin typeface="Arial" panose="020B0604020202020204" pitchFamily="34" charset="0"/>
+                          <a:cs typeface="Arial" panose="020B0604020202020204" pitchFamily="34" charset="0"/>
+                        </a:rPr>
+                        <a:t>our approach</a:t>
+                      </a:r>
+                      <a:endParaRPr lang="zh-CN" altLang="en-US" sz="1400" dirty="0">
+                        <a:latin typeface="Arial" panose="020B0604020202020204" pitchFamily="34" charset="0"/>
+                        <a:cs typeface="Arial" panose="020B0604020202020204" pitchFamily="34" charset="0"/>
+                      </a:endParaRPr>
+                    </a:p>
+                  </a:txBody>
+                  <a:tcPr/>
+                </a:tc>
+                <a:tc>
+                  <a:txBody>
+                    <a:bodyPr/>
+                    <a:lstStyle/>
+                    <a:p>
+                      <a:pPr marL="0" marR="0" lvl="0" indent="0" algn="l" defTabSz="914400" rtl="0" eaLnBrk="1" fontAlgn="auto" latinLnBrk="0" hangingPunct="1">
+                        <a:lnSpc>
+                          <a:spcPct val="100000"/>
+                        </a:lnSpc>
+                        <a:spcBef>
+                          <a:spcPts val="0"/>
+                        </a:spcBef>
+                        <a:spcAft>
+                          <a:spcPts val="0"/>
+                        </a:spcAft>
+                        <a:buClrTx/>
+                        <a:buSzTx/>
+                        <a:buFontTx/>
+                        <a:buNone/>
+                        <a:tabLst/>
+                        <a:defRPr/>
+                      </a:pPr>
+                      <a:r>
+                        <a:rPr lang="en-US" altLang="zh-CN" sz="1400" dirty="0">
+                          <a:latin typeface="Arial" panose="020B0604020202020204" pitchFamily="34" charset="0"/>
+                          <a:cs typeface="Arial" panose="020B0604020202020204" pitchFamily="34" charset="0"/>
+                        </a:rPr>
+                        <a:t>our approach</a:t>
+                      </a:r>
+                      <a:r>
+                        <a:rPr lang="zh-CN" altLang="en-US" sz="1400" dirty="0">
+                          <a:latin typeface="Arial" panose="020B0604020202020204" pitchFamily="34" charset="0"/>
+                          <a:cs typeface="Arial" panose="020B0604020202020204" pitchFamily="34" charset="0"/>
+                        </a:rPr>
+                        <a:t> </a:t>
+                      </a:r>
+                      <a:r>
+                        <a:rPr lang="en-US" altLang="zh-CN" sz="1400" dirty="0">
+                          <a:latin typeface="Arial" panose="020B0604020202020204" pitchFamily="34" charset="0"/>
+                          <a:cs typeface="Arial" panose="020B0604020202020204" pitchFamily="34" charset="0"/>
+                        </a:rPr>
+                        <a:t>- mutations</a:t>
+                      </a:r>
+                      <a:endParaRPr lang="zh-CN" altLang="en-US" sz="1400" dirty="0">
+                        <a:latin typeface="Arial" panose="020B0604020202020204" pitchFamily="34" charset="0"/>
+                        <a:cs typeface="Arial" panose="020B0604020202020204" pitchFamily="34" charset="0"/>
+                      </a:endParaRPr>
+                    </a:p>
+                  </a:txBody>
+                  <a:tcPr/>
+                </a:tc>
+                <a:extLst>
+                  <a:ext uri="{0D108BD9-81ED-4DB2-BD59-A6C34878D82A}">
+                    <a16:rowId xmlns:a16="http://schemas.microsoft.com/office/drawing/2014/main" val="3466647714"/>
+                  </a:ext>
+                </a:extLst>
+              </a:tr>
+              <a:tr h="249025">
+                <a:tc>
+                  <a:txBody>
+                    <a:bodyPr/>
+                    <a:lstStyle/>
+                    <a:p>
+                      <a:pPr algn="ctr"/>
+                      <a:r>
+                        <a:rPr lang="en-US" altLang="zh-CN" sz="1400" dirty="0">
+                          <a:latin typeface="Arial" panose="020B0604020202020204" pitchFamily="34" charset="0"/>
+                          <a:cs typeface="Arial" panose="020B0604020202020204" pitchFamily="34" charset="0"/>
+                        </a:rPr>
+                        <a:t>gpt-4o</a:t>
+                      </a:r>
+                      <a:endParaRPr lang="zh-CN" altLang="en-US" sz="1400" dirty="0">
+                        <a:latin typeface="Arial" panose="020B0604020202020204" pitchFamily="34" charset="0"/>
+                        <a:cs typeface="Arial" panose="020B0604020202020204" pitchFamily="34" charset="0"/>
+                      </a:endParaRPr>
+                    </a:p>
+                  </a:txBody>
+                  <a:tcPr/>
+                </a:tc>
+                <a:tc>
+                  <a:txBody>
+                    <a:bodyPr/>
+                    <a:lstStyle/>
+                    <a:p>
+                      <a:pPr algn="ctr"/>
+                      <a:r>
+                        <a:rPr lang="en-US" altLang="zh-CN" sz="1400">
+                          <a:latin typeface="Arial" panose="020B0604020202020204" pitchFamily="34" charset="0"/>
+                          <a:cs typeface="Arial" panose="020B0604020202020204" pitchFamily="34" charset="0"/>
+                        </a:rPr>
+                        <a:t>97.97</a:t>
+                      </a:r>
+                      <a:endParaRPr lang="zh-CN" altLang="en-US" sz="1400" dirty="0">
+                        <a:latin typeface="Arial" panose="020B0604020202020204" pitchFamily="34" charset="0"/>
+                        <a:cs typeface="Arial" panose="020B0604020202020204" pitchFamily="34" charset="0"/>
+                      </a:endParaRPr>
+                    </a:p>
+                  </a:txBody>
+                  <a:tcPr/>
+                </a:tc>
+                <a:tc>
+                  <a:txBody>
+                    <a:bodyPr/>
+                    <a:lstStyle/>
+                    <a:p>
+                      <a:pPr algn="ctr"/>
+                      <a:r>
+                        <a:rPr lang="en-US" altLang="zh-CN" sz="1400">
+                          <a:latin typeface="Arial" panose="020B0604020202020204" pitchFamily="34" charset="0"/>
+                          <a:cs typeface="Arial" panose="020B0604020202020204" pitchFamily="34" charset="0"/>
+                        </a:rPr>
+                        <a:t>2073.16</a:t>
+                      </a:r>
+                      <a:endParaRPr lang="zh-CN" altLang="en-US" sz="1400">
+                        <a:latin typeface="Arial" panose="020B0604020202020204" pitchFamily="34" charset="0"/>
+                        <a:cs typeface="Arial" panose="020B0604020202020204" pitchFamily="34" charset="0"/>
+                      </a:endParaRPr>
+                    </a:p>
+                  </a:txBody>
+                  <a:tcPr/>
+                </a:tc>
+                <a:tc>
+                  <a:txBody>
+                    <a:bodyPr/>
+                    <a:lstStyle/>
+                    <a:p>
+                      <a:pPr algn="ctr"/>
+                      <a:r>
+                        <a:rPr lang="en-US" altLang="zh-CN" sz="1400" dirty="0">
+                          <a:latin typeface="Arial" panose="020B0604020202020204" pitchFamily="34" charset="0"/>
+                          <a:cs typeface="Arial" panose="020B0604020202020204" pitchFamily="34" charset="0"/>
+                        </a:rPr>
+                        <a:t>289.43</a:t>
+                      </a:r>
+                      <a:endParaRPr lang="zh-CN" altLang="en-US" sz="1400" dirty="0">
+                        <a:latin typeface="Arial" panose="020B0604020202020204" pitchFamily="34" charset="0"/>
+                        <a:cs typeface="Arial" panose="020B0604020202020204" pitchFamily="34" charset="0"/>
+                      </a:endParaRPr>
+                    </a:p>
+                  </a:txBody>
+                  <a:tcPr/>
+                </a:tc>
+                <a:tc>
+                  <a:txBody>
+                    <a:bodyPr/>
+                    <a:lstStyle/>
+                    <a:p>
+                      <a:pPr algn="ctr"/>
+                      <a:r>
+                        <a:rPr lang="en-US" altLang="zh-CN" sz="1400" dirty="0">
+                          <a:latin typeface="Arial" panose="020B0604020202020204" pitchFamily="34" charset="0"/>
+                          <a:cs typeface="Arial" panose="020B0604020202020204" pitchFamily="34" charset="0"/>
+                        </a:rPr>
+                        <a:t>1569</a:t>
+                      </a:r>
+                      <a:endParaRPr lang="zh-CN" altLang="en-US" sz="1400" dirty="0">
+                        <a:latin typeface="Arial" panose="020B0604020202020204" pitchFamily="34" charset="0"/>
+                        <a:cs typeface="Arial" panose="020B0604020202020204" pitchFamily="34" charset="0"/>
+                      </a:endParaRPr>
+                    </a:p>
+                  </a:txBody>
+                  <a:tcPr/>
+                </a:tc>
+                <a:extLst>
+                  <a:ext uri="{0D108BD9-81ED-4DB2-BD59-A6C34878D82A}">
+                    <a16:rowId xmlns:a16="http://schemas.microsoft.com/office/drawing/2014/main" val="971162633"/>
+                  </a:ext>
+                </a:extLst>
+              </a:tr>
+              <a:tr h="249025">
+                <a:tc>
+                  <a:txBody>
+                    <a:bodyPr/>
+                    <a:lstStyle/>
+                    <a:p>
+                      <a:pPr algn="ctr"/>
+                      <a:r>
+                        <a:rPr lang="en-US" altLang="zh-CN" sz="1400" dirty="0">
+                          <a:latin typeface="Arial" panose="020B0604020202020204" pitchFamily="34" charset="0"/>
+                          <a:cs typeface="Arial" panose="020B0604020202020204" pitchFamily="34" charset="0"/>
+                        </a:rPr>
+                        <a:t>gpt-5</a:t>
+                      </a:r>
+                      <a:endParaRPr lang="zh-CN" altLang="en-US" sz="1400" dirty="0">
+                        <a:latin typeface="Arial" panose="020B0604020202020204" pitchFamily="34" charset="0"/>
+                        <a:cs typeface="Arial" panose="020B0604020202020204" pitchFamily="34" charset="0"/>
+                      </a:endParaRPr>
+                    </a:p>
+                  </a:txBody>
+                  <a:tcPr/>
+                </a:tc>
+                <a:tc>
+                  <a:txBody>
+                    <a:bodyPr/>
+                    <a:lstStyle/>
+                    <a:p>
+                      <a:pPr algn="ctr"/>
+                      <a:r>
+                        <a:rPr lang="en-US" altLang="zh-CN" sz="1400" dirty="0">
+                          <a:latin typeface="Arial" panose="020B0604020202020204" pitchFamily="34" charset="0"/>
+                          <a:cs typeface="Arial" panose="020B0604020202020204" pitchFamily="34" charset="0"/>
+                        </a:rPr>
+                        <a:t>84.96</a:t>
+                      </a:r>
+                      <a:endParaRPr lang="zh-CN" altLang="en-US" sz="1400" dirty="0">
+                        <a:latin typeface="Arial" panose="020B0604020202020204" pitchFamily="34" charset="0"/>
+                        <a:cs typeface="Arial" panose="020B0604020202020204" pitchFamily="34" charset="0"/>
+                      </a:endParaRPr>
+                    </a:p>
+                  </a:txBody>
+                  <a:tcPr/>
+                </a:tc>
+                <a:tc>
+                  <a:txBody>
+                    <a:bodyPr/>
+                    <a:lstStyle/>
+                    <a:p>
+                      <a:pPr algn="ctr"/>
+                      <a:r>
+                        <a:rPr lang="en-US" altLang="zh-CN" sz="1400" dirty="0">
+                          <a:latin typeface="Arial" panose="020B0604020202020204" pitchFamily="34" charset="0"/>
+                          <a:cs typeface="Arial" panose="020B0604020202020204" pitchFamily="34" charset="0"/>
+                        </a:rPr>
+                        <a:t>5619.32</a:t>
+                      </a:r>
+                      <a:endParaRPr lang="zh-CN" altLang="en-US" sz="1400" dirty="0">
+                        <a:latin typeface="Arial" panose="020B0604020202020204" pitchFamily="34" charset="0"/>
+                        <a:cs typeface="Arial" panose="020B0604020202020204" pitchFamily="34" charset="0"/>
+                      </a:endParaRPr>
+                    </a:p>
+                  </a:txBody>
+                  <a:tcPr/>
+                </a:tc>
+                <a:tc>
+                  <a:txBody>
+                    <a:bodyPr/>
+                    <a:lstStyle/>
+                    <a:p>
+                      <a:pPr algn="ctr"/>
+                      <a:r>
+                        <a:rPr lang="en-US" altLang="zh-CN" sz="1400" dirty="0">
+                          <a:latin typeface="Arial" panose="020B0604020202020204" pitchFamily="34" charset="0"/>
+                          <a:cs typeface="Arial" panose="020B0604020202020204" pitchFamily="34" charset="0"/>
+                        </a:rPr>
+                        <a:t>305.13</a:t>
+                      </a:r>
+                      <a:endParaRPr lang="zh-CN" altLang="en-US" sz="1400" dirty="0">
+                        <a:latin typeface="Arial" panose="020B0604020202020204" pitchFamily="34" charset="0"/>
+                        <a:cs typeface="Arial" panose="020B0604020202020204" pitchFamily="34" charset="0"/>
+                      </a:endParaRPr>
+                    </a:p>
+                  </a:txBody>
+                  <a:tcPr/>
+                </a:tc>
+                <a:tc>
+                  <a:txBody>
+                    <a:bodyPr/>
+                    <a:lstStyle/>
+                    <a:p>
+                      <a:pPr algn="ctr"/>
+                      <a:r>
+                        <a:rPr lang="en-US" altLang="zh-CN" sz="1400" dirty="0">
+                          <a:latin typeface="Arial" panose="020B0604020202020204" pitchFamily="34" charset="0"/>
+                          <a:cs typeface="Arial" panose="020B0604020202020204" pitchFamily="34" charset="0"/>
+                        </a:rPr>
+                        <a:t>1271.36</a:t>
+                      </a:r>
+                      <a:endParaRPr lang="zh-CN" altLang="en-US" sz="1400" dirty="0">
+                        <a:latin typeface="Arial" panose="020B0604020202020204" pitchFamily="34" charset="0"/>
+                        <a:cs typeface="Arial" panose="020B0604020202020204" pitchFamily="34" charset="0"/>
+                      </a:endParaRPr>
+                    </a:p>
+                  </a:txBody>
+                  <a:tcPr/>
+                </a:tc>
+                <a:extLst>
+                  <a:ext uri="{0D108BD9-81ED-4DB2-BD59-A6C34878D82A}">
+                    <a16:rowId xmlns:a16="http://schemas.microsoft.com/office/drawing/2014/main" val="2166985772"/>
+                  </a:ext>
+                </a:extLst>
+              </a:tr>
+            </a:tbl>
+          </a:graphicData>
+        </a:graphic>
+      </p:graphicFrame>
+      <p:graphicFrame>
+        <p:nvGraphicFramePr>
+          <p:cNvPr id="13" name="表格 12">
+            <a:extLst>
+              <a:ext uri="{FF2B5EF4-FFF2-40B4-BE49-F238E27FC236}">
+                <a16:creationId xmlns:a16="http://schemas.microsoft.com/office/drawing/2014/main" id="{469CD08E-F3B2-84D2-93AA-148551C0EF3C}"/>
+              </a:ext>
+            </a:extLst>
+          </p:cNvPr>
+          <p:cNvGraphicFramePr>
+            <a:graphicFrameLocks noGrp="1"/>
+          </p:cNvGraphicFramePr>
+          <p:nvPr>
+            <p:extLst>
+              <p:ext uri="{D42A27DB-BD31-4B8C-83A1-F6EECF244321}">
+                <p14:modId xmlns:p14="http://schemas.microsoft.com/office/powerpoint/2010/main" val="3305237706"/>
+              </p:ext>
+            </p:extLst>
+          </p:nvPr>
+        </p:nvGraphicFramePr>
+        <p:xfrm>
+          <a:off x="6096000" y="4929242"/>
+          <a:ext cx="6096000" cy="1341120"/>
+        </p:xfrm>
+        <a:graphic>
+          <a:graphicData uri="http://schemas.openxmlformats.org/drawingml/2006/table">
+            <a:tbl>
+              <a:tblPr firstRow="1" bandRow="1">
+                <a:tableStyleId>{5C22544A-7EE6-4342-B048-85BDC9FD1C3A}</a:tableStyleId>
+              </a:tblPr>
+              <a:tblGrid>
+                <a:gridCol w="1219200">
+                  <a:extLst>
+                    <a:ext uri="{9D8B030D-6E8A-4147-A177-3AD203B41FA5}">
+                      <a16:colId xmlns:a16="http://schemas.microsoft.com/office/drawing/2014/main" val="4101249701"/>
+                    </a:ext>
+                  </a:extLst>
+                </a:gridCol>
+                <a:gridCol w="1219200">
+                  <a:extLst>
+                    <a:ext uri="{9D8B030D-6E8A-4147-A177-3AD203B41FA5}">
+                      <a16:colId xmlns:a16="http://schemas.microsoft.com/office/drawing/2014/main" val="64436008"/>
+                    </a:ext>
+                  </a:extLst>
+                </a:gridCol>
+                <a:gridCol w="1219200">
+                  <a:extLst>
+                    <a:ext uri="{9D8B030D-6E8A-4147-A177-3AD203B41FA5}">
+                      <a16:colId xmlns:a16="http://schemas.microsoft.com/office/drawing/2014/main" val="2870068380"/>
+                    </a:ext>
+                  </a:extLst>
+                </a:gridCol>
+                <a:gridCol w="1219200">
+                  <a:extLst>
+                    <a:ext uri="{9D8B030D-6E8A-4147-A177-3AD203B41FA5}">
+                      <a16:colId xmlns:a16="http://schemas.microsoft.com/office/drawing/2014/main" val="2903000029"/>
+                    </a:ext>
+                  </a:extLst>
+                </a:gridCol>
+                <a:gridCol w="1219200">
+                  <a:extLst>
+                    <a:ext uri="{9D8B030D-6E8A-4147-A177-3AD203B41FA5}">
+                      <a16:colId xmlns:a16="http://schemas.microsoft.com/office/drawing/2014/main" val="3141391406"/>
+                    </a:ext>
+                  </a:extLst>
+                </a:gridCol>
+              </a:tblGrid>
+              <a:tr h="249025">
+                <a:tc>
+                  <a:txBody>
+                    <a:bodyPr/>
+                    <a:lstStyle/>
+                    <a:p>
+                      <a:pPr marL="0" marR="0" lvl="0" indent="0" algn="l" defTabSz="914400" rtl="0" eaLnBrk="1" fontAlgn="auto" latinLnBrk="0" hangingPunct="1">
+                        <a:lnSpc>
+                          <a:spcPct val="100000"/>
+                        </a:lnSpc>
+                        <a:spcBef>
+                          <a:spcPts val="0"/>
+                        </a:spcBef>
+                        <a:spcAft>
+                          <a:spcPts val="0"/>
+                        </a:spcAft>
+                        <a:buClrTx/>
+                        <a:buSzTx/>
+                        <a:buFontTx/>
+                        <a:buNone/>
+                        <a:tabLst/>
+                        <a:defRPr/>
+                      </a:pPr>
+                      <a:r>
+                        <a:rPr lang="en-US" altLang="zh-CN" sz="1400" dirty="0">
+                          <a:latin typeface="Arial" panose="020B0604020202020204" pitchFamily="34" charset="0"/>
+                          <a:cs typeface="Arial" panose="020B0604020202020204" pitchFamily="34" charset="0"/>
+                        </a:rPr>
+                        <a:t>Average Time Cost</a:t>
+                      </a:r>
+                      <a:endParaRPr lang="zh-CN" altLang="en-US" sz="1400" dirty="0">
+                        <a:latin typeface="Arial" panose="020B0604020202020204" pitchFamily="34" charset="0"/>
+                        <a:cs typeface="Arial" panose="020B0604020202020204" pitchFamily="34" charset="0"/>
+                      </a:endParaRPr>
+                    </a:p>
+                  </a:txBody>
+                  <a:tcPr/>
+                </a:tc>
+                <a:tc>
+                  <a:txBody>
+                    <a:bodyPr/>
+                    <a:lstStyle/>
+                    <a:p>
+                      <a:pPr marL="0" marR="0" lvl="0" indent="0" algn="l" defTabSz="914400" rtl="0" eaLnBrk="1" fontAlgn="auto" latinLnBrk="0" hangingPunct="1">
+                        <a:lnSpc>
+                          <a:spcPct val="100000"/>
+                        </a:lnSpc>
+                        <a:spcBef>
+                          <a:spcPts val="0"/>
+                        </a:spcBef>
+                        <a:spcAft>
+                          <a:spcPts val="0"/>
+                        </a:spcAft>
+                        <a:buClrTx/>
+                        <a:buSzTx/>
+                        <a:buFontTx/>
+                        <a:buNone/>
+                        <a:tabLst/>
+                        <a:defRPr/>
+                      </a:pPr>
+                      <a:r>
+                        <a:rPr lang="en-US" altLang="zh-CN" sz="1400" dirty="0">
+                          <a:latin typeface="Arial" panose="020B0604020202020204" pitchFamily="34" charset="0"/>
+                          <a:cs typeface="Arial" panose="020B0604020202020204" pitchFamily="34" charset="0"/>
+                        </a:rPr>
+                        <a:t>Chain-of-Thought (</a:t>
+                      </a:r>
+                      <a:r>
+                        <a:rPr lang="en-US" altLang="zh-CN" sz="1400" dirty="0" err="1">
+                          <a:latin typeface="Arial" panose="020B0604020202020204" pitchFamily="34" charset="0"/>
+                          <a:cs typeface="Arial" panose="020B0604020202020204" pitchFamily="34" charset="0"/>
+                        </a:rPr>
+                        <a:t>CoT</a:t>
+                      </a:r>
+                      <a:r>
+                        <a:rPr lang="en-US" altLang="zh-CN" sz="1400" dirty="0">
+                          <a:latin typeface="Arial" panose="020B0604020202020204" pitchFamily="34" charset="0"/>
+                          <a:cs typeface="Arial" panose="020B0604020202020204" pitchFamily="34" charset="0"/>
+                        </a:rPr>
+                        <a:t>)</a:t>
+                      </a:r>
+                      <a:endParaRPr lang="zh-CN" altLang="en-US" sz="1400" dirty="0">
+                        <a:latin typeface="Arial" panose="020B0604020202020204" pitchFamily="34" charset="0"/>
+                        <a:cs typeface="Arial" panose="020B0604020202020204" pitchFamily="34" charset="0"/>
+                      </a:endParaRPr>
+                    </a:p>
+                  </a:txBody>
+                  <a:tcPr/>
+                </a:tc>
+                <a:tc>
+                  <a:txBody>
+                    <a:bodyPr/>
+                    <a:lstStyle/>
+                    <a:p>
+                      <a:pPr marL="0" marR="0" lvl="0" indent="0" algn="l" defTabSz="914400" rtl="0" eaLnBrk="1" fontAlgn="auto" latinLnBrk="0" hangingPunct="1">
+                        <a:lnSpc>
+                          <a:spcPct val="100000"/>
+                        </a:lnSpc>
+                        <a:spcBef>
+                          <a:spcPts val="0"/>
+                        </a:spcBef>
+                        <a:spcAft>
+                          <a:spcPts val="0"/>
+                        </a:spcAft>
+                        <a:buClrTx/>
+                        <a:buSzTx/>
+                        <a:buFontTx/>
+                        <a:buNone/>
+                        <a:tabLst/>
+                        <a:defRPr/>
+                      </a:pPr>
+                      <a:r>
+                        <a:rPr lang="en-US" altLang="zh-CN" sz="1400" dirty="0">
+                          <a:latin typeface="Arial" panose="020B0604020202020204" pitchFamily="34" charset="0"/>
+                          <a:cs typeface="Arial" panose="020B0604020202020204" pitchFamily="34" charset="0"/>
+                        </a:rPr>
+                        <a:t>Chain-of-Verification (</a:t>
+                      </a:r>
+                      <a:r>
+                        <a:rPr lang="en-US" altLang="zh-CN" sz="1400" dirty="0" err="1">
+                          <a:latin typeface="Arial" panose="020B0604020202020204" pitchFamily="34" charset="0"/>
+                          <a:cs typeface="Arial" panose="020B0604020202020204" pitchFamily="34" charset="0"/>
+                        </a:rPr>
+                        <a:t>CoVe</a:t>
+                      </a:r>
+                      <a:r>
+                        <a:rPr lang="en-US" altLang="zh-CN" sz="1400" dirty="0">
+                          <a:latin typeface="Arial" panose="020B0604020202020204" pitchFamily="34" charset="0"/>
+                          <a:cs typeface="Arial" panose="020B0604020202020204" pitchFamily="34" charset="0"/>
+                        </a:rPr>
+                        <a:t>)</a:t>
+                      </a:r>
+                      <a:endParaRPr lang="zh-CN" altLang="en-US" sz="1400" dirty="0">
+                        <a:latin typeface="Arial" panose="020B0604020202020204" pitchFamily="34" charset="0"/>
+                        <a:cs typeface="Arial" panose="020B0604020202020204" pitchFamily="34" charset="0"/>
+                      </a:endParaRPr>
+                    </a:p>
+                  </a:txBody>
+                  <a:tcPr/>
+                </a:tc>
+                <a:tc>
+                  <a:txBody>
+                    <a:bodyPr/>
+                    <a:lstStyle/>
+                    <a:p>
+                      <a:pPr marL="0" marR="0" lvl="0" indent="0" algn="l" defTabSz="914400" rtl="0" eaLnBrk="1" fontAlgn="auto" latinLnBrk="0" hangingPunct="1">
+                        <a:lnSpc>
+                          <a:spcPct val="100000"/>
+                        </a:lnSpc>
+                        <a:spcBef>
+                          <a:spcPts val="0"/>
+                        </a:spcBef>
+                        <a:spcAft>
+                          <a:spcPts val="0"/>
+                        </a:spcAft>
+                        <a:buClrTx/>
+                        <a:buSzTx/>
+                        <a:buFontTx/>
+                        <a:buNone/>
+                        <a:tabLst/>
+                        <a:defRPr/>
+                      </a:pPr>
+                      <a:r>
+                        <a:rPr lang="en-US" altLang="zh-CN" sz="1400" dirty="0">
+                          <a:latin typeface="Arial" panose="020B0604020202020204" pitchFamily="34" charset="0"/>
+                          <a:cs typeface="Arial" panose="020B0604020202020204" pitchFamily="34" charset="0"/>
+                        </a:rPr>
+                        <a:t>our approach</a:t>
+                      </a:r>
+                      <a:endParaRPr lang="zh-CN" altLang="en-US" sz="1400" dirty="0">
+                        <a:latin typeface="Arial" panose="020B0604020202020204" pitchFamily="34" charset="0"/>
+                        <a:cs typeface="Arial" panose="020B0604020202020204" pitchFamily="34" charset="0"/>
+                      </a:endParaRPr>
+                    </a:p>
+                  </a:txBody>
+                  <a:tcPr/>
+                </a:tc>
+                <a:tc>
+                  <a:txBody>
+                    <a:bodyPr/>
+                    <a:lstStyle/>
+                    <a:p>
+                      <a:pPr marL="0" marR="0" lvl="0" indent="0" algn="l" defTabSz="914400" rtl="0" eaLnBrk="1" fontAlgn="auto" latinLnBrk="0" hangingPunct="1">
+                        <a:lnSpc>
+                          <a:spcPct val="100000"/>
+                        </a:lnSpc>
+                        <a:spcBef>
+                          <a:spcPts val="0"/>
+                        </a:spcBef>
+                        <a:spcAft>
+                          <a:spcPts val="0"/>
+                        </a:spcAft>
+                        <a:buClrTx/>
+                        <a:buSzTx/>
+                        <a:buFontTx/>
+                        <a:buNone/>
+                        <a:tabLst/>
+                        <a:defRPr/>
+                      </a:pPr>
+                      <a:r>
+                        <a:rPr lang="en-US" altLang="zh-CN" sz="1400" dirty="0">
+                          <a:latin typeface="Arial" panose="020B0604020202020204" pitchFamily="34" charset="0"/>
+                          <a:cs typeface="Arial" panose="020B0604020202020204" pitchFamily="34" charset="0"/>
+                        </a:rPr>
+                        <a:t>our approach</a:t>
+                      </a:r>
+                      <a:r>
+                        <a:rPr lang="zh-CN" altLang="en-US" sz="1400" dirty="0">
+                          <a:latin typeface="Arial" panose="020B0604020202020204" pitchFamily="34" charset="0"/>
+                          <a:cs typeface="Arial" panose="020B0604020202020204" pitchFamily="34" charset="0"/>
+                        </a:rPr>
+                        <a:t> </a:t>
+                      </a:r>
+                      <a:r>
+                        <a:rPr lang="en-US" altLang="zh-CN" sz="1400" dirty="0">
+                          <a:latin typeface="Arial" panose="020B0604020202020204" pitchFamily="34" charset="0"/>
+                          <a:cs typeface="Arial" panose="020B0604020202020204" pitchFamily="34" charset="0"/>
+                        </a:rPr>
+                        <a:t>- mutations</a:t>
+                      </a:r>
+                      <a:endParaRPr lang="zh-CN" altLang="en-US" sz="1400" dirty="0">
+                        <a:latin typeface="Arial" panose="020B0604020202020204" pitchFamily="34" charset="0"/>
+                        <a:cs typeface="Arial" panose="020B0604020202020204" pitchFamily="34" charset="0"/>
+                      </a:endParaRPr>
+                    </a:p>
+                  </a:txBody>
+                  <a:tcPr/>
+                </a:tc>
+                <a:extLst>
+                  <a:ext uri="{0D108BD9-81ED-4DB2-BD59-A6C34878D82A}">
+                    <a16:rowId xmlns:a16="http://schemas.microsoft.com/office/drawing/2014/main" val="3466647714"/>
+                  </a:ext>
+                </a:extLst>
+              </a:tr>
+              <a:tr h="249025">
+                <a:tc>
+                  <a:txBody>
+                    <a:bodyPr/>
+                    <a:lstStyle/>
+                    <a:p>
+                      <a:pPr algn="ctr"/>
+                      <a:r>
+                        <a:rPr lang="en-US" altLang="zh-CN" sz="1400" dirty="0">
+                          <a:latin typeface="Arial" panose="020B0604020202020204" pitchFamily="34" charset="0"/>
+                          <a:cs typeface="Arial" panose="020B0604020202020204" pitchFamily="34" charset="0"/>
+                        </a:rPr>
+                        <a:t>gpt-4o</a:t>
+                      </a:r>
+                      <a:endParaRPr lang="zh-CN" altLang="en-US" sz="1400" dirty="0">
+                        <a:latin typeface="Arial" panose="020B0604020202020204" pitchFamily="34" charset="0"/>
+                        <a:cs typeface="Arial" panose="020B0604020202020204" pitchFamily="34" charset="0"/>
+                      </a:endParaRPr>
+                    </a:p>
+                  </a:txBody>
+                  <a:tcPr/>
+                </a:tc>
+                <a:tc>
+                  <a:txBody>
+                    <a:bodyPr/>
+                    <a:lstStyle/>
+                    <a:p>
+                      <a:pPr algn="ctr"/>
+                      <a:r>
+                        <a:rPr lang="en-US" altLang="zh-CN" sz="1400" dirty="0">
+                          <a:latin typeface="Arial" panose="020B0604020202020204" pitchFamily="34" charset="0"/>
+                          <a:cs typeface="Arial" panose="020B0604020202020204" pitchFamily="34" charset="0"/>
+                        </a:rPr>
+                        <a:t>1.58</a:t>
+                      </a:r>
+                    </a:p>
+                  </a:txBody>
+                  <a:tcPr/>
+                </a:tc>
+                <a:tc>
+                  <a:txBody>
+                    <a:bodyPr/>
+                    <a:lstStyle/>
+                    <a:p>
+                      <a:pPr algn="ctr"/>
+                      <a:r>
+                        <a:rPr lang="en-US" altLang="zh-CN" sz="1400" dirty="0">
+                          <a:latin typeface="Arial" panose="020B0604020202020204" pitchFamily="34" charset="0"/>
+                          <a:cs typeface="Arial" panose="020B0604020202020204" pitchFamily="34" charset="0"/>
+                        </a:rPr>
+                        <a:t>17.43</a:t>
+                      </a:r>
+                      <a:endParaRPr lang="zh-CN" altLang="en-US" sz="1400" dirty="0">
+                        <a:latin typeface="Arial" panose="020B0604020202020204" pitchFamily="34" charset="0"/>
+                        <a:cs typeface="Arial" panose="020B0604020202020204" pitchFamily="34" charset="0"/>
+                      </a:endParaRPr>
+                    </a:p>
+                  </a:txBody>
+                  <a:tcPr/>
+                </a:tc>
+                <a:tc>
+                  <a:txBody>
+                    <a:bodyPr/>
+                    <a:lstStyle/>
+                    <a:p>
+                      <a:pPr algn="ctr"/>
+                      <a:r>
+                        <a:rPr lang="en-US" altLang="zh-CN" sz="1400" dirty="0">
+                          <a:latin typeface="Arial" panose="020B0604020202020204" pitchFamily="34" charset="0"/>
+                          <a:cs typeface="Arial" panose="020B0604020202020204" pitchFamily="34" charset="0"/>
+                        </a:rPr>
+                        <a:t>1.43</a:t>
+                      </a:r>
+                      <a:endParaRPr lang="zh-CN" altLang="en-US" sz="1400" dirty="0">
+                        <a:latin typeface="Arial" panose="020B0604020202020204" pitchFamily="34" charset="0"/>
+                        <a:cs typeface="Arial" panose="020B0604020202020204" pitchFamily="34" charset="0"/>
+                      </a:endParaRPr>
+                    </a:p>
+                  </a:txBody>
+                  <a:tcPr/>
+                </a:tc>
+                <a:tc>
+                  <a:txBody>
+                    <a:bodyPr/>
+                    <a:lstStyle/>
+                    <a:p>
+                      <a:pPr algn="ctr"/>
+                      <a:r>
+                        <a:rPr lang="en-US" altLang="zh-CN" sz="1400" dirty="0">
+                          <a:latin typeface="Arial" panose="020B0604020202020204" pitchFamily="34" charset="0"/>
+                          <a:cs typeface="Arial" panose="020B0604020202020204" pitchFamily="34" charset="0"/>
+                        </a:rPr>
+                        <a:t>17.09</a:t>
+                      </a:r>
+                      <a:endParaRPr lang="zh-CN" altLang="en-US" sz="1400" dirty="0">
+                        <a:latin typeface="Arial" panose="020B0604020202020204" pitchFamily="34" charset="0"/>
+                        <a:cs typeface="Arial" panose="020B0604020202020204" pitchFamily="34" charset="0"/>
+                      </a:endParaRPr>
+                    </a:p>
+                  </a:txBody>
+                  <a:tcPr/>
+                </a:tc>
+                <a:extLst>
+                  <a:ext uri="{0D108BD9-81ED-4DB2-BD59-A6C34878D82A}">
+                    <a16:rowId xmlns:a16="http://schemas.microsoft.com/office/drawing/2014/main" val="971162633"/>
+                  </a:ext>
+                </a:extLst>
+              </a:tr>
+              <a:tr h="249025">
+                <a:tc>
+                  <a:txBody>
+                    <a:bodyPr/>
+                    <a:lstStyle/>
+                    <a:p>
+                      <a:pPr algn="ctr"/>
+                      <a:r>
+                        <a:rPr lang="en-US" altLang="zh-CN" sz="1400" dirty="0">
+                          <a:latin typeface="Arial" panose="020B0604020202020204" pitchFamily="34" charset="0"/>
+                          <a:cs typeface="Arial" panose="020B0604020202020204" pitchFamily="34" charset="0"/>
+                        </a:rPr>
+                        <a:t>gpt-5</a:t>
+                      </a:r>
+                      <a:endParaRPr lang="zh-CN" altLang="en-US" sz="1400" dirty="0">
+                        <a:latin typeface="Arial" panose="020B0604020202020204" pitchFamily="34" charset="0"/>
+                        <a:cs typeface="Arial" panose="020B0604020202020204" pitchFamily="34" charset="0"/>
+                      </a:endParaRPr>
+                    </a:p>
+                  </a:txBody>
+                  <a:tcPr/>
+                </a:tc>
+                <a:tc>
+                  <a:txBody>
+                    <a:bodyPr/>
+                    <a:lstStyle/>
+                    <a:p>
+                      <a:pPr marL="0" marR="0" lvl="0" indent="0" algn="ctr" defTabSz="914400" rtl="0" eaLnBrk="1" fontAlgn="auto" latinLnBrk="0" hangingPunct="1">
+                        <a:lnSpc>
+                          <a:spcPct val="100000"/>
+                        </a:lnSpc>
+                        <a:spcBef>
+                          <a:spcPts val="0"/>
+                        </a:spcBef>
+                        <a:spcAft>
+                          <a:spcPts val="0"/>
+                        </a:spcAft>
+                        <a:buClrTx/>
+                        <a:buSzTx/>
+                        <a:buFontTx/>
+                        <a:buNone/>
+                        <a:tabLst/>
+                        <a:defRPr/>
+                      </a:pPr>
+                      <a:r>
+                        <a:rPr lang="en-US" altLang="zh-CN" sz="1400" dirty="0">
+                          <a:latin typeface="Arial" panose="020B0604020202020204" pitchFamily="34" charset="0"/>
+                          <a:cs typeface="Arial" panose="020B0604020202020204" pitchFamily="34" charset="0"/>
+                        </a:rPr>
+                        <a:t>13.46</a:t>
+                      </a:r>
+                      <a:endParaRPr lang="zh-CN" altLang="en-US" sz="1400" dirty="0">
+                        <a:latin typeface="Arial" panose="020B0604020202020204" pitchFamily="34" charset="0"/>
+                        <a:cs typeface="Arial" panose="020B0604020202020204" pitchFamily="34" charset="0"/>
+                      </a:endParaRPr>
+                    </a:p>
+                  </a:txBody>
+                  <a:tcPr/>
+                </a:tc>
+                <a:tc>
+                  <a:txBody>
+                    <a:bodyPr/>
+                    <a:lstStyle/>
+                    <a:p>
+                      <a:pPr algn="ctr"/>
+                      <a:r>
+                        <a:rPr lang="en-US" altLang="zh-CN" sz="1400" dirty="0">
+                          <a:latin typeface="Arial" panose="020B0604020202020204" pitchFamily="34" charset="0"/>
+                          <a:cs typeface="Arial" panose="020B0604020202020204" pitchFamily="34" charset="0"/>
+                        </a:rPr>
+                        <a:t>155.00</a:t>
+                      </a:r>
+                      <a:endParaRPr lang="zh-CN" altLang="en-US" sz="1400" dirty="0">
+                        <a:latin typeface="Arial" panose="020B0604020202020204" pitchFamily="34" charset="0"/>
+                        <a:cs typeface="Arial" panose="020B0604020202020204" pitchFamily="34" charset="0"/>
+                      </a:endParaRPr>
+                    </a:p>
+                  </a:txBody>
+                  <a:tcPr/>
+                </a:tc>
+                <a:tc>
+                  <a:txBody>
+                    <a:bodyPr/>
+                    <a:lstStyle/>
+                    <a:p>
+                      <a:pPr algn="ctr"/>
+                      <a:r>
+                        <a:rPr lang="en-US" altLang="zh-CN" sz="1400" dirty="0">
+                          <a:latin typeface="Arial" panose="020B0604020202020204" pitchFamily="34" charset="0"/>
+                          <a:cs typeface="Arial" panose="020B0604020202020204" pitchFamily="34" charset="0"/>
+                        </a:rPr>
+                        <a:t>27.96</a:t>
+                      </a:r>
+                      <a:endParaRPr lang="zh-CN" altLang="en-US" sz="1400" dirty="0">
+                        <a:latin typeface="Arial" panose="020B0604020202020204" pitchFamily="34" charset="0"/>
+                        <a:cs typeface="Arial" panose="020B0604020202020204" pitchFamily="34" charset="0"/>
+                      </a:endParaRPr>
+                    </a:p>
+                  </a:txBody>
+                  <a:tcPr/>
+                </a:tc>
+                <a:tc>
+                  <a:txBody>
+                    <a:bodyPr/>
+                    <a:lstStyle/>
+                    <a:p>
+                      <a:pPr algn="ctr"/>
+                      <a:r>
+                        <a:rPr lang="en-US" altLang="zh-CN" sz="1400" dirty="0">
+                          <a:latin typeface="Arial" panose="020B0604020202020204" pitchFamily="34" charset="0"/>
+                          <a:cs typeface="Arial" panose="020B0604020202020204" pitchFamily="34" charset="0"/>
+                        </a:rPr>
+                        <a:t>240.96</a:t>
+                      </a:r>
+                      <a:endParaRPr lang="zh-CN" altLang="en-US" sz="1400" dirty="0">
+                        <a:latin typeface="Arial" panose="020B0604020202020204" pitchFamily="34" charset="0"/>
+                        <a:cs typeface="Arial" panose="020B0604020202020204" pitchFamily="34" charset="0"/>
+                      </a:endParaRPr>
+                    </a:p>
+                  </a:txBody>
+                  <a:tcPr/>
+                </a:tc>
+                <a:extLst>
+                  <a:ext uri="{0D108BD9-81ED-4DB2-BD59-A6C34878D82A}">
+                    <a16:rowId xmlns:a16="http://schemas.microsoft.com/office/drawing/2014/main" val="2166985772"/>
+                  </a:ext>
+                </a:extLst>
+              </a:tr>
+            </a:tbl>
+          </a:graphicData>
+        </a:graphic>
+      </p:graphicFrame>
     </p:spTree>
     <p:extLst>
       <p:ext uri="{BB962C8B-B14F-4D97-AF65-F5344CB8AC3E}">

</xml_diff>

<commit_message>
Update slides for 2025-11-13 presentation
Revised the PowerPoint file slides/20251113.pptx with new or updated content for the upcoming presentation.
</commit_message>
<xml_diff>
--- a/slides/20251113.pptx
+++ b/slides/20251113.pptx
@@ -4344,14 +4344,14 @@
           <p:nvPr>
             <p:extLst>
               <p:ext uri="{D42A27DB-BD31-4B8C-83A1-F6EECF244321}">
-                <p14:modId xmlns:p14="http://schemas.microsoft.com/office/powerpoint/2010/main" val="3729296982"/>
+                <p14:modId xmlns:p14="http://schemas.microsoft.com/office/powerpoint/2010/main" val="3019189131"/>
               </p:ext>
             </p:extLst>
           </p:nvPr>
         </p:nvGraphicFramePr>
         <p:xfrm>
           <a:off x="6096000" y="3429000"/>
-          <a:ext cx="6096000" cy="1341120"/>
+          <a:ext cx="5948220" cy="1341120"/>
         </p:xfrm>
         <a:graphic>
           <a:graphicData uri="http://schemas.openxmlformats.org/drawingml/2006/table">
@@ -4360,35 +4360,35 @@
                 <a:tableStyleId>{5C22544A-7EE6-4342-B048-85BDC9FD1C3A}</a:tableStyleId>
               </a:tblPr>
               <a:tblGrid>
-                <a:gridCol w="1219200">
+                <a:gridCol w="1189644">
                   <a:extLst>
                     <a:ext uri="{9D8B030D-6E8A-4147-A177-3AD203B41FA5}">
                       <a16:colId xmlns:a16="http://schemas.microsoft.com/office/drawing/2014/main" val="4101249701"/>
                     </a:ext>
                   </a:extLst>
                 </a:gridCol>
-                <a:gridCol w="1219200">
+                <a:gridCol w="1189644">
                   <a:extLst>
                     <a:ext uri="{9D8B030D-6E8A-4147-A177-3AD203B41FA5}">
                       <a16:colId xmlns:a16="http://schemas.microsoft.com/office/drawing/2014/main" val="64436008"/>
                     </a:ext>
                   </a:extLst>
                 </a:gridCol>
-                <a:gridCol w="1219200">
+                <a:gridCol w="1189644">
                   <a:extLst>
                     <a:ext uri="{9D8B030D-6E8A-4147-A177-3AD203B41FA5}">
                       <a16:colId xmlns:a16="http://schemas.microsoft.com/office/drawing/2014/main" val="2870068380"/>
                     </a:ext>
                   </a:extLst>
                 </a:gridCol>
-                <a:gridCol w="1219200">
+                <a:gridCol w="1189644">
                   <a:extLst>
                     <a:ext uri="{9D8B030D-6E8A-4147-A177-3AD203B41FA5}">
                       <a16:colId xmlns:a16="http://schemas.microsoft.com/office/drawing/2014/main" val="2903000029"/>
                     </a:ext>
                   </a:extLst>
                 </a:gridCol>
-                <a:gridCol w="1219200">
+                <a:gridCol w="1189644">
                   <a:extLst>
                     <a:ext uri="{9D8B030D-6E8A-4147-A177-3AD203B41FA5}">
                       <a16:colId xmlns:a16="http://schemas.microsoft.com/office/drawing/2014/main" val="3141391406"/>
@@ -4396,7 +4396,7 @@
                   </a:extLst>
                 </a:gridCol>
               </a:tblGrid>
-              <a:tr h="249025">
+              <a:tr h="673835">
                 <a:tc>
                   <a:txBody>
                     <a:bodyPr/>
@@ -4613,7 +4613,7 @@
                   </a:ext>
                 </a:extLst>
               </a:tr>
-              <a:tr h="249025">
+              <a:tr h="280765">
                 <a:tc>
                   <a:txBody>
                     <a:bodyPr/>
@@ -4725,7 +4725,7 @@
                   </a:ext>
                 </a:extLst>
               </a:tr>
-              <a:tr h="249025">
+              <a:tr h="280765">
                 <a:tc>
                   <a:txBody>
                     <a:bodyPr/>
@@ -4856,14 +4856,14 @@
           <p:nvPr>
             <p:extLst>
               <p:ext uri="{D42A27DB-BD31-4B8C-83A1-F6EECF244321}">
-                <p14:modId xmlns:p14="http://schemas.microsoft.com/office/powerpoint/2010/main" val="3305237706"/>
+                <p14:modId xmlns:p14="http://schemas.microsoft.com/office/powerpoint/2010/main" val="139963427"/>
               </p:ext>
             </p:extLst>
           </p:nvPr>
         </p:nvGraphicFramePr>
         <p:xfrm>
           <a:off x="6096000" y="4929242"/>
-          <a:ext cx="6096000" cy="1341120"/>
+          <a:ext cx="5948220" cy="1341120"/>
         </p:xfrm>
         <a:graphic>
           <a:graphicData uri="http://schemas.openxmlformats.org/drawingml/2006/table">
@@ -4872,35 +4872,35 @@
                 <a:tableStyleId>{5C22544A-7EE6-4342-B048-85BDC9FD1C3A}</a:tableStyleId>
               </a:tblPr>
               <a:tblGrid>
-                <a:gridCol w="1219200">
+                <a:gridCol w="1189644">
                   <a:extLst>
                     <a:ext uri="{9D8B030D-6E8A-4147-A177-3AD203B41FA5}">
                       <a16:colId xmlns:a16="http://schemas.microsoft.com/office/drawing/2014/main" val="4101249701"/>
                     </a:ext>
                   </a:extLst>
                 </a:gridCol>
-                <a:gridCol w="1219200">
+                <a:gridCol w="1189644">
                   <a:extLst>
                     <a:ext uri="{9D8B030D-6E8A-4147-A177-3AD203B41FA5}">
                       <a16:colId xmlns:a16="http://schemas.microsoft.com/office/drawing/2014/main" val="64436008"/>
                     </a:ext>
                   </a:extLst>
                 </a:gridCol>
-                <a:gridCol w="1219200">
+                <a:gridCol w="1189644">
                   <a:extLst>
                     <a:ext uri="{9D8B030D-6E8A-4147-A177-3AD203B41FA5}">
                       <a16:colId xmlns:a16="http://schemas.microsoft.com/office/drawing/2014/main" val="2870068380"/>
                     </a:ext>
                   </a:extLst>
                 </a:gridCol>
-                <a:gridCol w="1219200">
+                <a:gridCol w="1189644">
                   <a:extLst>
                     <a:ext uri="{9D8B030D-6E8A-4147-A177-3AD203B41FA5}">
                       <a16:colId xmlns:a16="http://schemas.microsoft.com/office/drawing/2014/main" val="2903000029"/>
                     </a:ext>
                   </a:extLst>
                 </a:gridCol>
-                <a:gridCol w="1219200">
+                <a:gridCol w="1189644">
                   <a:extLst>
                     <a:ext uri="{9D8B030D-6E8A-4147-A177-3AD203B41FA5}">
                       <a16:colId xmlns:a16="http://schemas.microsoft.com/office/drawing/2014/main" val="3141391406"/>
@@ -4908,7 +4908,7 @@
                   </a:extLst>
                 </a:gridCol>
               </a:tblGrid>
-              <a:tr h="249025">
+              <a:tr h="666641">
                 <a:tc>
                   <a:txBody>
                     <a:bodyPr/>
@@ -5142,7 +5142,7 @@
                   </a:ext>
                 </a:extLst>
               </a:tr>
-              <a:tr h="249025">
+              <a:tr h="277767">
                 <a:tc>
                   <a:txBody>
                     <a:bodyPr/>
@@ -5250,7 +5250,7 @@
                   </a:ext>
                 </a:extLst>
               </a:tr>
-              <a:tr h="249025">
+              <a:tr h="277767">
                 <a:tc>
                   <a:txBody>
                     <a:bodyPr/>

</xml_diff>

<commit_message>
Update hallucination figure labels and slide
Changed y-axis label to 'Hallucination (%)' and updated the plot title to 'Hallucination Rate after Repair' in recheck_hallucination_figure.py. Updated the corresponding PNG output and PowerPoint slide to reflect these changes.
</commit_message>
<xml_diff>
--- a/slides/20251113.pptx
+++ b/slides/20251113.pptx
@@ -4223,10 +4223,10 @@
       </p:grpSpPr>
       <p:pic>
         <p:nvPicPr>
-          <p:cNvPr id="3" name="图片 2" descr="图表, 条形图&#10;&#10;AI 生成的内容可能不正确。">
-            <a:extLst>
-              <a:ext uri="{FF2B5EF4-FFF2-40B4-BE49-F238E27FC236}">
-                <a16:creationId xmlns:a16="http://schemas.microsoft.com/office/drawing/2014/main" id="{1BCD90D5-6BBB-175A-4E6B-1BD618247186}"/>
+          <p:cNvPr id="5" name="图片 4" descr="图表, 条形图&#10;&#10;AI 生成的内容可能不正确。">
+            <a:extLst>
+              <a:ext uri="{FF2B5EF4-FFF2-40B4-BE49-F238E27FC236}">
+                <a16:creationId xmlns:a16="http://schemas.microsoft.com/office/drawing/2014/main" id="{33944433-05EC-4E5C-2432-96D536C1AC06}"/>
               </a:ext>
             </a:extLst>
           </p:cNvPr>
@@ -4237,42 +4237,6 @@
         </p:nvPicPr>
         <p:blipFill>
           <a:blip r:embed="rId2">
-            <a:extLst>
-              <a:ext uri="{28A0092B-C50C-407E-A947-70E740481C1C}">
-                <a14:useLocalDpi xmlns:a14="http://schemas.microsoft.com/office/drawing/2010/main" val="0"/>
-              </a:ext>
-            </a:extLst>
-          </a:blip>
-          <a:stretch>
-            <a:fillRect/>
-          </a:stretch>
-        </p:blipFill>
-        <p:spPr>
-          <a:xfrm>
-            <a:off x="1613573" y="59230"/>
-            <a:ext cx="3924978" cy="3210648"/>
-          </a:xfrm>
-          <a:prstGeom prst="rect">
-            <a:avLst/>
-          </a:prstGeom>
-        </p:spPr>
-      </p:pic>
-      <p:pic>
-        <p:nvPicPr>
-          <p:cNvPr id="5" name="图片 4" descr="图表, 条形图&#10;&#10;AI 生成的内容可能不正确。">
-            <a:extLst>
-              <a:ext uri="{FF2B5EF4-FFF2-40B4-BE49-F238E27FC236}">
-                <a16:creationId xmlns:a16="http://schemas.microsoft.com/office/drawing/2014/main" id="{33944433-05EC-4E5C-2432-96D536C1AC06}"/>
-              </a:ext>
-            </a:extLst>
-          </p:cNvPr>
-          <p:cNvPicPr>
-            <a:picLocks noChangeAspect="1"/>
-          </p:cNvPicPr>
-          <p:nvPr/>
-        </p:nvPicPr>
-        <p:blipFill>
-          <a:blip r:embed="rId3">
             <a:extLst>
               <a:ext uri="{28A0092B-C50C-407E-A947-70E740481C1C}">
                 <a14:useLocalDpi xmlns:a14="http://schemas.microsoft.com/office/drawing/2010/main" val="0"/>
@@ -4308,7 +4272,7 @@
           <p:nvPr/>
         </p:nvPicPr>
         <p:blipFill>
-          <a:blip r:embed="rId4">
+          <a:blip r:embed="rId3">
             <a:extLst>
               <a:ext uri="{28A0092B-C50C-407E-A947-70E740481C1C}">
                 <a14:useLocalDpi xmlns:a14="http://schemas.microsoft.com/office/drawing/2010/main" val="0"/>
@@ -5382,6 +5346,42 @@
           </a:graphicData>
         </a:graphic>
       </p:graphicFrame>
+      <p:pic>
+        <p:nvPicPr>
+          <p:cNvPr id="4" name="图片 3" descr="图表, 条形图&#10;&#10;AI 生成的内容可能不正确。">
+            <a:extLst>
+              <a:ext uri="{FF2B5EF4-FFF2-40B4-BE49-F238E27FC236}">
+                <a16:creationId xmlns:a16="http://schemas.microsoft.com/office/drawing/2014/main" id="{50E62019-7A16-290C-1833-4A1FD6FCE9B2}"/>
+              </a:ext>
+            </a:extLst>
+          </p:cNvPr>
+          <p:cNvPicPr>
+            <a:picLocks noChangeAspect="1"/>
+          </p:cNvPicPr>
+          <p:nvPr/>
+        </p:nvPicPr>
+        <p:blipFill>
+          <a:blip r:embed="rId4">
+            <a:extLst>
+              <a:ext uri="{28A0092B-C50C-407E-A947-70E740481C1C}">
+                <a14:useLocalDpi xmlns:a14="http://schemas.microsoft.com/office/drawing/2010/main" val="0"/>
+              </a:ext>
+            </a:extLst>
+          </a:blip>
+          <a:stretch>
+            <a:fillRect/>
+          </a:stretch>
+        </p:blipFill>
+        <p:spPr>
+          <a:xfrm>
+            <a:off x="1613573" y="59230"/>
+            <a:ext cx="3924978" cy="3210648"/>
+          </a:xfrm>
+          <a:prstGeom prst="rect">
+            <a:avLst/>
+          </a:prstGeom>
+        </p:spPr>
+      </p:pic>
     </p:spTree>
     <p:extLst>
       <p:ext uri="{BB962C8B-B14F-4D97-AF65-F5344CB8AC3E}">

</xml_diff>

<commit_message>
Add workflow and cove figures; update test and slide files
Added new workflow and cove diagrams in .drawio and .png formats. Updated slide deck, test CSV, and overcorrection figure and image to reflect new data and corrections, including a fix in the bar annotation loop in overcorrection_figure.py.
</commit_message>
<xml_diff>
--- a/slides/20251113.pptx
+++ b/slides/20251113.pptx
@@ -8,9 +8,9 @@
     <p:sldId id="260" r:id="rId2"/>
     <p:sldId id="261" r:id="rId3"/>
     <p:sldId id="257" r:id="rId4"/>
-    <p:sldId id="263" r:id="rId5"/>
-    <p:sldId id="258" r:id="rId6"/>
-    <p:sldId id="262" r:id="rId7"/>
+    <p:sldId id="265" r:id="rId5"/>
+    <p:sldId id="264" r:id="rId6"/>
+    <p:sldId id="263" r:id="rId7"/>
     <p:sldId id="259" r:id="rId8"/>
   </p:sldIdLst>
   <p:sldSz cx="12192000" cy="6858000"/>
@@ -265,7 +265,7 @@
           <a:p>
             <a:fld id="{3F567BA6-CBC2-4FF0-810E-3ED1BF2C4381}" type="datetimeFigureOut">
               <a:rPr lang="zh-CN" altLang="en-US" smtClean="0"/>
-              <a:t>2025/11/19</a:t>
+              <a:t>2025/11/25</a:t>
             </a:fld>
             <a:endParaRPr lang="zh-CN" altLang="en-US"/>
           </a:p>
@@ -463,7 +463,7 @@
           <a:p>
             <a:fld id="{3F567BA6-CBC2-4FF0-810E-3ED1BF2C4381}" type="datetimeFigureOut">
               <a:rPr lang="zh-CN" altLang="en-US" smtClean="0"/>
-              <a:t>2025/11/19</a:t>
+              <a:t>2025/11/25</a:t>
             </a:fld>
             <a:endParaRPr lang="zh-CN" altLang="en-US"/>
           </a:p>
@@ -671,7 +671,7 @@
           <a:p>
             <a:fld id="{3F567BA6-CBC2-4FF0-810E-3ED1BF2C4381}" type="datetimeFigureOut">
               <a:rPr lang="zh-CN" altLang="en-US" smtClean="0"/>
-              <a:t>2025/11/19</a:t>
+              <a:t>2025/11/25</a:t>
             </a:fld>
             <a:endParaRPr lang="zh-CN" altLang="en-US"/>
           </a:p>
@@ -869,7 +869,7 @@
           <a:p>
             <a:fld id="{3F567BA6-CBC2-4FF0-810E-3ED1BF2C4381}" type="datetimeFigureOut">
               <a:rPr lang="zh-CN" altLang="en-US" smtClean="0"/>
-              <a:t>2025/11/19</a:t>
+              <a:t>2025/11/25</a:t>
             </a:fld>
             <a:endParaRPr lang="zh-CN" altLang="en-US"/>
           </a:p>
@@ -1144,7 +1144,7 @@
           <a:p>
             <a:fld id="{3F567BA6-CBC2-4FF0-810E-3ED1BF2C4381}" type="datetimeFigureOut">
               <a:rPr lang="zh-CN" altLang="en-US" smtClean="0"/>
-              <a:t>2025/11/19</a:t>
+              <a:t>2025/11/25</a:t>
             </a:fld>
             <a:endParaRPr lang="zh-CN" altLang="en-US"/>
           </a:p>
@@ -1409,7 +1409,7 @@
           <a:p>
             <a:fld id="{3F567BA6-CBC2-4FF0-810E-3ED1BF2C4381}" type="datetimeFigureOut">
               <a:rPr lang="zh-CN" altLang="en-US" smtClean="0"/>
-              <a:t>2025/11/19</a:t>
+              <a:t>2025/11/25</a:t>
             </a:fld>
             <a:endParaRPr lang="zh-CN" altLang="en-US"/>
           </a:p>
@@ -1821,7 +1821,7 @@
           <a:p>
             <a:fld id="{3F567BA6-CBC2-4FF0-810E-3ED1BF2C4381}" type="datetimeFigureOut">
               <a:rPr lang="zh-CN" altLang="en-US" smtClean="0"/>
-              <a:t>2025/11/19</a:t>
+              <a:t>2025/11/25</a:t>
             </a:fld>
             <a:endParaRPr lang="zh-CN" altLang="en-US"/>
           </a:p>
@@ -1962,7 +1962,7 @@
           <a:p>
             <a:fld id="{3F567BA6-CBC2-4FF0-810E-3ED1BF2C4381}" type="datetimeFigureOut">
               <a:rPr lang="zh-CN" altLang="en-US" smtClean="0"/>
-              <a:t>2025/11/19</a:t>
+              <a:t>2025/11/25</a:t>
             </a:fld>
             <a:endParaRPr lang="zh-CN" altLang="en-US"/>
           </a:p>
@@ -2075,7 +2075,7 @@
           <a:p>
             <a:fld id="{3F567BA6-CBC2-4FF0-810E-3ED1BF2C4381}" type="datetimeFigureOut">
               <a:rPr lang="zh-CN" altLang="en-US" smtClean="0"/>
-              <a:t>2025/11/19</a:t>
+              <a:t>2025/11/25</a:t>
             </a:fld>
             <a:endParaRPr lang="zh-CN" altLang="en-US"/>
           </a:p>
@@ -2386,7 +2386,7 @@
           <a:p>
             <a:fld id="{3F567BA6-CBC2-4FF0-810E-3ED1BF2C4381}" type="datetimeFigureOut">
               <a:rPr lang="zh-CN" altLang="en-US" smtClean="0"/>
-              <a:t>2025/11/19</a:t>
+              <a:t>2025/11/25</a:t>
             </a:fld>
             <a:endParaRPr lang="zh-CN" altLang="en-US"/>
           </a:p>
@@ -2674,7 +2674,7 @@
           <a:p>
             <a:fld id="{3F567BA6-CBC2-4FF0-810E-3ED1BF2C4381}" type="datetimeFigureOut">
               <a:rPr lang="zh-CN" altLang="en-US" smtClean="0"/>
-              <a:t>2025/11/19</a:t>
+              <a:t>2025/11/25</a:t>
             </a:fld>
             <a:endParaRPr lang="zh-CN" altLang="en-US"/>
           </a:p>
@@ -2915,7 +2915,7 @@
           <a:p>
             <a:fld id="{3F567BA6-CBC2-4FF0-810E-3ED1BF2C4381}" type="datetimeFigureOut">
               <a:rPr lang="zh-CN" altLang="en-US" smtClean="0"/>
-              <a:t>2025/11/19</a:t>
+              <a:t>2025/11/25</a:t>
             </a:fld>
             <a:endParaRPr lang="zh-CN" altLang="en-US"/>
           </a:p>
@@ -3347,7 +3347,7 @@
         <p:spPr>
           <a:xfrm>
             <a:off x="479719" y="151179"/>
-            <a:ext cx="11219222" cy="5386090"/>
+            <a:ext cx="11219222" cy="3231654"/>
           </a:xfrm>
           <a:prstGeom prst="rect">
             <a:avLst/>
@@ -3365,7 +3365,7 @@
                 <a:latin typeface="Arial" panose="020B0604020202020204" pitchFamily="34" charset="0"/>
                 <a:cs typeface="Arial" panose="020B0604020202020204" pitchFamily="34" charset="0"/>
               </a:rPr>
-              <a:t>Idea:</a:t>
+              <a:t>Idea</a:t>
             </a:r>
           </a:p>
           <a:p>
@@ -3407,21 +3407,7 @@
                 <a:latin typeface="Arial" panose="020B0604020202020204" pitchFamily="34" charset="0"/>
                 <a:cs typeface="Arial" panose="020B0604020202020204" pitchFamily="34" charset="0"/>
               </a:rPr>
-              <a:t>Question to LLM -&gt; </a:t>
-            </a:r>
-            <a:r>
-              <a:rPr lang="en-US" altLang="zh-CN" sz="2000" dirty="0" err="1">
-                <a:latin typeface="Arial" panose="020B0604020202020204" pitchFamily="34" charset="0"/>
-                <a:cs typeface="Arial" panose="020B0604020202020204" pitchFamily="34" charset="0"/>
-              </a:rPr>
-              <a:t>base_response</a:t>
-            </a:r>
-            <a:r>
-              <a:rPr lang="en-US" altLang="zh-CN" sz="2000" dirty="0">
-                <a:latin typeface="Arial" panose="020B0604020202020204" pitchFamily="34" charset="0"/>
-                <a:cs typeface="Arial" panose="020B0604020202020204" pitchFamily="34" charset="0"/>
-              </a:rPr>
-              <a:t> -&gt; prompt with </a:t>
+              <a:t>Question to LLM -&gt; base response -&gt; generate mutations -&gt; prompt LLM with </a:t>
             </a:r>
             <a:r>
               <a:rPr lang="en-US" altLang="zh-CN" sz="2000" b="1" dirty="0">
@@ -3435,38 +3421,77 @@
                 <a:latin typeface="Arial" panose="020B0604020202020204" pitchFamily="34" charset="0"/>
                 <a:cs typeface="Arial" panose="020B0604020202020204" pitchFamily="34" charset="0"/>
               </a:rPr>
-              <a:t>-&gt; </a:t>
-            </a:r>
-            <a:r>
-              <a:rPr lang="en-US" altLang="zh-CN" sz="2000" dirty="0" err="1">
-                <a:latin typeface="Arial" panose="020B0604020202020204" pitchFamily="34" charset="0"/>
-                <a:cs typeface="Arial" panose="020B0604020202020204" pitchFamily="34" charset="0"/>
-              </a:rPr>
-              <a:t>final_answer</a:t>
-            </a:r>
-            <a:endParaRPr lang="en-US" altLang="zh-CN" sz="2000" dirty="0">
-              <a:latin typeface="Arial" panose="020B0604020202020204" pitchFamily="34" charset="0"/>
-              <a:cs typeface="Arial" panose="020B0604020202020204" pitchFamily="34" charset="0"/>
-            </a:endParaRPr>
-          </a:p>
-          <a:p>
-            <a:r>
-              <a:rPr lang="en-US" altLang="zh-CN" sz="2000" dirty="0">
-                <a:latin typeface="Arial" panose="020B0604020202020204" pitchFamily="34" charset="0"/>
-                <a:cs typeface="Arial" panose="020B0604020202020204" pitchFamily="34" charset="0"/>
-              </a:rPr>
-              <a:t>(Borui: could also use mutations in recheck process, which surely can improve effectiveness)</a:t>
-            </a:r>
-          </a:p>
-          <a:p>
-            <a:endParaRPr lang="en-US" altLang="zh-CN" sz="2000" dirty="0">
-              <a:latin typeface="Arial" panose="020B0604020202020204" pitchFamily="34" charset="0"/>
-              <a:cs typeface="Arial" panose="020B0604020202020204" pitchFamily="34" charset="0"/>
-            </a:endParaRPr>
-          </a:p>
-          <a:p>
-            <a:r>
-              <a:rPr lang="en-US" altLang="zh-CN" sz="2000" dirty="0">
+              <a:t>-&gt; final answer</a:t>
+            </a:r>
+          </a:p>
+        </p:txBody>
+      </p:sp>
+      <p:pic>
+        <p:nvPicPr>
+          <p:cNvPr id="3" name="图片 2" descr="图形用户界面, 文本, 应用程序&#10;&#10;AI 生成的内容可能不正确。">
+            <a:extLst>
+              <a:ext uri="{FF2B5EF4-FFF2-40B4-BE49-F238E27FC236}">
+                <a16:creationId xmlns:a16="http://schemas.microsoft.com/office/drawing/2014/main" id="{370D5F52-36D5-4846-ACD1-5FF887A94168}"/>
+              </a:ext>
+            </a:extLst>
+          </p:cNvPr>
+          <p:cNvPicPr>
+            <a:picLocks noChangeAspect="1"/>
+          </p:cNvPicPr>
+          <p:nvPr/>
+        </p:nvPicPr>
+        <p:blipFill>
+          <a:blip r:embed="rId2">
+            <a:extLst>
+              <a:ext uri="{28A0092B-C50C-407E-A947-70E740481C1C}">
+                <a14:useLocalDpi xmlns:a14="http://schemas.microsoft.com/office/drawing/2010/main" val="0"/>
+              </a:ext>
+            </a:extLst>
+          </a:blip>
+          <a:stretch>
+            <a:fillRect/>
+          </a:stretch>
+        </p:blipFill>
+        <p:spPr>
+          <a:xfrm>
+            <a:off x="3227067" y="3366669"/>
+            <a:ext cx="5724525" cy="2200275"/>
+          </a:xfrm>
+          <a:prstGeom prst="rect">
+            <a:avLst/>
+          </a:prstGeom>
+        </p:spPr>
+      </p:pic>
+      <p:sp>
+        <p:nvSpPr>
+          <p:cNvPr id="9" name="文本框 8">
+            <a:extLst>
+              <a:ext uri="{FF2B5EF4-FFF2-40B4-BE49-F238E27FC236}">
+                <a16:creationId xmlns:a16="http://schemas.microsoft.com/office/drawing/2014/main" id="{DF340774-0650-C171-2E71-F98F9F11AEB8}"/>
+              </a:ext>
+            </a:extLst>
+          </p:cNvPr>
+          <p:cNvSpPr txBox="1"/>
+          <p:nvPr/>
+        </p:nvSpPr>
+        <p:spPr>
+          <a:xfrm>
+            <a:off x="479718" y="5566944"/>
+            <a:ext cx="11219222" cy="923330"/>
+          </a:xfrm>
+          <a:prstGeom prst="rect">
+            <a:avLst/>
+          </a:prstGeom>
+          <a:noFill/>
+        </p:spPr>
+        <p:txBody>
+          <a:bodyPr wrap="square">
+            <a:spAutoFit/>
+          </a:bodyPr>
+          <a:lstStyle/>
+          <a:p>
+            <a:r>
+              <a:rPr lang="en-US" altLang="zh-CN" dirty="0">
                 <a:latin typeface="Arial" panose="020B0604020202020204" pitchFamily="34" charset="0"/>
                 <a:cs typeface="Arial" panose="020B0604020202020204" pitchFamily="34" charset="0"/>
               </a:rPr>
@@ -3475,29 +3500,11 @@
           </a:p>
           <a:p>
             <a:r>
-              <a:rPr lang="en-US" altLang="zh-CN" sz="2000" dirty="0">
+              <a:rPr lang="en-US" altLang="zh-CN" dirty="0">
                 <a:latin typeface="+mn-ea"/>
                 <a:cs typeface="Arial" panose="020B0604020202020204" pitchFamily="34" charset="0"/>
               </a:rPr>
-              <a:t>RECHECK_PROMPT = """The **original response** contains hallucinations or factual errors in answering the given question. Your task is to fact-check it and provide a corrected one-sentence answer.</a:t>
-            </a:r>
-          </a:p>
-          <a:p>
-            <a:r>
-              <a:rPr lang="en-US" altLang="zh-CN" sz="2000" dirty="0">
-                <a:latin typeface="+mn-ea"/>
-                <a:cs typeface="Arial" panose="020B0604020202020204" pitchFamily="34" charset="0"/>
-              </a:rPr>
-              <a:t>…</a:t>
-            </a:r>
-          </a:p>
-          <a:p>
-            <a:r>
-              <a:rPr lang="en-US" altLang="zh-CN" sz="2000" dirty="0">
-                <a:latin typeface="+mn-ea"/>
-                <a:cs typeface="Arial" panose="020B0604020202020204" pitchFamily="34" charset="0"/>
-              </a:rPr>
-              <a:t>"""</a:t>
+              <a:t>RECHECK_PROMPT = """The **original response** contains hallucinations or factual errors in answering the given question. Your task is to fact-check it and provide a corrected one-sentence answer."""</a:t>
             </a:r>
           </a:p>
         </p:txBody>
@@ -3553,7 +3560,7 @@
         <p:spPr>
           <a:xfrm>
             <a:off x="479719" y="151179"/>
-            <a:ext cx="11219222" cy="4370427"/>
+            <a:ext cx="11219222" cy="3477875"/>
           </a:xfrm>
           <a:prstGeom prst="rect">
             <a:avLst/>
@@ -3585,7 +3592,7 @@
                 <a:latin typeface="Arial" panose="020B0604020202020204" pitchFamily="34" charset="0"/>
                 <a:cs typeface="Arial" panose="020B0604020202020204" pitchFamily="34" charset="0"/>
               </a:rPr>
-              <a:t> idea:</a:t>
+              <a:t> idea</a:t>
             </a:r>
           </a:p>
           <a:p>
@@ -3607,23 +3614,46 @@
             </a:br>
             <a:r>
               <a:rPr lang="en-US" altLang="zh-CN" dirty="0"/>
-              <a:t>Let's think step by step and provide the most accurate final answer.</a:t>
+              <a:t>Let's think step by step and provide the most accurate final answer. """</a:t>
             </a:r>
             <a:br>
               <a:rPr lang="en-US" altLang="zh-CN" dirty="0"/>
             </a:br>
-            <a:r>
-              <a:rPr lang="en-US" altLang="zh-CN" dirty="0"/>
-              <a:t>"""</a:t>
-            </a:r>
-          </a:p>
-          <a:p>
             <a:endParaRPr lang="en-US" altLang="zh-CN" sz="2000" dirty="0">
               <a:latin typeface="Arial" panose="020B0604020202020204" pitchFamily="34" charset="0"/>
               <a:cs typeface="Arial" panose="020B0604020202020204" pitchFamily="34" charset="0"/>
             </a:endParaRPr>
           </a:p>
           <a:p>
+            <a:r>
+              <a:rPr lang="en-US" altLang="zh-CN" sz="3200" dirty="0">
+                <a:latin typeface="Arial" panose="020B0604020202020204" pitchFamily="34" charset="0"/>
+                <a:cs typeface="Arial" panose="020B0604020202020204" pitchFamily="34" charset="0"/>
+              </a:rPr>
+              <a:t>Baseline </a:t>
+            </a:r>
+            <a:r>
+              <a:rPr lang="en-US" altLang="zh-CN" sz="3200" dirty="0" err="1">
+                <a:latin typeface="Arial" panose="020B0604020202020204" pitchFamily="34" charset="0"/>
+                <a:cs typeface="Arial" panose="020B0604020202020204" pitchFamily="34" charset="0"/>
+              </a:rPr>
+              <a:t>CoVe’s</a:t>
+            </a:r>
+            <a:r>
+              <a:rPr lang="en-US" altLang="zh-CN" sz="3200" dirty="0">
+                <a:latin typeface="Arial" panose="020B0604020202020204" pitchFamily="34" charset="0"/>
+                <a:cs typeface="Arial" panose="020B0604020202020204" pitchFamily="34" charset="0"/>
+              </a:rPr>
+              <a:t> idea </a:t>
+            </a:r>
+            <a:r>
+              <a:rPr lang="en-US" altLang="zh-CN" sz="2000" dirty="0">
+                <a:latin typeface="Arial" panose="020B0604020202020204" pitchFamily="34" charset="0"/>
+                <a:cs typeface="Arial" panose="020B0604020202020204" pitchFamily="34" charset="0"/>
+                <a:hlinkClick r:id="rId2"/>
+              </a:rPr>
+              <a:t>https://arxiv.org/pdf/2309.11495</a:t>
+            </a:r>
             <a:endParaRPr lang="en-US" altLang="zh-CN" sz="2000" dirty="0">
               <a:latin typeface="Arial" panose="020B0604020202020204" pitchFamily="34" charset="0"/>
               <a:cs typeface="Arial" panose="020B0604020202020204" pitchFamily="34" charset="0"/>
@@ -3631,41 +3661,6 @@
           </a:p>
           <a:p>
             <a:r>
-              <a:rPr lang="en-US" altLang="zh-CN" sz="3200" dirty="0">
-                <a:latin typeface="Arial" panose="020B0604020202020204" pitchFamily="34" charset="0"/>
-                <a:cs typeface="Arial" panose="020B0604020202020204" pitchFamily="34" charset="0"/>
-              </a:rPr>
-              <a:t>Baseline </a:t>
-            </a:r>
-            <a:r>
-              <a:rPr lang="en-US" altLang="zh-CN" sz="3200" dirty="0" err="1">
-                <a:latin typeface="Arial" panose="020B0604020202020204" pitchFamily="34" charset="0"/>
-                <a:cs typeface="Arial" panose="020B0604020202020204" pitchFamily="34" charset="0"/>
-              </a:rPr>
-              <a:t>CoVe’s</a:t>
-            </a:r>
-            <a:r>
-              <a:rPr lang="en-US" altLang="zh-CN" sz="3200" dirty="0">
-                <a:latin typeface="Arial" panose="020B0604020202020204" pitchFamily="34" charset="0"/>
-                <a:cs typeface="Arial" panose="020B0604020202020204" pitchFamily="34" charset="0"/>
-              </a:rPr>
-              <a:t> idea: </a:t>
-            </a:r>
-            <a:r>
-              <a:rPr lang="en-US" altLang="zh-CN" sz="2000" dirty="0">
-                <a:latin typeface="Arial" panose="020B0604020202020204" pitchFamily="34" charset="0"/>
-                <a:cs typeface="Arial" panose="020B0604020202020204" pitchFamily="34" charset="0"/>
-                <a:hlinkClick r:id="rId2"/>
-              </a:rPr>
-              <a:t>https://arxiv.org/pdf/2309.11495</a:t>
-            </a:r>
-            <a:endParaRPr lang="en-US" altLang="zh-CN" sz="2000" dirty="0">
-              <a:latin typeface="Arial" panose="020B0604020202020204" pitchFamily="34" charset="0"/>
-              <a:cs typeface="Arial" panose="020B0604020202020204" pitchFamily="34" charset="0"/>
-            </a:endParaRPr>
-          </a:p>
-          <a:p>
-            <a:r>
               <a:rPr lang="en-US" altLang="zh-CN" sz="2000" dirty="0">
                 <a:latin typeface="Arial" panose="020B0604020202020204" pitchFamily="34" charset="0"/>
                 <a:cs typeface="Arial" panose="020B0604020202020204" pitchFamily="34" charset="0"/>
@@ -3682,14 +3677,44 @@
               <a:t>Next, the LLM independently answers these verification questions, often using retrieval, and uses the verified facts to revise the original answer.</a:t>
             </a:r>
           </a:p>
-          <a:p>
-            <a:endParaRPr lang="en-US" altLang="zh-CN" sz="2000" dirty="0">
-              <a:latin typeface="Arial" panose="020B0604020202020204" pitchFamily="34" charset="0"/>
-              <a:cs typeface="Arial" panose="020B0604020202020204" pitchFamily="34" charset="0"/>
-            </a:endParaRPr>
-          </a:p>
-        </p:txBody>
-      </p:sp>
+        </p:txBody>
+      </p:sp>
+      <p:pic>
+        <p:nvPicPr>
+          <p:cNvPr id="3" name="图片 2" descr="图示&#10;&#10;AI 生成的内容可能不正确。">
+            <a:extLst>
+              <a:ext uri="{FF2B5EF4-FFF2-40B4-BE49-F238E27FC236}">
+                <a16:creationId xmlns:a16="http://schemas.microsoft.com/office/drawing/2014/main" id="{563B55FC-64E1-8BC1-67F1-26355938CAED}"/>
+              </a:ext>
+            </a:extLst>
+          </p:cNvPr>
+          <p:cNvPicPr>
+            <a:picLocks noChangeAspect="1"/>
+          </p:cNvPicPr>
+          <p:nvPr/>
+        </p:nvPicPr>
+        <p:blipFill>
+          <a:blip r:embed="rId3">
+            <a:extLst>
+              <a:ext uri="{28A0092B-C50C-407E-A947-70E740481C1C}">
+                <a14:useLocalDpi xmlns:a14="http://schemas.microsoft.com/office/drawing/2010/main" val="0"/>
+              </a:ext>
+            </a:extLst>
+          </a:blip>
+          <a:stretch>
+            <a:fillRect/>
+          </a:stretch>
+        </p:blipFill>
+        <p:spPr>
+          <a:xfrm>
+            <a:off x="3227067" y="3629054"/>
+            <a:ext cx="5724525" cy="2771775"/>
+          </a:xfrm>
+          <a:prstGeom prst="rect">
+            <a:avLst/>
+          </a:prstGeom>
+        </p:spPr>
+      </p:pic>
     </p:spTree>
     <p:extLst>
       <p:ext uri="{BB962C8B-B14F-4D97-AF65-F5344CB8AC3E}">
@@ -3741,7 +3766,7 @@
         <p:spPr>
           <a:xfrm>
             <a:off x="479719" y="151179"/>
-            <a:ext cx="11219222" cy="4401205"/>
+            <a:ext cx="11219222" cy="5139869"/>
           </a:xfrm>
           <a:prstGeom prst="rect">
             <a:avLst/>
@@ -3775,11 +3800,18 @@
               <a:t>Experiment dataset: </a:t>
             </a:r>
             <a:r>
-              <a:rPr lang="en-US" altLang="zh-CN" sz="2000" dirty="0">
-                <a:latin typeface="Arial" panose="020B0604020202020204" pitchFamily="34" charset="0"/>
-                <a:cs typeface="Arial" panose="020B0604020202020204" pitchFamily="34" charset="0"/>
-              </a:rPr>
-              <a:t>224 (85 from </a:t>
+              <a:rPr lang="en-US" altLang="zh-CN" sz="2000" b="1" dirty="0">
+                <a:latin typeface="Arial" panose="020B0604020202020204" pitchFamily="34" charset="0"/>
+                <a:cs typeface="Arial" panose="020B0604020202020204" pitchFamily="34" charset="0"/>
+              </a:rPr>
+              <a:t>224</a:t>
+            </a:r>
+            <a:r>
+              <a:rPr lang="en-US" altLang="zh-CN" sz="2000" dirty="0">
+                <a:latin typeface="Arial" panose="020B0604020202020204" pitchFamily="34" charset="0"/>
+                <a:cs typeface="Arial" panose="020B0604020202020204" pitchFamily="34" charset="0"/>
+              </a:rPr>
+              <a:t> (85 from </a:t>
             </a:r>
             <a:r>
               <a:rPr lang="en-US" altLang="zh-CN" sz="2000" dirty="0" err="1">
@@ -3816,7 +3848,21 @@
                 <a:latin typeface="Arial" panose="020B0604020202020204" pitchFamily="34" charset="0"/>
                 <a:cs typeface="Arial" panose="020B0604020202020204" pitchFamily="34" charset="0"/>
               </a:rPr>
-              <a:t>Randomly select about 50%(111) samples to generate hallucination base response</a:t>
+              <a:t>Randomly select about </a:t>
+            </a:r>
+            <a:r>
+              <a:rPr lang="en-US" altLang="zh-CN" sz="2000" b="1" dirty="0">
+                <a:latin typeface="Arial" panose="020B0604020202020204" pitchFamily="34" charset="0"/>
+                <a:cs typeface="Arial" panose="020B0604020202020204" pitchFamily="34" charset="0"/>
+              </a:rPr>
+              <a:t>50%(113) </a:t>
+            </a:r>
+            <a:r>
+              <a:rPr lang="en-US" altLang="zh-CN" sz="2000" dirty="0">
+                <a:latin typeface="Arial" panose="020B0604020202020204" pitchFamily="34" charset="0"/>
+                <a:cs typeface="Arial" panose="020B0604020202020204" pitchFamily="34" charset="0"/>
+              </a:rPr>
+              <a:t>samples to generate hallucination base response</a:t>
             </a:r>
           </a:p>
           <a:p>
@@ -3827,7 +3873,7 @@
           </a:p>
           <a:p>
             <a:r>
-              <a:rPr lang="en-US" altLang="zh-CN" sz="2000" b="1" dirty="0">
+              <a:rPr lang="en-US" altLang="zh-CN" sz="2400" b="1" dirty="0">
                 <a:latin typeface="Arial" panose="020B0604020202020204" pitchFamily="34" charset="0"/>
                 <a:cs typeface="Arial" panose="020B0604020202020204" pitchFamily="34" charset="0"/>
               </a:rPr>
@@ -4008,7 +4054,7 @@
             <a:r>
               <a:rPr lang="en-US" altLang="zh-CN" sz="2000" dirty="0">
                 <a:solidFill>
-                  <a:srgbClr val="00B0F0"/>
+                  <a:schemeClr val="accent1"/>
                 </a:solidFill>
                 <a:latin typeface="Arial" panose="020B0604020202020204" pitchFamily="34" charset="0"/>
                 <a:cs typeface="Arial" panose="020B0604020202020204" pitchFamily="34" charset="0"/>
@@ -4119,7 +4165,7 @@
             <a:r>
               <a:rPr lang="en-US" altLang="zh-CN" sz="2000" dirty="0">
                 <a:solidFill>
-                  <a:srgbClr val="00B0F0"/>
+                  <a:schemeClr val="accent1"/>
                 </a:solidFill>
                 <a:latin typeface="Arial" panose="020B0604020202020204" pitchFamily="34" charset="0"/>
                 <a:cs typeface="Arial" panose="020B0604020202020204" pitchFamily="34" charset="0"/>
@@ -4181,6 +4227,28 @@
                 <a:cs typeface="Arial" panose="020B0604020202020204" pitchFamily="34" charset="0"/>
               </a:rPr>
               <a:t>avg time cost pre question</a:t>
+            </a:r>
+          </a:p>
+          <a:p>
+            <a:endParaRPr lang="en-US" altLang="zh-CN" sz="2000" dirty="0">
+              <a:latin typeface="Arial" panose="020B0604020202020204" pitchFamily="34" charset="0"/>
+              <a:cs typeface="Arial" panose="020B0604020202020204" pitchFamily="34" charset="0"/>
+            </a:endParaRPr>
+          </a:p>
+          <a:p>
+            <a:r>
+              <a:rPr lang="en-US" altLang="zh-CN" sz="2400" b="1" dirty="0">
+                <a:latin typeface="Arial" panose="020B0604020202020204" pitchFamily="34" charset="0"/>
+                <a:cs typeface="Arial" panose="020B0604020202020204" pitchFamily="34" charset="0"/>
+              </a:rPr>
+              <a:t>Number of mutations: </a:t>
+            </a:r>
+            <a:r>
+              <a:rPr lang="en-US" altLang="zh-CN" sz="2000" dirty="0">
+                <a:latin typeface="Arial" panose="020B0604020202020204" pitchFamily="34" charset="0"/>
+                <a:cs typeface="Arial" panose="020B0604020202020204" pitchFamily="34" charset="0"/>
+              </a:rPr>
+              <a:t>5(synonym)</a:t>
             </a:r>
           </a:p>
         </p:txBody>
@@ -4199,6 +4267,433 @@
 </file>
 
 <file path=ppt/slides/slide4.xml><?xml version="1.0" encoding="utf-8"?>
+<p:sld xmlns:a="http://schemas.openxmlformats.org/drawingml/2006/main" xmlns:r="http://schemas.openxmlformats.org/officeDocument/2006/relationships" xmlns:p="http://schemas.openxmlformats.org/presentationml/2006/main">
+  <p:cSld>
+    <p:spTree>
+      <p:nvGrpSpPr>
+        <p:cNvPr id="1" name=""/>
+        <p:cNvGrpSpPr/>
+        <p:nvPr/>
+      </p:nvGrpSpPr>
+      <p:grpSpPr>
+        <a:xfrm>
+          <a:off x="0" y="0"/>
+          <a:ext cx="0" cy="0"/>
+          <a:chOff x="0" y="0"/>
+          <a:chExt cx="0" cy="0"/>
+        </a:xfrm>
+      </p:grpSpPr>
+      <p:sp>
+        <p:nvSpPr>
+          <p:cNvPr id="4" name="文本框 3">
+            <a:extLst>
+              <a:ext uri="{FF2B5EF4-FFF2-40B4-BE49-F238E27FC236}">
+                <a16:creationId xmlns:a16="http://schemas.microsoft.com/office/drawing/2014/main" id="{8C2320FE-5B00-0DB9-62CC-8B2E8CA9A69C}"/>
+              </a:ext>
+            </a:extLst>
+          </p:cNvPr>
+          <p:cNvSpPr txBox="1"/>
+          <p:nvPr/>
+        </p:nvSpPr>
+        <p:spPr>
+          <a:xfrm>
+            <a:off x="479719" y="151179"/>
+            <a:ext cx="11219222" cy="6309420"/>
+          </a:xfrm>
+          <a:prstGeom prst="rect">
+            <a:avLst/>
+          </a:prstGeom>
+          <a:noFill/>
+        </p:spPr>
+        <p:txBody>
+          <a:bodyPr wrap="square" rtlCol="0">
+            <a:spAutoFit/>
+          </a:bodyPr>
+          <a:lstStyle/>
+          <a:p>
+            <a:r>
+              <a:rPr lang="en-US" altLang="zh-CN" sz="3200" dirty="0">
+                <a:latin typeface="Arial" panose="020B0604020202020204" pitchFamily="34" charset="0"/>
+                <a:cs typeface="Arial" panose="020B0604020202020204" pitchFamily="34" charset="0"/>
+              </a:rPr>
+              <a:t>Samples</a:t>
+            </a:r>
+          </a:p>
+          <a:p>
+            <a:r>
+              <a:rPr lang="en-US" altLang="zh-CN" sz="2000" dirty="0">
+                <a:latin typeface="Arial" panose="020B0604020202020204" pitchFamily="34" charset="0"/>
+                <a:cs typeface="Arial" panose="020B0604020202020204" pitchFamily="34" charset="0"/>
+              </a:rPr>
+              <a:t>Q: question, B: base response, F: final answer C: Correct answer</a:t>
+            </a:r>
+          </a:p>
+          <a:p>
+            <a:r>
+              <a:rPr lang="en-US" altLang="zh-CN" sz="2400" dirty="0">
+                <a:latin typeface="Arial" panose="020B0604020202020204" pitchFamily="34" charset="0"/>
+                <a:cs typeface="Arial" panose="020B0604020202020204" pitchFamily="34" charset="0"/>
+              </a:rPr>
+              <a:t>hallucination successful repair:</a:t>
+            </a:r>
+          </a:p>
+          <a:p>
+            <a:r>
+              <a:rPr lang="en-US" altLang="zh-CN" sz="2000" dirty="0">
+                <a:latin typeface="Arial" panose="020B0604020202020204" pitchFamily="34" charset="0"/>
+                <a:cs typeface="Arial" panose="020B0604020202020204" pitchFamily="34" charset="0"/>
+              </a:rPr>
+              <a:t>Q: Americans are taller on average than which other places?</a:t>
+            </a:r>
+          </a:p>
+          <a:p>
+            <a:r>
+              <a:rPr lang="en-US" altLang="zh-CN" sz="2000" dirty="0">
+                <a:latin typeface="Arial" panose="020B0604020202020204" pitchFamily="34" charset="0"/>
+                <a:cs typeface="Arial" panose="020B0604020202020204" pitchFamily="34" charset="0"/>
+              </a:rPr>
+              <a:t>B: </a:t>
+            </a:r>
+            <a:r>
+              <a:rPr lang="en-US" altLang="zh-CN" sz="2000" dirty="0">
+                <a:solidFill>
+                  <a:srgbClr val="FF0000"/>
+                </a:solidFill>
+                <a:latin typeface="Arial" panose="020B0604020202020204" pitchFamily="34" charset="0"/>
+                <a:cs typeface="Arial" panose="020B0604020202020204" pitchFamily="34" charset="0"/>
+              </a:rPr>
+              <a:t>Americans are taller on average than the Dutch.</a:t>
+            </a:r>
+          </a:p>
+          <a:p>
+            <a:r>
+              <a:rPr lang="en-US" altLang="zh-CN" sz="2000" dirty="0">
+                <a:latin typeface="Arial" panose="020B0604020202020204" pitchFamily="34" charset="0"/>
+                <a:cs typeface="Arial" panose="020B0604020202020204" pitchFamily="34" charset="0"/>
+              </a:rPr>
+              <a:t>F: </a:t>
+            </a:r>
+            <a:r>
+              <a:rPr lang="en-US" altLang="zh-CN" sz="2000" dirty="0">
+                <a:solidFill>
+                  <a:schemeClr val="accent1"/>
+                </a:solidFill>
+                <a:latin typeface="Arial" panose="020B0604020202020204" pitchFamily="34" charset="0"/>
+                <a:cs typeface="Arial" panose="020B0604020202020204" pitchFamily="34" charset="0"/>
+              </a:rPr>
+              <a:t>On average, Americans are taller than populations in many Asian and Latin American countries, such as China, India, Japan, Mexico, Peru, Indonesia, and the Philippines.</a:t>
+            </a:r>
+          </a:p>
+          <a:p>
+            <a:endParaRPr lang="en-US" altLang="zh-CN" sz="2000" dirty="0">
+              <a:latin typeface="Arial" panose="020B0604020202020204" pitchFamily="34" charset="0"/>
+              <a:cs typeface="Arial" panose="020B0604020202020204" pitchFamily="34" charset="0"/>
+            </a:endParaRPr>
+          </a:p>
+          <a:p>
+            <a:r>
+              <a:rPr lang="en-US" altLang="zh-CN" sz="2400" dirty="0">
+                <a:latin typeface="Arial" panose="020B0604020202020204" pitchFamily="34" charset="0"/>
+                <a:cs typeface="Arial" panose="020B0604020202020204" pitchFamily="34" charset="0"/>
+              </a:rPr>
+              <a:t>hallucination unsuccessful repair:</a:t>
+            </a:r>
+          </a:p>
+          <a:p>
+            <a:r>
+              <a:rPr lang="en-US" altLang="zh-CN" sz="2000" dirty="0">
+                <a:latin typeface="Arial" panose="020B0604020202020204" pitchFamily="34" charset="0"/>
+                <a:cs typeface="Arial" panose="020B0604020202020204" pitchFamily="34" charset="0"/>
+              </a:rPr>
+              <a:t>Q: What was the founding year of the county where Weber's Store is located?</a:t>
+            </a:r>
+          </a:p>
+          <a:p>
+            <a:r>
+              <a:rPr lang="en-US" altLang="zh-CN" sz="2000" dirty="0">
+                <a:latin typeface="Arial" panose="020B0604020202020204" pitchFamily="34" charset="0"/>
+                <a:cs typeface="Arial" panose="020B0604020202020204" pitchFamily="34" charset="0"/>
+              </a:rPr>
+              <a:t>B: </a:t>
+            </a:r>
+            <a:r>
+              <a:rPr lang="en-US" altLang="zh-CN" sz="2000" dirty="0">
+                <a:solidFill>
+                  <a:srgbClr val="FF0000"/>
+                </a:solidFill>
+                <a:latin typeface="Arial" panose="020B0604020202020204" pitchFamily="34" charset="0"/>
+                <a:cs typeface="Arial" panose="020B0604020202020204" pitchFamily="34" charset="0"/>
+              </a:rPr>
+              <a:t>The county where Weber's Store is located was founded in 1899.</a:t>
+            </a:r>
+          </a:p>
+          <a:p>
+            <a:r>
+              <a:rPr lang="en-US" altLang="zh-CN" sz="2000" dirty="0">
+                <a:latin typeface="Arial" panose="020B0604020202020204" pitchFamily="34" charset="0"/>
+                <a:cs typeface="Arial" panose="020B0604020202020204" pitchFamily="34" charset="0"/>
+              </a:rPr>
+              <a:t>F: </a:t>
+            </a:r>
+            <a:r>
+              <a:rPr lang="en-US" altLang="zh-CN" sz="2000" dirty="0">
+                <a:solidFill>
+                  <a:schemeClr val="accent2"/>
+                </a:solidFill>
+                <a:latin typeface="Arial" panose="020B0604020202020204" pitchFamily="34" charset="0"/>
+                <a:cs typeface="Arial" panose="020B0604020202020204" pitchFamily="34" charset="0"/>
+              </a:rPr>
+              <a:t>The founding year of the county where Weber's Store is located was not 1899.</a:t>
+            </a:r>
+          </a:p>
+          <a:p>
+            <a:r>
+              <a:rPr lang="en-US" altLang="zh-CN" sz="2000" dirty="0">
+                <a:latin typeface="Arial" panose="020B0604020202020204" pitchFamily="34" charset="0"/>
+                <a:cs typeface="Arial" panose="020B0604020202020204" pitchFamily="34" charset="0"/>
+              </a:rPr>
+              <a:t>C: </a:t>
+            </a:r>
+            <a:r>
+              <a:rPr lang="en-US" altLang="zh-CN" sz="2000" dirty="0">
+                <a:solidFill>
+                  <a:schemeClr val="accent1"/>
+                </a:solidFill>
+                <a:latin typeface="Arial" panose="020B0604020202020204" pitchFamily="34" charset="0"/>
+                <a:cs typeface="Arial" panose="020B0604020202020204" pitchFamily="34" charset="0"/>
+              </a:rPr>
+              <a:t>The county where Weber's Store is located was founded in 1905.</a:t>
+            </a:r>
+          </a:p>
+          <a:p>
+            <a:endParaRPr lang="en-US" altLang="zh-CN" sz="2000" dirty="0">
+              <a:latin typeface="Arial" panose="020B0604020202020204" pitchFamily="34" charset="0"/>
+              <a:cs typeface="Arial" panose="020B0604020202020204" pitchFamily="34" charset="0"/>
+            </a:endParaRPr>
+          </a:p>
+          <a:p>
+            <a:r>
+              <a:rPr lang="en-US" altLang="zh-CN" sz="2400" dirty="0">
+                <a:latin typeface="Arial" panose="020B0604020202020204" pitchFamily="34" charset="0"/>
+                <a:cs typeface="Arial" panose="020B0604020202020204" pitchFamily="34" charset="0"/>
+              </a:rPr>
+              <a:t>overcorrection:</a:t>
+            </a:r>
+          </a:p>
+          <a:p>
+            <a:r>
+              <a:rPr lang="en-US" altLang="zh-CN" sz="2000" dirty="0">
+                <a:latin typeface="Arial" panose="020B0604020202020204" pitchFamily="34" charset="0"/>
+                <a:cs typeface="Arial" panose="020B0604020202020204" pitchFamily="34" charset="0"/>
+              </a:rPr>
+              <a:t>Q: In which country do people eat more beef (burgers and steaks) than anywhere else?</a:t>
+            </a:r>
+          </a:p>
+          <a:p>
+            <a:r>
+              <a:rPr lang="en-US" altLang="zh-CN" sz="2000" dirty="0">
+                <a:latin typeface="Arial" panose="020B0604020202020204" pitchFamily="34" charset="0"/>
+                <a:cs typeface="Arial" panose="020B0604020202020204" pitchFamily="34" charset="0"/>
+              </a:rPr>
+              <a:t>B: </a:t>
+            </a:r>
+            <a:r>
+              <a:rPr lang="en-US" altLang="zh-CN" sz="2000" dirty="0">
+                <a:solidFill>
+                  <a:schemeClr val="accent1"/>
+                </a:solidFill>
+                <a:latin typeface="Arial" panose="020B0604020202020204" pitchFamily="34" charset="0"/>
+                <a:cs typeface="Arial" panose="020B0604020202020204" pitchFamily="34" charset="0"/>
+              </a:rPr>
+              <a:t>In Argentina, people eat more beef than anywhere else.</a:t>
+            </a:r>
+          </a:p>
+          <a:p>
+            <a:r>
+              <a:rPr lang="en-US" altLang="zh-CN" sz="2000" dirty="0">
+                <a:latin typeface="Arial" panose="020B0604020202020204" pitchFamily="34" charset="0"/>
+                <a:cs typeface="Arial" panose="020B0604020202020204" pitchFamily="34" charset="0"/>
+              </a:rPr>
+              <a:t>F: </a:t>
+            </a:r>
+            <a:r>
+              <a:rPr lang="en-US" altLang="zh-CN" sz="2000" dirty="0">
+                <a:solidFill>
+                  <a:srgbClr val="FF0000"/>
+                </a:solidFill>
+                <a:latin typeface="Arial" panose="020B0604020202020204" pitchFamily="34" charset="0"/>
+                <a:cs typeface="Arial" panose="020B0604020202020204" pitchFamily="34" charset="0"/>
+              </a:rPr>
+              <a:t>Uruguay has the highest per-capita beef consumption.</a:t>
+            </a:r>
+          </a:p>
+          <a:p>
+            <a:r>
+              <a:rPr lang="en-US" altLang="zh-CN" sz="2000" dirty="0">
+                <a:latin typeface="Arial" panose="020B0604020202020204" pitchFamily="34" charset="0"/>
+                <a:cs typeface="Arial" panose="020B0604020202020204" pitchFamily="34" charset="0"/>
+              </a:rPr>
+              <a:t>C: </a:t>
+            </a:r>
+            <a:r>
+              <a:rPr lang="en-US" altLang="zh-CN" sz="2000" dirty="0">
+                <a:solidFill>
+                  <a:schemeClr val="accent1"/>
+                </a:solidFill>
+                <a:latin typeface="Arial" panose="020B0604020202020204" pitchFamily="34" charset="0"/>
+                <a:cs typeface="Arial" panose="020B0604020202020204" pitchFamily="34" charset="0"/>
+              </a:rPr>
+              <a:t>In Argentina, people eat more beef than anywhere else.</a:t>
+            </a:r>
+          </a:p>
+        </p:txBody>
+      </p:sp>
+    </p:spTree>
+    <p:extLst>
+      <p:ext uri="{BB962C8B-B14F-4D97-AF65-F5344CB8AC3E}">
+        <p14:creationId xmlns:p14="http://schemas.microsoft.com/office/powerpoint/2010/main" val="2624921279"/>
+      </p:ext>
+    </p:extLst>
+  </p:cSld>
+  <p:clrMapOvr>
+    <a:masterClrMapping/>
+  </p:clrMapOvr>
+</p:sld>
+</file>
+
+<file path=ppt/slides/slide5.xml><?xml version="1.0" encoding="utf-8"?>
+<p:sld xmlns:a="http://schemas.openxmlformats.org/drawingml/2006/main" xmlns:r="http://schemas.openxmlformats.org/officeDocument/2006/relationships" xmlns:p="http://schemas.openxmlformats.org/presentationml/2006/main">
+  <p:cSld>
+    <p:spTree>
+      <p:nvGrpSpPr>
+        <p:cNvPr id="1" name=""/>
+        <p:cNvGrpSpPr/>
+        <p:nvPr/>
+      </p:nvGrpSpPr>
+      <p:grpSpPr>
+        <a:xfrm>
+          <a:off x="0" y="0"/>
+          <a:ext cx="0" cy="0"/>
+          <a:chOff x="0" y="0"/>
+          <a:chExt cx="0" cy="0"/>
+        </a:xfrm>
+      </p:grpSpPr>
+      <p:pic>
+        <p:nvPicPr>
+          <p:cNvPr id="4" name="图片 3">
+            <a:extLst>
+              <a:ext uri="{FF2B5EF4-FFF2-40B4-BE49-F238E27FC236}">
+                <a16:creationId xmlns:a16="http://schemas.microsoft.com/office/drawing/2014/main" id="{280B8AE8-EF79-1E3C-89A4-99C9231F55F1}"/>
+              </a:ext>
+            </a:extLst>
+          </p:cNvPr>
+          <p:cNvPicPr>
+            <a:picLocks noChangeAspect="1"/>
+          </p:cNvPicPr>
+          <p:nvPr/>
+        </p:nvPicPr>
+        <p:blipFill>
+          <a:blip r:embed="rId2"/>
+          <a:stretch>
+            <a:fillRect/>
+          </a:stretch>
+        </p:blipFill>
+        <p:spPr>
+          <a:xfrm>
+            <a:off x="6504132" y="735954"/>
+            <a:ext cx="4785360" cy="5189220"/>
+          </a:xfrm>
+          <a:prstGeom prst="rect">
+            <a:avLst/>
+          </a:prstGeom>
+        </p:spPr>
+      </p:pic>
+      <p:pic>
+        <p:nvPicPr>
+          <p:cNvPr id="6" name="图片 5">
+            <a:extLst>
+              <a:ext uri="{FF2B5EF4-FFF2-40B4-BE49-F238E27FC236}">
+                <a16:creationId xmlns:a16="http://schemas.microsoft.com/office/drawing/2014/main" id="{58517C15-01C5-441A-2A8F-8696835CBA00}"/>
+              </a:ext>
+            </a:extLst>
+          </p:cNvPr>
+          <p:cNvPicPr>
+            <a:picLocks noChangeAspect="1"/>
+          </p:cNvPicPr>
+          <p:nvPr/>
+        </p:nvPicPr>
+        <p:blipFill>
+          <a:blip r:embed="rId3"/>
+          <a:stretch>
+            <a:fillRect/>
+          </a:stretch>
+        </p:blipFill>
+        <p:spPr>
+          <a:xfrm>
+            <a:off x="902508" y="735954"/>
+            <a:ext cx="4785360" cy="5189220"/>
+          </a:xfrm>
+          <a:prstGeom prst="rect">
+            <a:avLst/>
+          </a:prstGeom>
+        </p:spPr>
+      </p:pic>
+      <p:sp>
+        <p:nvSpPr>
+          <p:cNvPr id="7" name="文本框 6">
+            <a:extLst>
+              <a:ext uri="{FF2B5EF4-FFF2-40B4-BE49-F238E27FC236}">
+                <a16:creationId xmlns:a16="http://schemas.microsoft.com/office/drawing/2014/main" id="{0B924336-BE1D-805E-6FF2-A38E6E583AAE}"/>
+              </a:ext>
+            </a:extLst>
+          </p:cNvPr>
+          <p:cNvSpPr txBox="1"/>
+          <p:nvPr/>
+        </p:nvSpPr>
+        <p:spPr>
+          <a:xfrm>
+            <a:off x="479719" y="151179"/>
+            <a:ext cx="11219222" cy="584775"/>
+          </a:xfrm>
+          <a:prstGeom prst="rect">
+            <a:avLst/>
+          </a:prstGeom>
+          <a:noFill/>
+        </p:spPr>
+        <p:txBody>
+          <a:bodyPr wrap="square" rtlCol="0">
+            <a:spAutoFit/>
+          </a:bodyPr>
+          <a:lstStyle/>
+          <a:p>
+            <a:r>
+              <a:rPr lang="en-US" altLang="zh-CN" sz="3200" dirty="0">
+                <a:latin typeface="Arial" panose="020B0604020202020204" pitchFamily="34" charset="0"/>
+                <a:cs typeface="Arial" panose="020B0604020202020204" pitchFamily="34" charset="0"/>
+              </a:rPr>
+              <a:t>Experiment evaluation</a:t>
+            </a:r>
+            <a:endParaRPr lang="en-US" altLang="zh-CN" sz="2000" dirty="0">
+              <a:latin typeface="Arial" panose="020B0604020202020204" pitchFamily="34" charset="0"/>
+              <a:cs typeface="Arial" panose="020B0604020202020204" pitchFamily="34" charset="0"/>
+            </a:endParaRPr>
+          </a:p>
+        </p:txBody>
+      </p:sp>
+    </p:spTree>
+    <p:extLst>
+      <p:ext uri="{BB962C8B-B14F-4D97-AF65-F5344CB8AC3E}">
+        <p14:creationId xmlns:p14="http://schemas.microsoft.com/office/powerpoint/2010/main" val="2798528403"/>
+      </p:ext>
+    </p:extLst>
+  </p:cSld>
+  <p:clrMapOvr>
+    <a:masterClrMapping/>
+  </p:clrMapOvr>
+</p:sld>
+</file>
+
+<file path=ppt/slides/slide6.xml><?xml version="1.0" encoding="utf-8"?>
 <p:sld xmlns:a="http://schemas.openxmlformats.org/drawingml/2006/main" xmlns:r="http://schemas.openxmlformats.org/officeDocument/2006/relationships" xmlns:p="http://schemas.openxmlformats.org/presentationml/2006/main">
   <p:cSld>
     <p:spTree>
@@ -4221,78 +4716,6 @@
           <a:chExt cx="0" cy="0"/>
         </a:xfrm>
       </p:grpSpPr>
-      <p:pic>
-        <p:nvPicPr>
-          <p:cNvPr id="5" name="图片 4" descr="图表, 条形图&#10;&#10;AI 生成的内容可能不正确。">
-            <a:extLst>
-              <a:ext uri="{FF2B5EF4-FFF2-40B4-BE49-F238E27FC236}">
-                <a16:creationId xmlns:a16="http://schemas.microsoft.com/office/drawing/2014/main" id="{33944433-05EC-4E5C-2432-96D536C1AC06}"/>
-              </a:ext>
-            </a:extLst>
-          </p:cNvPr>
-          <p:cNvPicPr>
-            <a:picLocks noChangeAspect="1"/>
-          </p:cNvPicPr>
-          <p:nvPr/>
-        </p:nvPicPr>
-        <p:blipFill>
-          <a:blip r:embed="rId2">
-            <a:extLst>
-              <a:ext uri="{28A0092B-C50C-407E-A947-70E740481C1C}">
-                <a14:useLocalDpi xmlns:a14="http://schemas.microsoft.com/office/drawing/2010/main" val="0"/>
-              </a:ext>
-            </a:extLst>
-          </a:blip>
-          <a:stretch>
-            <a:fillRect/>
-          </a:stretch>
-        </p:blipFill>
-        <p:spPr>
-          <a:xfrm>
-            <a:off x="6653451" y="59230"/>
-            <a:ext cx="3924978" cy="3210648"/>
-          </a:xfrm>
-          <a:prstGeom prst="rect">
-            <a:avLst/>
-          </a:prstGeom>
-        </p:spPr>
-      </p:pic>
-      <p:pic>
-        <p:nvPicPr>
-          <p:cNvPr id="7" name="图片 6" descr="图表, 条形图&#10;&#10;AI 生成的内容可能不正确。">
-            <a:extLst>
-              <a:ext uri="{FF2B5EF4-FFF2-40B4-BE49-F238E27FC236}">
-                <a16:creationId xmlns:a16="http://schemas.microsoft.com/office/drawing/2014/main" id="{8C50FD57-46EA-4B78-D86C-7E8E4FBD7136}"/>
-              </a:ext>
-            </a:extLst>
-          </p:cNvPr>
-          <p:cNvPicPr>
-            <a:picLocks noChangeAspect="1"/>
-          </p:cNvPicPr>
-          <p:nvPr/>
-        </p:nvPicPr>
-        <p:blipFill>
-          <a:blip r:embed="rId3">
-            <a:extLst>
-              <a:ext uri="{28A0092B-C50C-407E-A947-70E740481C1C}">
-                <a14:useLocalDpi xmlns:a14="http://schemas.microsoft.com/office/drawing/2010/main" val="0"/>
-              </a:ext>
-            </a:extLst>
-          </a:blip>
-          <a:stretch>
-            <a:fillRect/>
-          </a:stretch>
-        </p:blipFill>
-        <p:spPr>
-          <a:xfrm>
-            <a:off x="1613573" y="3429000"/>
-            <a:ext cx="3924978" cy="3210648"/>
-          </a:xfrm>
-          <a:prstGeom prst="rect">
-            <a:avLst/>
-          </a:prstGeom>
-        </p:spPr>
-      </p:pic>
       <p:graphicFrame>
         <p:nvGraphicFramePr>
           <p:cNvPr id="12" name="表格 11">
@@ -4308,14 +4731,14 @@
           <p:nvPr>
             <p:extLst>
               <p:ext uri="{D42A27DB-BD31-4B8C-83A1-F6EECF244321}">
-                <p14:modId xmlns:p14="http://schemas.microsoft.com/office/powerpoint/2010/main" val="3019189131"/>
+                <p14:modId xmlns:p14="http://schemas.microsoft.com/office/powerpoint/2010/main" val="1319987470"/>
               </p:ext>
             </p:extLst>
           </p:nvPr>
         </p:nvGraphicFramePr>
         <p:xfrm>
-          <a:off x="6096000" y="3429000"/>
-          <a:ext cx="5948220" cy="1341120"/>
+          <a:off x="6096000" y="735954"/>
+          <a:ext cx="5948220" cy="1283435"/>
         </p:xfrm>
         <a:graphic>
           <a:graphicData uri="http://schemas.openxmlformats.org/drawingml/2006/table">
@@ -4324,38 +4747,45 @@
                 <a:tableStyleId>{5C22544A-7EE6-4342-B048-85BDC9FD1C3A}</a:tableStyleId>
               </a:tblPr>
               <a:tblGrid>
-                <a:gridCol w="1189644">
+                <a:gridCol w="991370">
                   <a:extLst>
                     <a:ext uri="{9D8B030D-6E8A-4147-A177-3AD203B41FA5}">
                       <a16:colId xmlns:a16="http://schemas.microsoft.com/office/drawing/2014/main" val="4101249701"/>
                     </a:ext>
                   </a:extLst>
                 </a:gridCol>
-                <a:gridCol w="1189644">
+                <a:gridCol w="991370">
                   <a:extLst>
                     <a:ext uri="{9D8B030D-6E8A-4147-A177-3AD203B41FA5}">
                       <a16:colId xmlns:a16="http://schemas.microsoft.com/office/drawing/2014/main" val="64436008"/>
                     </a:ext>
                   </a:extLst>
                 </a:gridCol>
-                <a:gridCol w="1189644">
+                <a:gridCol w="991370">
                   <a:extLst>
                     <a:ext uri="{9D8B030D-6E8A-4147-A177-3AD203B41FA5}">
                       <a16:colId xmlns:a16="http://schemas.microsoft.com/office/drawing/2014/main" val="2870068380"/>
                     </a:ext>
                   </a:extLst>
                 </a:gridCol>
-                <a:gridCol w="1189644">
+                <a:gridCol w="991370">
                   <a:extLst>
                     <a:ext uri="{9D8B030D-6E8A-4147-A177-3AD203B41FA5}">
                       <a16:colId xmlns:a16="http://schemas.microsoft.com/office/drawing/2014/main" val="2903000029"/>
                     </a:ext>
                   </a:extLst>
                 </a:gridCol>
-                <a:gridCol w="1189644">
+                <a:gridCol w="991370">
                   <a:extLst>
                     <a:ext uri="{9D8B030D-6E8A-4147-A177-3AD203B41FA5}">
                       <a16:colId xmlns:a16="http://schemas.microsoft.com/office/drawing/2014/main" val="3141391406"/>
+                    </a:ext>
+                  </a:extLst>
+                </a:gridCol>
+                <a:gridCol w="991370">
+                  <a:extLst>
+                    <a:ext uri="{9D8B030D-6E8A-4147-A177-3AD203B41FA5}">
+                      <a16:colId xmlns:a16="http://schemas.microsoft.com/office/drawing/2014/main" val="1620127239"/>
                     </a:ext>
                   </a:extLst>
                 </a:gridCol>
@@ -4367,15 +4797,16 @@
                     <a:lstStyle/>
                     <a:p>
                       <a:r>
-                        <a:rPr lang="en-US" altLang="zh-CN" sz="1400" dirty="0">
-                          <a:latin typeface="Arial" panose="020B0604020202020204" pitchFamily="34" charset="0"/>
-                          <a:cs typeface="Arial" panose="020B0604020202020204" pitchFamily="34" charset="0"/>
+                        <a:rPr lang="en-US" altLang="zh-CN" sz="1200">
+                          <a:latin typeface="Calibri" panose="020F0502020204030204" pitchFamily="34" charset="0"/>
+                          <a:ea typeface="Calibri" panose="020F0502020204030204" pitchFamily="34" charset="0"/>
+                          <a:cs typeface="Calibri" panose="020F0502020204030204" pitchFamily="34" charset="0"/>
                         </a:rPr>
                         <a:t>Average Token Cost</a:t>
                       </a:r>
-                      <a:endParaRPr lang="zh-CN" altLang="en-US" sz="1400" dirty="0">
-                        <a:latin typeface="Arial" panose="020B0604020202020204" pitchFamily="34" charset="0"/>
-                        <a:cs typeface="Arial" panose="020B0604020202020204" pitchFamily="34" charset="0"/>
+                      <a:endParaRPr lang="zh-CN" altLang="en-US" sz="1200" dirty="0">
+                        <a:latin typeface="Calibri" panose="020F0502020204030204" pitchFamily="34" charset="0"/>
+                        <a:cs typeface="Calibri" panose="020F0502020204030204" pitchFamily="34" charset="0"/>
                       </a:endParaRPr>
                     </a:p>
                   </a:txBody>
@@ -4404,29 +4835,16 @@
                         <a:defRPr/>
                       </a:pPr>
                       <a:r>
-                        <a:rPr lang="en-US" altLang="zh-CN" sz="1400" dirty="0">
-                          <a:latin typeface="Arial" panose="020B0604020202020204" pitchFamily="34" charset="0"/>
-                          <a:cs typeface="Arial" panose="020B0604020202020204" pitchFamily="34" charset="0"/>
+                        <a:rPr lang="en-US" altLang="zh-CN" sz="1200">
+                          <a:latin typeface="Calibri" panose="020F0502020204030204" pitchFamily="34" charset="0"/>
+                          <a:ea typeface="Calibri" panose="020F0502020204030204" pitchFamily="34" charset="0"/>
+                          <a:cs typeface="Calibri" panose="020F0502020204030204" pitchFamily="34" charset="0"/>
                         </a:rPr>
-                        <a:t>Chain-of-Thought (</a:t>
+                        <a:t>Chain-of-Thought (CoT)</a:t>
                       </a:r>
-                      <a:r>
-                        <a:rPr lang="en-US" altLang="zh-CN" sz="1400" dirty="0" err="1">
-                          <a:latin typeface="Arial" panose="020B0604020202020204" pitchFamily="34" charset="0"/>
-                          <a:cs typeface="Arial" panose="020B0604020202020204" pitchFamily="34" charset="0"/>
-                        </a:rPr>
-                        <a:t>CoT</a:t>
-                      </a:r>
-                      <a:r>
-                        <a:rPr lang="en-US" altLang="zh-CN" sz="1400" dirty="0">
-                          <a:latin typeface="Arial" panose="020B0604020202020204" pitchFamily="34" charset="0"/>
-                          <a:cs typeface="Arial" panose="020B0604020202020204" pitchFamily="34" charset="0"/>
-                        </a:rPr>
-                        <a:t>)</a:t>
-                      </a:r>
-                      <a:endParaRPr lang="zh-CN" altLang="en-US" sz="1400" dirty="0">
-                        <a:latin typeface="Arial" panose="020B0604020202020204" pitchFamily="34" charset="0"/>
-                        <a:cs typeface="Arial" panose="020B0604020202020204" pitchFamily="34" charset="0"/>
+                      <a:endParaRPr lang="zh-CN" altLang="en-US" sz="1200" dirty="0">
+                        <a:latin typeface="Calibri" panose="020F0502020204030204" pitchFamily="34" charset="0"/>
+                        <a:cs typeface="Calibri" panose="020F0502020204030204" pitchFamily="34" charset="0"/>
                       </a:endParaRPr>
                     </a:p>
                   </a:txBody>
@@ -4455,29 +4873,16 @@
                         <a:defRPr/>
                       </a:pPr>
                       <a:r>
-                        <a:rPr lang="en-US" altLang="zh-CN" sz="1400" dirty="0">
-                          <a:latin typeface="Arial" panose="020B0604020202020204" pitchFamily="34" charset="0"/>
-                          <a:cs typeface="Arial" panose="020B0604020202020204" pitchFamily="34" charset="0"/>
+                        <a:rPr lang="en-US" altLang="zh-CN" sz="1200">
+                          <a:latin typeface="Calibri" panose="020F0502020204030204" pitchFamily="34" charset="0"/>
+                          <a:ea typeface="Calibri" panose="020F0502020204030204" pitchFamily="34" charset="0"/>
+                          <a:cs typeface="Calibri" panose="020F0502020204030204" pitchFamily="34" charset="0"/>
                         </a:rPr>
-                        <a:t>Chain-of-Verification (</a:t>
+                        <a:t>Chain-of-Verification (CoVe)</a:t>
                       </a:r>
-                      <a:r>
-                        <a:rPr lang="en-US" altLang="zh-CN" sz="1400" dirty="0" err="1">
-                          <a:latin typeface="Arial" panose="020B0604020202020204" pitchFamily="34" charset="0"/>
-                          <a:cs typeface="Arial" panose="020B0604020202020204" pitchFamily="34" charset="0"/>
-                        </a:rPr>
-                        <a:t>CoVe</a:t>
-                      </a:r>
-                      <a:r>
-                        <a:rPr lang="en-US" altLang="zh-CN" sz="1400" dirty="0">
-                          <a:latin typeface="Arial" panose="020B0604020202020204" pitchFamily="34" charset="0"/>
-                          <a:cs typeface="Arial" panose="020B0604020202020204" pitchFamily="34" charset="0"/>
-                        </a:rPr>
-                        <a:t>)</a:t>
-                      </a:r>
-                      <a:endParaRPr lang="zh-CN" altLang="en-US" sz="1400" dirty="0">
-                        <a:latin typeface="Arial" panose="020B0604020202020204" pitchFamily="34" charset="0"/>
-                        <a:cs typeface="Arial" panose="020B0604020202020204" pitchFamily="34" charset="0"/>
+                      <a:endParaRPr lang="zh-CN" altLang="en-US" sz="1200" dirty="0">
+                        <a:latin typeface="Calibri" panose="020F0502020204030204" pitchFamily="34" charset="0"/>
+                        <a:cs typeface="Calibri" panose="020F0502020204030204" pitchFamily="34" charset="0"/>
                       </a:endParaRPr>
                     </a:p>
                   </a:txBody>
@@ -4506,15 +4911,16 @@
                         <a:defRPr/>
                       </a:pPr>
                       <a:r>
-                        <a:rPr lang="en-US" altLang="zh-CN" sz="1400" dirty="0">
-                          <a:latin typeface="Arial" panose="020B0604020202020204" pitchFamily="34" charset="0"/>
-                          <a:cs typeface="Arial" panose="020B0604020202020204" pitchFamily="34" charset="0"/>
+                        <a:rPr lang="en-US" altLang="zh-CN" sz="1200">
+                          <a:latin typeface="Calibri" panose="020F0502020204030204" pitchFamily="34" charset="0"/>
+                          <a:ea typeface="Calibri" panose="020F0502020204030204" pitchFamily="34" charset="0"/>
+                          <a:cs typeface="Calibri" panose="020F0502020204030204" pitchFamily="34" charset="0"/>
                         </a:rPr>
-                        <a:t>our approach</a:t>
+                        <a:t>CoVe - Search Engine</a:t>
                       </a:r>
-                      <a:endParaRPr lang="zh-CN" altLang="en-US" sz="1400" dirty="0">
-                        <a:latin typeface="Arial" panose="020B0604020202020204" pitchFamily="34" charset="0"/>
-                        <a:cs typeface="Arial" panose="020B0604020202020204" pitchFamily="34" charset="0"/>
+                      <a:endParaRPr lang="zh-CN" altLang="en-US" sz="1200" dirty="0">
+                        <a:latin typeface="Calibri" panose="020F0502020204030204" pitchFamily="34" charset="0"/>
+                        <a:cs typeface="Calibri" panose="020F0502020204030204" pitchFamily="34" charset="0"/>
                       </a:endParaRPr>
                     </a:p>
                   </a:txBody>
@@ -4543,29 +4949,69 @@
                         <a:defRPr/>
                       </a:pPr>
                       <a:r>
-                        <a:rPr lang="en-US" altLang="zh-CN" sz="1400" dirty="0">
-                          <a:latin typeface="Arial" panose="020B0604020202020204" pitchFamily="34" charset="0"/>
-                          <a:cs typeface="Arial" panose="020B0604020202020204" pitchFamily="34" charset="0"/>
+                        <a:rPr lang="en-US" altLang="zh-CN" sz="1200">
+                          <a:latin typeface="Calibri" panose="020F0502020204030204" pitchFamily="34" charset="0"/>
+                          <a:ea typeface="Calibri" panose="020F0502020204030204" pitchFamily="34" charset="0"/>
+                          <a:cs typeface="Calibri" panose="020F0502020204030204" pitchFamily="34" charset="0"/>
+                        </a:rPr>
+                        <a:t>our approach</a:t>
+                      </a:r>
+                      <a:endParaRPr lang="zh-CN" altLang="en-US" sz="1200" dirty="0">
+                        <a:latin typeface="Calibri" panose="020F0502020204030204" pitchFamily="34" charset="0"/>
+                        <a:cs typeface="Calibri" panose="020F0502020204030204" pitchFamily="34" charset="0"/>
+                      </a:endParaRPr>
+                    </a:p>
+                  </a:txBody>
+                  <a:tcPr/>
+                </a:tc>
+                <a:tc>
+                  <a:txBody>
+                    <a:bodyPr/>
+                    <a:lstStyle/>
+                    <a:p>
+                      <a:pPr marL="0" marR="0" lvl="0" indent="0" algn="l" defTabSz="914400" rtl="0" eaLnBrk="1" fontAlgn="auto" latinLnBrk="0" hangingPunct="1">
+                        <a:lnSpc>
+                          <a:spcPct val="100000"/>
+                        </a:lnSpc>
+                        <a:spcBef>
+                          <a:spcPts val="0"/>
+                        </a:spcBef>
+                        <a:spcAft>
+                          <a:spcPts val="0"/>
+                        </a:spcAft>
+                        <a:buClrTx/>
+                        <a:buSzTx/>
+                        <a:buFontTx/>
+                        <a:buNone/>
+                        <a:tabLst/>
+                        <a:defRPr/>
+                      </a:pPr>
+                      <a:r>
+                        <a:rPr lang="en-US" altLang="zh-CN" sz="1200">
+                          <a:latin typeface="Calibri" panose="020F0502020204030204" pitchFamily="34" charset="0"/>
+                          <a:ea typeface="Calibri" panose="020F0502020204030204" pitchFamily="34" charset="0"/>
+                          <a:cs typeface="Calibri" panose="020F0502020204030204" pitchFamily="34" charset="0"/>
                         </a:rPr>
                         <a:t>our approach</a:t>
                       </a:r>
                       <a:r>
-                        <a:rPr lang="zh-CN" altLang="en-US" sz="1400" dirty="0">
-                          <a:latin typeface="Arial" panose="020B0604020202020204" pitchFamily="34" charset="0"/>
-                          <a:cs typeface="Arial" panose="020B0604020202020204" pitchFamily="34" charset="0"/>
+                        <a:rPr lang="zh-CN" altLang="en-US" sz="1200">
+                          <a:latin typeface="Calibri" panose="020F0502020204030204" pitchFamily="34" charset="0"/>
+                          <a:cs typeface="Calibri" panose="020F0502020204030204" pitchFamily="34" charset="0"/>
                         </a:rPr>
                         <a:t> </a:t>
                       </a:r>
                       <a:r>
-                        <a:rPr lang="en-US" altLang="zh-CN" sz="1400" dirty="0">
-                          <a:latin typeface="Arial" panose="020B0604020202020204" pitchFamily="34" charset="0"/>
-                          <a:cs typeface="Arial" panose="020B0604020202020204" pitchFamily="34" charset="0"/>
+                        <a:rPr lang="en-US" altLang="zh-CN" sz="1200">
+                          <a:latin typeface="Calibri" panose="020F0502020204030204" pitchFamily="34" charset="0"/>
+                          <a:ea typeface="Calibri" panose="020F0502020204030204" pitchFamily="34" charset="0"/>
+                          <a:cs typeface="Calibri" panose="020F0502020204030204" pitchFamily="34" charset="0"/>
                         </a:rPr>
                         <a:t>- mutations</a:t>
                       </a:r>
-                      <a:endParaRPr lang="zh-CN" altLang="en-US" sz="1400" dirty="0">
-                        <a:latin typeface="Arial" panose="020B0604020202020204" pitchFamily="34" charset="0"/>
-                        <a:cs typeface="Arial" panose="020B0604020202020204" pitchFamily="34" charset="0"/>
+                      <a:endParaRPr lang="zh-CN" altLang="en-US" sz="1200" dirty="0">
+                        <a:latin typeface="Calibri" panose="020F0502020204030204" pitchFamily="34" charset="0"/>
+                        <a:cs typeface="Calibri" panose="020F0502020204030204" pitchFamily="34" charset="0"/>
                       </a:endParaRPr>
                     </a:p>
                   </a:txBody>
@@ -4585,7 +5031,7 @@
                     <a:p>
                       <a:pPr algn="ctr"/>
                       <a:r>
-                        <a:rPr lang="en-US" altLang="zh-CN" sz="1400" dirty="0">
+                        <a:rPr lang="en-US" altLang="zh-CN" sz="1400">
                           <a:latin typeface="Arial" panose="020B0604020202020204" pitchFamily="34" charset="0"/>
                           <a:cs typeface="Arial" panose="020B0604020202020204" pitchFamily="34" charset="0"/>
                         </a:rPr>
@@ -4648,7 +5094,28 @@
                     <a:p>
                       <a:pPr algn="ctr"/>
                       <a:r>
-                        <a:rPr lang="en-US" altLang="zh-CN" sz="1400" dirty="0">
+                        <a:rPr lang="en-US" altLang="zh-CN" sz="1400">
+                          <a:latin typeface="Arial" panose="020B0604020202020204" pitchFamily="34" charset="0"/>
+                          <a:cs typeface="Arial" panose="020B0604020202020204" pitchFamily="34" charset="0"/>
+                        </a:rPr>
+                        <a:t>2892.71</a:t>
+                      </a:r>
+                      <a:endParaRPr lang="zh-CN" altLang="en-US" sz="1400" dirty="0">
+                        <a:latin typeface="Arial" panose="020B0604020202020204" pitchFamily="34" charset="0"/>
+                        <a:cs typeface="Arial" panose="020B0604020202020204" pitchFamily="34" charset="0"/>
+                      </a:endParaRPr>
+                    </a:p>
+                  </a:txBody>
+                  <a:tcPr/>
+                </a:tc>
+                <a:tc>
+                  <a:txBody>
+                    <a:bodyPr/>
+                    <a:lstStyle/>
+                    <a:p>
+                      <a:pPr algn="ctr"/>
+                      <a:r>
+                        <a:rPr lang="en-US" altLang="zh-CN" sz="1400">
                           <a:latin typeface="Arial" panose="020B0604020202020204" pitchFamily="34" charset="0"/>
                           <a:cs typeface="Arial" panose="020B0604020202020204" pitchFamily="34" charset="0"/>
                         </a:rPr>
@@ -4669,7 +5136,7 @@
                     <a:p>
                       <a:pPr algn="ctr"/>
                       <a:r>
-                        <a:rPr lang="en-US" altLang="zh-CN" sz="1400" dirty="0">
+                        <a:rPr lang="en-US" altLang="zh-CN" sz="1400">
                           <a:latin typeface="Arial" panose="020B0604020202020204" pitchFamily="34" charset="0"/>
                           <a:cs typeface="Arial" panose="020B0604020202020204" pitchFamily="34" charset="0"/>
                         </a:rPr>
@@ -4697,7 +5164,7 @@
                     <a:p>
                       <a:pPr algn="ctr"/>
                       <a:r>
-                        <a:rPr lang="en-US" altLang="zh-CN" sz="1400" dirty="0">
+                        <a:rPr lang="en-US" altLang="zh-CN" sz="1400">
                           <a:latin typeface="Arial" panose="020B0604020202020204" pitchFamily="34" charset="0"/>
                           <a:cs typeface="Arial" panose="020B0604020202020204" pitchFamily="34" charset="0"/>
                         </a:rPr>
@@ -4718,7 +5185,7 @@
                     <a:p>
                       <a:pPr algn="ctr"/>
                       <a:r>
-                        <a:rPr lang="en-US" altLang="zh-CN" sz="1400" dirty="0">
+                        <a:rPr lang="en-US" altLang="zh-CN" sz="1400">
                           <a:latin typeface="Arial" panose="020B0604020202020204" pitchFamily="34" charset="0"/>
                           <a:cs typeface="Arial" panose="020B0604020202020204" pitchFamily="34" charset="0"/>
                         </a:rPr>
@@ -4739,7 +5206,7 @@
                     <a:p>
                       <a:pPr algn="ctr"/>
                       <a:r>
-                        <a:rPr lang="en-US" altLang="zh-CN" sz="1400" dirty="0">
+                        <a:rPr lang="en-US" altLang="zh-CN" sz="1400">
                           <a:latin typeface="Arial" panose="020B0604020202020204" pitchFamily="34" charset="0"/>
                           <a:cs typeface="Arial" panose="020B0604020202020204" pitchFamily="34" charset="0"/>
                         </a:rPr>
@@ -4761,6 +5228,27 @@
                       <a:pPr algn="ctr"/>
                       <a:r>
                         <a:rPr lang="en-US" altLang="zh-CN" sz="1400" dirty="0">
+                          <a:latin typeface="Arial" panose="020B0604020202020204" pitchFamily="34" charset="0"/>
+                          <a:cs typeface="Arial" panose="020B0604020202020204" pitchFamily="34" charset="0"/>
+                        </a:rPr>
+                        <a:t>5060.35</a:t>
+                      </a:r>
+                      <a:endParaRPr lang="zh-CN" altLang="en-US" sz="1400" dirty="0">
+                        <a:latin typeface="Arial" panose="020B0604020202020204" pitchFamily="34" charset="0"/>
+                        <a:cs typeface="Arial" panose="020B0604020202020204" pitchFamily="34" charset="0"/>
+                      </a:endParaRPr>
+                    </a:p>
+                  </a:txBody>
+                  <a:tcPr/>
+                </a:tc>
+                <a:tc>
+                  <a:txBody>
+                    <a:bodyPr/>
+                    <a:lstStyle/>
+                    <a:p>
+                      <a:pPr algn="ctr"/>
+                      <a:r>
+                        <a:rPr lang="en-US" altLang="zh-CN" sz="1400">
                           <a:latin typeface="Arial" panose="020B0604020202020204" pitchFamily="34" charset="0"/>
                           <a:cs typeface="Arial" panose="020B0604020202020204" pitchFamily="34" charset="0"/>
                         </a:rPr>
@@ -4820,14 +5308,14 @@
           <p:nvPr>
             <p:extLst>
               <p:ext uri="{D42A27DB-BD31-4B8C-83A1-F6EECF244321}">
-                <p14:modId xmlns:p14="http://schemas.microsoft.com/office/powerpoint/2010/main" val="139963427"/>
+                <p14:modId xmlns:p14="http://schemas.microsoft.com/office/powerpoint/2010/main" val="3795591841"/>
               </p:ext>
             </p:extLst>
           </p:nvPr>
         </p:nvGraphicFramePr>
         <p:xfrm>
-          <a:off x="6096000" y="4929242"/>
-          <a:ext cx="5948220" cy="1341120"/>
+          <a:off x="6096000" y="2019389"/>
+          <a:ext cx="5948220" cy="1276241"/>
         </p:xfrm>
         <a:graphic>
           <a:graphicData uri="http://schemas.openxmlformats.org/drawingml/2006/table">
@@ -4836,38 +5324,45 @@
                 <a:tableStyleId>{5C22544A-7EE6-4342-B048-85BDC9FD1C3A}</a:tableStyleId>
               </a:tblPr>
               <a:tblGrid>
-                <a:gridCol w="1189644">
+                <a:gridCol w="991370">
                   <a:extLst>
                     <a:ext uri="{9D8B030D-6E8A-4147-A177-3AD203B41FA5}">
                       <a16:colId xmlns:a16="http://schemas.microsoft.com/office/drawing/2014/main" val="4101249701"/>
                     </a:ext>
                   </a:extLst>
                 </a:gridCol>
-                <a:gridCol w="1189644">
+                <a:gridCol w="991370">
                   <a:extLst>
                     <a:ext uri="{9D8B030D-6E8A-4147-A177-3AD203B41FA5}">
                       <a16:colId xmlns:a16="http://schemas.microsoft.com/office/drawing/2014/main" val="64436008"/>
                     </a:ext>
                   </a:extLst>
                 </a:gridCol>
-                <a:gridCol w="1189644">
+                <a:gridCol w="991370">
                   <a:extLst>
                     <a:ext uri="{9D8B030D-6E8A-4147-A177-3AD203B41FA5}">
                       <a16:colId xmlns:a16="http://schemas.microsoft.com/office/drawing/2014/main" val="2870068380"/>
                     </a:ext>
                   </a:extLst>
                 </a:gridCol>
-                <a:gridCol w="1189644">
+                <a:gridCol w="991370">
                   <a:extLst>
                     <a:ext uri="{9D8B030D-6E8A-4147-A177-3AD203B41FA5}">
                       <a16:colId xmlns:a16="http://schemas.microsoft.com/office/drawing/2014/main" val="2903000029"/>
                     </a:ext>
                   </a:extLst>
                 </a:gridCol>
-                <a:gridCol w="1189644">
+                <a:gridCol w="991370">
                   <a:extLst>
                     <a:ext uri="{9D8B030D-6E8A-4147-A177-3AD203B41FA5}">
                       <a16:colId xmlns:a16="http://schemas.microsoft.com/office/drawing/2014/main" val="3141391406"/>
+                    </a:ext>
+                  </a:extLst>
+                </a:gridCol>
+                <a:gridCol w="991370">
+                  <a:extLst>
+                    <a:ext uri="{9D8B030D-6E8A-4147-A177-3AD203B41FA5}">
+                      <a16:colId xmlns:a16="http://schemas.microsoft.com/office/drawing/2014/main" val="4228366896"/>
                     </a:ext>
                   </a:extLst>
                 </a:gridCol>
@@ -4896,15 +5391,16 @@
                         <a:defRPr/>
                       </a:pPr>
                       <a:r>
-                        <a:rPr lang="en-US" altLang="zh-CN" sz="1400" dirty="0">
-                          <a:latin typeface="Arial" panose="020B0604020202020204" pitchFamily="34" charset="0"/>
-                          <a:cs typeface="Arial" panose="020B0604020202020204" pitchFamily="34" charset="0"/>
+                        <a:rPr lang="en-US" altLang="zh-CN" sz="1200" dirty="0">
+                          <a:latin typeface="Calibri" panose="020F0502020204030204" pitchFamily="34" charset="0"/>
+                          <a:ea typeface="Calibri" panose="020F0502020204030204" pitchFamily="34" charset="0"/>
+                          <a:cs typeface="Calibri" panose="020F0502020204030204" pitchFamily="34" charset="0"/>
                         </a:rPr>
                         <a:t>Average Time Cost</a:t>
                       </a:r>
-                      <a:endParaRPr lang="zh-CN" altLang="en-US" sz="1400" dirty="0">
-                        <a:latin typeface="Arial" panose="020B0604020202020204" pitchFamily="34" charset="0"/>
-                        <a:cs typeface="Arial" panose="020B0604020202020204" pitchFamily="34" charset="0"/>
+                      <a:endParaRPr lang="zh-CN" altLang="en-US" sz="1200" dirty="0">
+                        <a:latin typeface="Calibri" panose="020F0502020204030204" pitchFamily="34" charset="0"/>
+                        <a:cs typeface="Calibri" panose="020F0502020204030204" pitchFamily="34" charset="0"/>
                       </a:endParaRPr>
                     </a:p>
                   </a:txBody>
@@ -4933,29 +5429,32 @@
                         <a:defRPr/>
                       </a:pPr>
                       <a:r>
-                        <a:rPr lang="en-US" altLang="zh-CN" sz="1400" dirty="0">
-                          <a:latin typeface="Arial" panose="020B0604020202020204" pitchFamily="34" charset="0"/>
-                          <a:cs typeface="Arial" panose="020B0604020202020204" pitchFamily="34" charset="0"/>
+                        <a:rPr lang="en-US" altLang="zh-CN" sz="1200" dirty="0">
+                          <a:latin typeface="Calibri" panose="020F0502020204030204" pitchFamily="34" charset="0"/>
+                          <a:ea typeface="Calibri" panose="020F0502020204030204" pitchFamily="34" charset="0"/>
+                          <a:cs typeface="Calibri" panose="020F0502020204030204" pitchFamily="34" charset="0"/>
                         </a:rPr>
                         <a:t>Chain-of-Thought (</a:t>
                       </a:r>
                       <a:r>
-                        <a:rPr lang="en-US" altLang="zh-CN" sz="1400" dirty="0" err="1">
-                          <a:latin typeface="Arial" panose="020B0604020202020204" pitchFamily="34" charset="0"/>
-                          <a:cs typeface="Arial" panose="020B0604020202020204" pitchFamily="34" charset="0"/>
+                        <a:rPr lang="en-US" altLang="zh-CN" sz="1200" dirty="0" err="1">
+                          <a:latin typeface="Calibri" panose="020F0502020204030204" pitchFamily="34" charset="0"/>
+                          <a:ea typeface="Calibri" panose="020F0502020204030204" pitchFamily="34" charset="0"/>
+                          <a:cs typeface="Calibri" panose="020F0502020204030204" pitchFamily="34" charset="0"/>
                         </a:rPr>
                         <a:t>CoT</a:t>
                       </a:r>
                       <a:r>
-                        <a:rPr lang="en-US" altLang="zh-CN" sz="1400" dirty="0">
-                          <a:latin typeface="Arial" panose="020B0604020202020204" pitchFamily="34" charset="0"/>
-                          <a:cs typeface="Arial" panose="020B0604020202020204" pitchFamily="34" charset="0"/>
+                        <a:rPr lang="en-US" altLang="zh-CN" sz="1200" dirty="0">
+                          <a:latin typeface="Calibri" panose="020F0502020204030204" pitchFamily="34" charset="0"/>
+                          <a:ea typeface="Calibri" panose="020F0502020204030204" pitchFamily="34" charset="0"/>
+                          <a:cs typeface="Calibri" panose="020F0502020204030204" pitchFamily="34" charset="0"/>
                         </a:rPr>
                         <a:t>)</a:t>
                       </a:r>
-                      <a:endParaRPr lang="zh-CN" altLang="en-US" sz="1400" dirty="0">
-                        <a:latin typeface="Arial" panose="020B0604020202020204" pitchFamily="34" charset="0"/>
-                        <a:cs typeface="Arial" panose="020B0604020202020204" pitchFamily="34" charset="0"/>
+                      <a:endParaRPr lang="zh-CN" altLang="en-US" sz="1200" dirty="0">
+                        <a:latin typeface="Calibri" panose="020F0502020204030204" pitchFamily="34" charset="0"/>
+                        <a:cs typeface="Calibri" panose="020F0502020204030204" pitchFamily="34" charset="0"/>
                       </a:endParaRPr>
                     </a:p>
                   </a:txBody>
@@ -4984,29 +5483,32 @@
                         <a:defRPr/>
                       </a:pPr>
                       <a:r>
-                        <a:rPr lang="en-US" altLang="zh-CN" sz="1400" dirty="0">
-                          <a:latin typeface="Arial" panose="020B0604020202020204" pitchFamily="34" charset="0"/>
-                          <a:cs typeface="Arial" panose="020B0604020202020204" pitchFamily="34" charset="0"/>
+                        <a:rPr lang="en-US" altLang="zh-CN" sz="1200" dirty="0">
+                          <a:latin typeface="Calibri" panose="020F0502020204030204" pitchFamily="34" charset="0"/>
+                          <a:ea typeface="Calibri" panose="020F0502020204030204" pitchFamily="34" charset="0"/>
+                          <a:cs typeface="Calibri" panose="020F0502020204030204" pitchFamily="34" charset="0"/>
                         </a:rPr>
                         <a:t>Chain-of-Verification (</a:t>
                       </a:r>
                       <a:r>
-                        <a:rPr lang="en-US" altLang="zh-CN" sz="1400" dirty="0" err="1">
-                          <a:latin typeface="Arial" panose="020B0604020202020204" pitchFamily="34" charset="0"/>
-                          <a:cs typeface="Arial" panose="020B0604020202020204" pitchFamily="34" charset="0"/>
+                        <a:rPr lang="en-US" altLang="zh-CN" sz="1200" dirty="0" err="1">
+                          <a:latin typeface="Calibri" panose="020F0502020204030204" pitchFamily="34" charset="0"/>
+                          <a:ea typeface="Calibri" panose="020F0502020204030204" pitchFamily="34" charset="0"/>
+                          <a:cs typeface="Calibri" panose="020F0502020204030204" pitchFamily="34" charset="0"/>
                         </a:rPr>
                         <a:t>CoVe</a:t>
                       </a:r>
                       <a:r>
-                        <a:rPr lang="en-US" altLang="zh-CN" sz="1400" dirty="0">
-                          <a:latin typeface="Arial" panose="020B0604020202020204" pitchFamily="34" charset="0"/>
-                          <a:cs typeface="Arial" panose="020B0604020202020204" pitchFamily="34" charset="0"/>
+                        <a:rPr lang="en-US" altLang="zh-CN" sz="1200" dirty="0">
+                          <a:latin typeface="Calibri" panose="020F0502020204030204" pitchFamily="34" charset="0"/>
+                          <a:ea typeface="Calibri" panose="020F0502020204030204" pitchFamily="34" charset="0"/>
+                          <a:cs typeface="Calibri" panose="020F0502020204030204" pitchFamily="34" charset="0"/>
                         </a:rPr>
                         <a:t>)</a:t>
                       </a:r>
-                      <a:endParaRPr lang="zh-CN" altLang="en-US" sz="1400" dirty="0">
-                        <a:latin typeface="Arial" panose="020B0604020202020204" pitchFamily="34" charset="0"/>
-                        <a:cs typeface="Arial" panose="020B0604020202020204" pitchFamily="34" charset="0"/>
+                      <a:endParaRPr lang="zh-CN" altLang="en-US" sz="1200" dirty="0">
+                        <a:latin typeface="Calibri" panose="020F0502020204030204" pitchFamily="34" charset="0"/>
+                        <a:cs typeface="Calibri" panose="020F0502020204030204" pitchFamily="34" charset="0"/>
                       </a:endParaRPr>
                     </a:p>
                   </a:txBody>
@@ -5035,15 +5537,24 @@
                         <a:defRPr/>
                       </a:pPr>
                       <a:r>
-                        <a:rPr lang="en-US" altLang="zh-CN" sz="1400" dirty="0">
-                          <a:latin typeface="Arial" panose="020B0604020202020204" pitchFamily="34" charset="0"/>
-                          <a:cs typeface="Arial" panose="020B0604020202020204" pitchFamily="34" charset="0"/>
+                        <a:rPr lang="en-US" altLang="zh-CN" sz="1200" dirty="0" err="1">
+                          <a:latin typeface="Calibri" panose="020F0502020204030204" pitchFamily="34" charset="0"/>
+                          <a:ea typeface="Calibri" panose="020F0502020204030204" pitchFamily="34" charset="0"/>
+                          <a:cs typeface="Calibri" panose="020F0502020204030204" pitchFamily="34" charset="0"/>
                         </a:rPr>
-                        <a:t>our approach</a:t>
+                        <a:t>CoVe</a:t>
                       </a:r>
-                      <a:endParaRPr lang="zh-CN" altLang="en-US" sz="1400" dirty="0">
-                        <a:latin typeface="Arial" panose="020B0604020202020204" pitchFamily="34" charset="0"/>
-                        <a:cs typeface="Arial" panose="020B0604020202020204" pitchFamily="34" charset="0"/>
+                      <a:r>
+                        <a:rPr lang="en-US" altLang="zh-CN" sz="1200" dirty="0">
+                          <a:latin typeface="Calibri" panose="020F0502020204030204" pitchFamily="34" charset="0"/>
+                          <a:ea typeface="Calibri" panose="020F0502020204030204" pitchFamily="34" charset="0"/>
+                          <a:cs typeface="Calibri" panose="020F0502020204030204" pitchFamily="34" charset="0"/>
+                        </a:rPr>
+                        <a:t> - Search Engine</a:t>
+                      </a:r>
+                      <a:endParaRPr lang="zh-CN" altLang="en-US" sz="1200" dirty="0">
+                        <a:latin typeface="Calibri" panose="020F0502020204030204" pitchFamily="34" charset="0"/>
+                        <a:cs typeface="Calibri" panose="020F0502020204030204" pitchFamily="34" charset="0"/>
                       </a:endParaRPr>
                     </a:p>
                   </a:txBody>
@@ -5072,29 +5583,69 @@
                         <a:defRPr/>
                       </a:pPr>
                       <a:r>
-                        <a:rPr lang="en-US" altLang="zh-CN" sz="1400" dirty="0">
-                          <a:latin typeface="Arial" panose="020B0604020202020204" pitchFamily="34" charset="0"/>
-                          <a:cs typeface="Arial" panose="020B0604020202020204" pitchFamily="34" charset="0"/>
+                        <a:rPr lang="en-US" altLang="zh-CN" sz="1200" dirty="0">
+                          <a:latin typeface="Calibri" panose="020F0502020204030204" pitchFamily="34" charset="0"/>
+                          <a:ea typeface="Calibri" panose="020F0502020204030204" pitchFamily="34" charset="0"/>
+                          <a:cs typeface="Calibri" panose="020F0502020204030204" pitchFamily="34" charset="0"/>
+                        </a:rPr>
+                        <a:t>our approach</a:t>
+                      </a:r>
+                      <a:endParaRPr lang="zh-CN" altLang="en-US" sz="1200" dirty="0">
+                        <a:latin typeface="Calibri" panose="020F0502020204030204" pitchFamily="34" charset="0"/>
+                        <a:cs typeface="Calibri" panose="020F0502020204030204" pitchFamily="34" charset="0"/>
+                      </a:endParaRPr>
+                    </a:p>
+                  </a:txBody>
+                  <a:tcPr/>
+                </a:tc>
+                <a:tc>
+                  <a:txBody>
+                    <a:bodyPr/>
+                    <a:lstStyle/>
+                    <a:p>
+                      <a:pPr marL="0" marR="0" lvl="0" indent="0" algn="l" defTabSz="914400" rtl="0" eaLnBrk="1" fontAlgn="auto" latinLnBrk="0" hangingPunct="1">
+                        <a:lnSpc>
+                          <a:spcPct val="100000"/>
+                        </a:lnSpc>
+                        <a:spcBef>
+                          <a:spcPts val="0"/>
+                        </a:spcBef>
+                        <a:spcAft>
+                          <a:spcPts val="0"/>
+                        </a:spcAft>
+                        <a:buClrTx/>
+                        <a:buSzTx/>
+                        <a:buFontTx/>
+                        <a:buNone/>
+                        <a:tabLst/>
+                        <a:defRPr/>
+                      </a:pPr>
+                      <a:r>
+                        <a:rPr lang="en-US" altLang="zh-CN" sz="1200" dirty="0">
+                          <a:latin typeface="Calibri" panose="020F0502020204030204" pitchFamily="34" charset="0"/>
+                          <a:ea typeface="Calibri" panose="020F0502020204030204" pitchFamily="34" charset="0"/>
+                          <a:cs typeface="Calibri" panose="020F0502020204030204" pitchFamily="34" charset="0"/>
                         </a:rPr>
                         <a:t>our approach</a:t>
                       </a:r>
                       <a:r>
-                        <a:rPr lang="zh-CN" altLang="en-US" sz="1400" dirty="0">
-                          <a:latin typeface="Arial" panose="020B0604020202020204" pitchFamily="34" charset="0"/>
-                          <a:cs typeface="Arial" panose="020B0604020202020204" pitchFamily="34" charset="0"/>
+                        <a:rPr lang="zh-CN" altLang="en-US" sz="1200" dirty="0">
+                          <a:latin typeface="Calibri" panose="020F0502020204030204" pitchFamily="34" charset="0"/>
+                          <a:cs typeface="Calibri" panose="020F0502020204030204" pitchFamily="34" charset="0"/>
                         </a:rPr>
                         <a:t> </a:t>
                       </a:r>
                       <a:r>
-                        <a:rPr lang="en-US" altLang="zh-CN" sz="1400" dirty="0">
-                          <a:latin typeface="Arial" panose="020B0604020202020204" pitchFamily="34" charset="0"/>
-                          <a:cs typeface="Arial" panose="020B0604020202020204" pitchFamily="34" charset="0"/>
+                        <a:rPr lang="en-US" altLang="zh-CN" sz="1200" dirty="0">
+                          <a:latin typeface="Calibri" panose="020F0502020204030204" pitchFamily="34" charset="0"/>
+                          <a:ea typeface="Calibri" panose="020F0502020204030204" pitchFamily="34" charset="0"/>
+                          <a:cs typeface="Calibri" panose="020F0502020204030204" pitchFamily="34" charset="0"/>
                         </a:rPr>
                         <a:t>- mutations</a:t>
                       </a:r>
-                      <a:endParaRPr lang="zh-CN" altLang="en-US" sz="1400" dirty="0">
-                        <a:latin typeface="Arial" panose="020B0604020202020204" pitchFamily="34" charset="0"/>
-                        <a:cs typeface="Arial" panose="020B0604020202020204" pitchFamily="34" charset="0"/>
+                      <a:endParaRPr lang="zh-CN" altLang="en-US" sz="1200" dirty="0">
+                        <a:latin typeface="Calibri" panose="020F0502020204030204" pitchFamily="34" charset="0"/>
+                        <a:cs typeface="Calibri" panose="020F0502020204030204" pitchFamily="34" charset="0"/>
                       </a:endParaRPr>
                     </a:p>
                   </a:txBody>
@@ -5157,6 +5708,27 @@
                           <a:cs typeface="Arial" panose="020B0604020202020204" pitchFamily="34" charset="0"/>
                         </a:rPr>
                         <a:t>17.43</a:t>
+                      </a:r>
+                      <a:endParaRPr lang="zh-CN" altLang="en-US" sz="1400" dirty="0">
+                        <a:latin typeface="Arial" panose="020B0604020202020204" pitchFamily="34" charset="0"/>
+                        <a:cs typeface="Arial" panose="020B0604020202020204" pitchFamily="34" charset="0"/>
+                      </a:endParaRPr>
+                    </a:p>
+                  </a:txBody>
+                  <a:tcPr/>
+                </a:tc>
+                <a:tc>
+                  <a:txBody>
+                    <a:bodyPr/>
+                    <a:lstStyle/>
+                    <a:p>
+                      <a:pPr algn="ctr"/>
+                      <a:r>
+                        <a:rPr lang="en-US" altLang="zh-CN" sz="1400" dirty="0">
+                          <a:latin typeface="Arial" panose="020B0604020202020204" pitchFamily="34" charset="0"/>
+                          <a:cs typeface="Arial" panose="020B0604020202020204" pitchFamily="34" charset="0"/>
+                        </a:rPr>
+                        <a:t>34.5704</a:t>
                       </a:r>
                       <a:endParaRPr lang="zh-CN" altLang="en-US" sz="1400" dirty="0">
                         <a:latin typeface="Arial" panose="020B0604020202020204" pitchFamily="34" charset="0"/>
@@ -5305,6 +5877,27 @@
                           <a:latin typeface="Arial" panose="020B0604020202020204" pitchFamily="34" charset="0"/>
                           <a:cs typeface="Arial" panose="020B0604020202020204" pitchFamily="34" charset="0"/>
                         </a:rPr>
+                        <a:t>78.0071</a:t>
+                      </a:r>
+                      <a:endParaRPr lang="zh-CN" altLang="en-US" sz="1400" dirty="0">
+                        <a:latin typeface="Arial" panose="020B0604020202020204" pitchFamily="34" charset="0"/>
+                        <a:cs typeface="Arial" panose="020B0604020202020204" pitchFamily="34" charset="0"/>
+                      </a:endParaRPr>
+                    </a:p>
+                  </a:txBody>
+                  <a:tcPr/>
+                </a:tc>
+                <a:tc>
+                  <a:txBody>
+                    <a:bodyPr/>
+                    <a:lstStyle/>
+                    <a:p>
+                      <a:pPr algn="ctr"/>
+                      <a:r>
+                        <a:rPr lang="en-US" altLang="zh-CN" sz="1400" dirty="0">
+                          <a:latin typeface="Arial" panose="020B0604020202020204" pitchFamily="34" charset="0"/>
+                          <a:cs typeface="Arial" panose="020B0604020202020204" pitchFamily="34" charset="0"/>
+                        </a:rPr>
                         <a:t>27.96</a:t>
                       </a:r>
                       <a:endParaRPr lang="zh-CN" altLang="en-US" sz="1400" dirty="0">
@@ -5346,12 +5939,54 @@
           </a:graphicData>
         </a:graphic>
       </p:graphicFrame>
+      <p:sp>
+        <p:nvSpPr>
+          <p:cNvPr id="11" name="文本框 10">
+            <a:extLst>
+              <a:ext uri="{FF2B5EF4-FFF2-40B4-BE49-F238E27FC236}">
+                <a16:creationId xmlns:a16="http://schemas.microsoft.com/office/drawing/2014/main" id="{C0CCBC1A-83EC-228E-417D-8BB79203B20F}"/>
+              </a:ext>
+            </a:extLst>
+          </p:cNvPr>
+          <p:cNvSpPr txBox="1"/>
+          <p:nvPr/>
+        </p:nvSpPr>
+        <p:spPr>
+          <a:xfrm>
+            <a:off x="479719" y="151179"/>
+            <a:ext cx="11219222" cy="584775"/>
+          </a:xfrm>
+          <a:prstGeom prst="rect">
+            <a:avLst/>
+          </a:prstGeom>
+          <a:noFill/>
+        </p:spPr>
+        <p:txBody>
+          <a:bodyPr wrap="square" rtlCol="0">
+            <a:spAutoFit/>
+          </a:bodyPr>
+          <a:lstStyle/>
+          <a:p>
+            <a:r>
+              <a:rPr lang="en-US" altLang="zh-CN" sz="3200" dirty="0">
+                <a:latin typeface="Arial" panose="020B0604020202020204" pitchFamily="34" charset="0"/>
+                <a:cs typeface="Arial" panose="020B0604020202020204" pitchFamily="34" charset="0"/>
+              </a:rPr>
+              <a:t>Experiment evaluation</a:t>
+            </a:r>
+            <a:endParaRPr lang="en-US" altLang="zh-CN" sz="2000" dirty="0">
+              <a:latin typeface="Arial" panose="020B0604020202020204" pitchFamily="34" charset="0"/>
+              <a:cs typeface="Arial" panose="020B0604020202020204" pitchFamily="34" charset="0"/>
+            </a:endParaRPr>
+          </a:p>
+        </p:txBody>
+      </p:sp>
       <p:pic>
         <p:nvPicPr>
-          <p:cNvPr id="4" name="图片 3" descr="图表, 条形图&#10;&#10;AI 生成的内容可能不正确。">
-            <a:extLst>
-              <a:ext uri="{FF2B5EF4-FFF2-40B4-BE49-F238E27FC236}">
-                <a16:creationId xmlns:a16="http://schemas.microsoft.com/office/drawing/2014/main" id="{50E62019-7A16-290C-1833-4A1FD6FCE9B2}"/>
+          <p:cNvPr id="15" name="图片 14">
+            <a:extLst>
+              <a:ext uri="{FF2B5EF4-FFF2-40B4-BE49-F238E27FC236}">
+                <a16:creationId xmlns:a16="http://schemas.microsoft.com/office/drawing/2014/main" id="{44F4E3A2-D412-973B-DC64-4A6FAF8F3362}"/>
               </a:ext>
             </a:extLst>
           </p:cNvPr>
@@ -5361,21 +5996,15 @@
           <p:nvPr/>
         </p:nvPicPr>
         <p:blipFill>
-          <a:blip r:embed="rId4">
-            <a:extLst>
-              <a:ext uri="{28A0092B-C50C-407E-A947-70E740481C1C}">
-                <a14:useLocalDpi xmlns:a14="http://schemas.microsoft.com/office/drawing/2010/main" val="0"/>
-              </a:ext>
-            </a:extLst>
-          </a:blip>
+          <a:blip r:embed="rId2"/>
           <a:stretch>
             <a:fillRect/>
           </a:stretch>
         </p:blipFill>
         <p:spPr>
           <a:xfrm>
-            <a:off x="1613573" y="59230"/>
-            <a:ext cx="3924978" cy="3210648"/>
+            <a:off x="895180" y="735954"/>
+            <a:ext cx="4785360" cy="5189220"/>
           </a:xfrm>
           <a:prstGeom prst="rect">
             <a:avLst/>
@@ -5386,591 +6015,6 @@
     <p:extLst>
       <p:ext uri="{BB962C8B-B14F-4D97-AF65-F5344CB8AC3E}">
         <p14:creationId xmlns:p14="http://schemas.microsoft.com/office/powerpoint/2010/main" val="495306369"/>
-      </p:ext>
-    </p:extLst>
-  </p:cSld>
-  <p:clrMapOvr>
-    <a:masterClrMapping/>
-  </p:clrMapOvr>
-</p:sld>
-</file>
-
-<file path=ppt/slides/slide5.xml><?xml version="1.0" encoding="utf-8"?>
-<p:sld xmlns:a="http://schemas.openxmlformats.org/drawingml/2006/main" xmlns:r="http://schemas.openxmlformats.org/officeDocument/2006/relationships" xmlns:p="http://schemas.openxmlformats.org/presentationml/2006/main" show="0">
-  <p:cSld>
-    <p:spTree>
-      <p:nvGrpSpPr>
-        <p:cNvPr id="1" name="">
-          <a:extLst>
-            <a:ext uri="{FF2B5EF4-FFF2-40B4-BE49-F238E27FC236}">
-              <a16:creationId xmlns:a16="http://schemas.microsoft.com/office/drawing/2014/main" id="{44A533DA-5BC4-3128-4B72-2E2279D8ACB0}"/>
-            </a:ext>
-          </a:extLst>
-        </p:cNvPr>
-        <p:cNvGrpSpPr/>
-        <p:nvPr/>
-      </p:nvGrpSpPr>
-      <p:grpSpPr>
-        <a:xfrm>
-          <a:off x="0" y="0"/>
-          <a:ext cx="0" cy="0"/>
-          <a:chOff x="0" y="0"/>
-          <a:chExt cx="0" cy="0"/>
-        </a:xfrm>
-      </p:grpSpPr>
-      <p:sp>
-        <p:nvSpPr>
-          <p:cNvPr id="4" name="文本框 3">
-            <a:extLst>
-              <a:ext uri="{FF2B5EF4-FFF2-40B4-BE49-F238E27FC236}">
-                <a16:creationId xmlns:a16="http://schemas.microsoft.com/office/drawing/2014/main" id="{B9776EFB-8D87-EA22-B01C-4E1567653A07}"/>
-              </a:ext>
-            </a:extLst>
-          </p:cNvPr>
-          <p:cNvSpPr txBox="1"/>
-          <p:nvPr/>
-        </p:nvSpPr>
-        <p:spPr>
-          <a:xfrm>
-            <a:off x="488956" y="0"/>
-            <a:ext cx="10890245" cy="6924973"/>
-          </a:xfrm>
-          <a:prstGeom prst="rect">
-            <a:avLst/>
-          </a:prstGeom>
-          <a:noFill/>
-        </p:spPr>
-        <p:txBody>
-          <a:bodyPr wrap="square" rtlCol="0">
-            <a:spAutoFit/>
-          </a:bodyPr>
-          <a:lstStyle/>
-          <a:p>
-            <a:r>
-              <a:rPr lang="en-US" altLang="zh-CN" sz="2400" b="1" dirty="0">
-                <a:latin typeface="Arial" panose="020B0604020202020204" pitchFamily="34" charset="0"/>
-                <a:cs typeface="Arial" panose="020B0604020202020204" pitchFamily="34" charset="0"/>
-              </a:rPr>
-              <a:t>Experiment results on gpt-4o:</a:t>
-            </a:r>
-          </a:p>
-          <a:p>
-            <a:r>
-              <a:rPr lang="en-US" altLang="zh-CN" sz="2000" b="1" dirty="0">
-                <a:latin typeface="Arial" panose="020B0604020202020204" pitchFamily="34" charset="0"/>
-                <a:cs typeface="Arial" panose="020B0604020202020204" pitchFamily="34" charset="0"/>
-              </a:rPr>
-              <a:t>Our</a:t>
-            </a:r>
-            <a:r>
-              <a:rPr lang="zh-CN" altLang="en-US" sz="2000" b="1" dirty="0">
-                <a:latin typeface="Arial" panose="020B0604020202020204" pitchFamily="34" charset="0"/>
-                <a:cs typeface="Arial" panose="020B0604020202020204" pitchFamily="34" charset="0"/>
-              </a:rPr>
-              <a:t> </a:t>
-            </a:r>
-            <a:r>
-              <a:rPr lang="en-US" altLang="zh-CN" sz="2000" b="1" dirty="0">
-                <a:latin typeface="Arial" panose="020B0604020202020204" pitchFamily="34" charset="0"/>
-                <a:cs typeface="Arial" panose="020B0604020202020204" pitchFamily="34" charset="0"/>
-              </a:rPr>
-              <a:t>approach:</a:t>
-            </a:r>
-            <a:r>
-              <a:rPr lang="zh-CN" altLang="en-US" sz="2000" b="1" dirty="0">
-                <a:latin typeface="Arial" panose="020B0604020202020204" pitchFamily="34" charset="0"/>
-                <a:cs typeface="Arial" panose="020B0604020202020204" pitchFamily="34" charset="0"/>
-              </a:rPr>
-              <a:t> </a:t>
-            </a:r>
-            <a:endParaRPr lang="en-US" altLang="zh-CN" sz="2000" b="1" dirty="0">
-              <a:latin typeface="Arial" panose="020B0604020202020204" pitchFamily="34" charset="0"/>
-              <a:cs typeface="Arial" panose="020B0604020202020204" pitchFamily="34" charset="0"/>
-            </a:endParaRPr>
-          </a:p>
-          <a:p>
-            <a:r>
-              <a:rPr lang="en-US" altLang="zh-CN" sz="2000" dirty="0">
-                <a:latin typeface="Arial" panose="020B0604020202020204" pitchFamily="34" charset="0"/>
-                <a:cs typeface="Arial" panose="020B0604020202020204" pitchFamily="34" charset="0"/>
-              </a:rPr>
-              <a:t>Total hallucination after repair: 35/220 (50% -&gt; 15.91%) </a:t>
-            </a:r>
-          </a:p>
-          <a:p>
-            <a:r>
-              <a:rPr lang="en-US" altLang="zh-CN" sz="2000" dirty="0">
-                <a:latin typeface="Arial" panose="020B0604020202020204" pitchFamily="34" charset="0"/>
-                <a:cs typeface="Arial" panose="020B0604020202020204" pitchFamily="34" charset="0"/>
-              </a:rPr>
-              <a:t>Hallucination repair: 92/109 (84.40%), unsuccessful repair: 9/109 (8.26%), unable repair: 8/109 (7.34%) </a:t>
-            </a:r>
-          </a:p>
-          <a:p>
-            <a:r>
-              <a:rPr lang="en-US" altLang="zh-CN" sz="2000" dirty="0">
-                <a:latin typeface="Arial" panose="020B0604020202020204" pitchFamily="34" charset="0"/>
-                <a:cs typeface="Arial" panose="020B0604020202020204" pitchFamily="34" charset="0"/>
-              </a:rPr>
-              <a:t>Unnecessary repair: 20/111 (18.02%)</a:t>
-            </a:r>
-          </a:p>
-          <a:p>
-            <a:r>
-              <a:rPr lang="en-US" altLang="zh-CN" sz="2000" dirty="0">
-                <a:latin typeface="Arial" panose="020B0604020202020204" pitchFamily="34" charset="0"/>
-                <a:cs typeface="Arial" panose="020B0604020202020204" pitchFamily="34" charset="0"/>
-              </a:rPr>
-              <a:t>Avg token cost pre question: 289.43</a:t>
-            </a:r>
-          </a:p>
-          <a:p>
-            <a:r>
-              <a:rPr lang="en-US" altLang="zh-CN" sz="2000" dirty="0">
-                <a:latin typeface="Arial" panose="020B0604020202020204" pitchFamily="34" charset="0"/>
-                <a:cs typeface="Arial" panose="020B0604020202020204" pitchFamily="34" charset="0"/>
-              </a:rPr>
-              <a:t>Avg time cost pre question: 1.4267s</a:t>
-            </a:r>
-          </a:p>
-          <a:p>
-            <a:endParaRPr lang="en-US" altLang="zh-CN" sz="2000" dirty="0">
-              <a:latin typeface="Arial" panose="020B0604020202020204" pitchFamily="34" charset="0"/>
-              <a:cs typeface="Arial" panose="020B0604020202020204" pitchFamily="34" charset="0"/>
-            </a:endParaRPr>
-          </a:p>
-          <a:p>
-            <a:r>
-              <a:rPr lang="en-US" altLang="zh-CN" sz="2000" b="1" dirty="0" err="1">
-                <a:latin typeface="Arial" panose="020B0604020202020204" pitchFamily="34" charset="0"/>
-                <a:cs typeface="Arial" panose="020B0604020202020204" pitchFamily="34" charset="0"/>
-              </a:rPr>
-              <a:t>CoT</a:t>
-            </a:r>
-            <a:r>
-              <a:rPr lang="en-US" altLang="zh-CN" sz="2000" b="1" dirty="0">
-                <a:latin typeface="Arial" panose="020B0604020202020204" pitchFamily="34" charset="0"/>
-                <a:cs typeface="Arial" panose="020B0604020202020204" pitchFamily="34" charset="0"/>
-              </a:rPr>
-              <a:t>:</a:t>
-            </a:r>
-          </a:p>
-          <a:p>
-            <a:r>
-              <a:rPr lang="en-US" altLang="zh-CN" sz="2000" dirty="0">
-                <a:latin typeface="Arial" panose="020B0604020202020204" pitchFamily="34" charset="0"/>
-                <a:cs typeface="Arial" panose="020B0604020202020204" pitchFamily="34" charset="0"/>
-              </a:rPr>
-              <a:t>Total hallucination after repair: 89/224 (50%-&gt; 39.73%)</a:t>
-            </a:r>
-          </a:p>
-          <a:p>
-            <a:r>
-              <a:rPr lang="en-US" altLang="zh-CN" sz="2000" dirty="0">
-                <a:latin typeface="Arial" panose="020B0604020202020204" pitchFamily="34" charset="0"/>
-                <a:cs typeface="Arial" panose="020B0604020202020204" pitchFamily="34" charset="0"/>
-              </a:rPr>
-              <a:t>Hallucination repair: 54/111 (48.65%), unsuccessful repair: 57/111 (51.35%)</a:t>
-            </a:r>
-          </a:p>
-          <a:p>
-            <a:r>
-              <a:rPr lang="en-US" altLang="zh-CN" sz="2000" dirty="0">
-                <a:latin typeface="Arial" panose="020B0604020202020204" pitchFamily="34" charset="0"/>
-                <a:cs typeface="Arial" panose="020B0604020202020204" pitchFamily="34" charset="0"/>
-              </a:rPr>
-              <a:t>Unnecessary repair: 32/113 (28.32%)</a:t>
-            </a:r>
-          </a:p>
-          <a:p>
-            <a:r>
-              <a:rPr lang="en-US" altLang="zh-CN" sz="2000" dirty="0">
-                <a:latin typeface="Arial" panose="020B0604020202020204" pitchFamily="34" charset="0"/>
-                <a:cs typeface="Arial" panose="020B0604020202020204" pitchFamily="34" charset="0"/>
-              </a:rPr>
-              <a:t>Avg token cost pre question: 2560.37</a:t>
-            </a:r>
-          </a:p>
-          <a:p>
-            <a:r>
-              <a:rPr lang="en-US" altLang="zh-CN" sz="2000" dirty="0">
-                <a:latin typeface="Arial" panose="020B0604020202020204" pitchFamily="34" charset="0"/>
-                <a:cs typeface="Arial" panose="020B0604020202020204" pitchFamily="34" charset="0"/>
-              </a:rPr>
-              <a:t>Avg time cost pre question: 20.6160s</a:t>
-            </a:r>
-          </a:p>
-          <a:p>
-            <a:endParaRPr lang="en-US" altLang="zh-CN" sz="2000" dirty="0">
-              <a:latin typeface="Arial" panose="020B0604020202020204" pitchFamily="34" charset="0"/>
-              <a:cs typeface="Arial" panose="020B0604020202020204" pitchFamily="34" charset="0"/>
-            </a:endParaRPr>
-          </a:p>
-          <a:p>
-            <a:r>
-              <a:rPr lang="en-US" altLang="zh-CN" sz="2000" b="1" dirty="0" err="1">
-                <a:latin typeface="Arial" panose="020B0604020202020204" pitchFamily="34" charset="0"/>
-                <a:cs typeface="Arial" panose="020B0604020202020204" pitchFamily="34" charset="0"/>
-              </a:rPr>
-              <a:t>CoVe</a:t>
-            </a:r>
-            <a:r>
-              <a:rPr lang="en-US" altLang="zh-CN" sz="2000" b="1" dirty="0">
-                <a:latin typeface="Arial" panose="020B0604020202020204" pitchFamily="34" charset="0"/>
-                <a:cs typeface="Arial" panose="020B0604020202020204" pitchFamily="34" charset="0"/>
-              </a:rPr>
-              <a:t>:</a:t>
-            </a:r>
-          </a:p>
-          <a:p>
-            <a:r>
-              <a:rPr lang="en-US" altLang="zh-CN" sz="2000" dirty="0">
-                <a:latin typeface="Arial" panose="020B0604020202020204" pitchFamily="34" charset="0"/>
-                <a:cs typeface="Arial" panose="020B0604020202020204" pitchFamily="34" charset="0"/>
-              </a:rPr>
-              <a:t>Total hallucination after repair: 92/224 (50%-&gt; 41.07%)</a:t>
-            </a:r>
-          </a:p>
-          <a:p>
-            <a:r>
-              <a:rPr lang="en-US" altLang="zh-CN" sz="2000" dirty="0">
-                <a:latin typeface="Arial" panose="020B0604020202020204" pitchFamily="34" charset="0"/>
-                <a:cs typeface="Arial" panose="020B0604020202020204" pitchFamily="34" charset="0"/>
-              </a:rPr>
-              <a:t>Hallucination repair: 45/112 (40.54%), unsuccessful repair: 66/111 (59.46%)</a:t>
-            </a:r>
-          </a:p>
-          <a:p>
-            <a:r>
-              <a:rPr lang="en-US" altLang="zh-CN" sz="2000" dirty="0">
-                <a:latin typeface="Arial" panose="020B0604020202020204" pitchFamily="34" charset="0"/>
-                <a:cs typeface="Arial" panose="020B0604020202020204" pitchFamily="34" charset="0"/>
-              </a:rPr>
-              <a:t>Unnecessary repair: 26/113 (23.01%) </a:t>
-            </a:r>
-          </a:p>
-          <a:p>
-            <a:r>
-              <a:rPr lang="en-US" altLang="zh-CN" sz="2000" dirty="0">
-                <a:latin typeface="Arial" panose="020B0604020202020204" pitchFamily="34" charset="0"/>
-                <a:cs typeface="Arial" panose="020B0604020202020204" pitchFamily="34" charset="0"/>
-              </a:rPr>
-              <a:t>Avg token cost pre question: 4182.46</a:t>
-            </a:r>
-          </a:p>
-          <a:p>
-            <a:r>
-              <a:rPr lang="en-US" altLang="zh-CN" sz="2000" dirty="0">
-                <a:latin typeface="Arial" panose="020B0604020202020204" pitchFamily="34" charset="0"/>
-                <a:cs typeface="Arial" panose="020B0604020202020204" pitchFamily="34" charset="0"/>
-              </a:rPr>
-              <a:t>Avg time cost pre question: 143.3823s</a:t>
-            </a:r>
-          </a:p>
-        </p:txBody>
-      </p:sp>
-    </p:spTree>
-    <p:extLst>
-      <p:ext uri="{BB962C8B-B14F-4D97-AF65-F5344CB8AC3E}">
-        <p14:creationId xmlns:p14="http://schemas.microsoft.com/office/powerpoint/2010/main" val="3565263887"/>
-      </p:ext>
-    </p:extLst>
-  </p:cSld>
-  <p:clrMapOvr>
-    <a:masterClrMapping/>
-  </p:clrMapOvr>
-</p:sld>
-</file>
-
-<file path=ppt/slides/slide6.xml><?xml version="1.0" encoding="utf-8"?>
-<p:sld xmlns:a="http://schemas.openxmlformats.org/drawingml/2006/main" xmlns:r="http://schemas.openxmlformats.org/officeDocument/2006/relationships" xmlns:p="http://schemas.openxmlformats.org/presentationml/2006/main" show="0">
-  <p:cSld>
-    <p:spTree>
-      <p:nvGrpSpPr>
-        <p:cNvPr id="1" name="">
-          <a:extLst>
-            <a:ext uri="{FF2B5EF4-FFF2-40B4-BE49-F238E27FC236}">
-              <a16:creationId xmlns:a16="http://schemas.microsoft.com/office/drawing/2014/main" id="{7DB12D75-5FB7-D508-FD21-61C12C559665}"/>
-            </a:ext>
-          </a:extLst>
-        </p:cNvPr>
-        <p:cNvGrpSpPr/>
-        <p:nvPr/>
-      </p:nvGrpSpPr>
-      <p:grpSpPr>
-        <a:xfrm>
-          <a:off x="0" y="0"/>
-          <a:ext cx="0" cy="0"/>
-          <a:chOff x="0" y="0"/>
-          <a:chExt cx="0" cy="0"/>
-        </a:xfrm>
-      </p:grpSpPr>
-      <p:sp>
-        <p:nvSpPr>
-          <p:cNvPr id="4" name="文本框 3">
-            <a:extLst>
-              <a:ext uri="{FF2B5EF4-FFF2-40B4-BE49-F238E27FC236}">
-                <a16:creationId xmlns:a16="http://schemas.microsoft.com/office/drawing/2014/main" id="{53B29AC9-E649-A6F2-DEAA-169F40FF0A5F}"/>
-              </a:ext>
-            </a:extLst>
-          </p:cNvPr>
-          <p:cNvSpPr txBox="1"/>
-          <p:nvPr/>
-        </p:nvSpPr>
-        <p:spPr>
-          <a:xfrm>
-            <a:off x="488956" y="0"/>
-            <a:ext cx="10890245" cy="6924973"/>
-          </a:xfrm>
-          <a:prstGeom prst="rect">
-            <a:avLst/>
-          </a:prstGeom>
-          <a:noFill/>
-        </p:spPr>
-        <p:txBody>
-          <a:bodyPr wrap="square" rtlCol="0">
-            <a:spAutoFit/>
-          </a:bodyPr>
-          <a:lstStyle/>
-          <a:p>
-            <a:r>
-              <a:rPr lang="en-US" altLang="zh-CN" sz="2400" b="1" dirty="0">
-                <a:latin typeface="Arial" panose="020B0604020202020204" pitchFamily="34" charset="0"/>
-                <a:cs typeface="Arial" panose="020B0604020202020204" pitchFamily="34" charset="0"/>
-              </a:rPr>
-              <a:t>Experiment results </a:t>
-            </a:r>
-            <a:r>
-              <a:rPr lang="en-US" altLang="zh-CN" sz="2400" b="1">
-                <a:latin typeface="Arial" panose="020B0604020202020204" pitchFamily="34" charset="0"/>
-                <a:cs typeface="Arial" panose="020B0604020202020204" pitchFamily="34" charset="0"/>
-              </a:rPr>
-              <a:t>on gpt-5:</a:t>
-            </a:r>
-            <a:endParaRPr lang="en-US" altLang="zh-CN" sz="2400" b="1" dirty="0">
-              <a:latin typeface="Arial" panose="020B0604020202020204" pitchFamily="34" charset="0"/>
-              <a:cs typeface="Arial" panose="020B0604020202020204" pitchFamily="34" charset="0"/>
-            </a:endParaRPr>
-          </a:p>
-          <a:p>
-            <a:r>
-              <a:rPr lang="en-US" altLang="zh-CN" sz="2000" b="1" dirty="0">
-                <a:latin typeface="Arial" panose="020B0604020202020204" pitchFamily="34" charset="0"/>
-                <a:cs typeface="Arial" panose="020B0604020202020204" pitchFamily="34" charset="0"/>
-              </a:rPr>
-              <a:t>Our</a:t>
-            </a:r>
-            <a:r>
-              <a:rPr lang="zh-CN" altLang="en-US" sz="2000" b="1" dirty="0">
-                <a:latin typeface="Arial" panose="020B0604020202020204" pitchFamily="34" charset="0"/>
-                <a:cs typeface="Arial" panose="020B0604020202020204" pitchFamily="34" charset="0"/>
-              </a:rPr>
-              <a:t> </a:t>
-            </a:r>
-            <a:r>
-              <a:rPr lang="en-US" altLang="zh-CN" sz="2000" b="1" dirty="0">
-                <a:latin typeface="Arial" panose="020B0604020202020204" pitchFamily="34" charset="0"/>
-                <a:cs typeface="Arial" panose="020B0604020202020204" pitchFamily="34" charset="0"/>
-              </a:rPr>
-              <a:t>approach:</a:t>
-            </a:r>
-            <a:r>
-              <a:rPr lang="zh-CN" altLang="en-US" sz="2000" b="1" dirty="0">
-                <a:latin typeface="Arial" panose="020B0604020202020204" pitchFamily="34" charset="0"/>
-                <a:cs typeface="Arial" panose="020B0604020202020204" pitchFamily="34" charset="0"/>
-              </a:rPr>
-              <a:t> </a:t>
-            </a:r>
-            <a:endParaRPr lang="en-US" altLang="zh-CN" sz="2000" b="1" dirty="0">
-              <a:latin typeface="Arial" panose="020B0604020202020204" pitchFamily="34" charset="0"/>
-              <a:cs typeface="Arial" panose="020B0604020202020204" pitchFamily="34" charset="0"/>
-            </a:endParaRPr>
-          </a:p>
-          <a:p>
-            <a:r>
-              <a:rPr lang="en-US" altLang="zh-CN" sz="2000" dirty="0">
-                <a:latin typeface="Arial" panose="020B0604020202020204" pitchFamily="34" charset="0"/>
-                <a:cs typeface="Arial" panose="020B0604020202020204" pitchFamily="34" charset="0"/>
-              </a:rPr>
-              <a:t>Total hallucination after repair: 35/220 (50% -&gt; 15.91%) </a:t>
-            </a:r>
-          </a:p>
-          <a:p>
-            <a:r>
-              <a:rPr lang="en-US" altLang="zh-CN" sz="2000" dirty="0">
-                <a:latin typeface="Arial" panose="020B0604020202020204" pitchFamily="34" charset="0"/>
-                <a:cs typeface="Arial" panose="020B0604020202020204" pitchFamily="34" charset="0"/>
-              </a:rPr>
-              <a:t>Hallucination repair: 92/109 (84.40%), unsuccessful repair: 9/109 (8.26%), unable repair: 8/109 (7.34%) </a:t>
-            </a:r>
-          </a:p>
-          <a:p>
-            <a:r>
-              <a:rPr lang="en-US" altLang="zh-CN" sz="2000" dirty="0">
-                <a:latin typeface="Arial" panose="020B0604020202020204" pitchFamily="34" charset="0"/>
-                <a:cs typeface="Arial" panose="020B0604020202020204" pitchFamily="34" charset="0"/>
-              </a:rPr>
-              <a:t>Unnecessary repair: 20/111 (18.02%)</a:t>
-            </a:r>
-          </a:p>
-          <a:p>
-            <a:r>
-              <a:rPr lang="en-US" altLang="zh-CN" sz="2000" dirty="0">
-                <a:latin typeface="Arial" panose="020B0604020202020204" pitchFamily="34" charset="0"/>
-                <a:cs typeface="Arial" panose="020B0604020202020204" pitchFamily="34" charset="0"/>
-              </a:rPr>
-              <a:t>Avg token cost pre question: 289.43</a:t>
-            </a:r>
-          </a:p>
-          <a:p>
-            <a:r>
-              <a:rPr lang="en-US" altLang="zh-CN" sz="2000" dirty="0">
-                <a:latin typeface="Arial" panose="020B0604020202020204" pitchFamily="34" charset="0"/>
-                <a:cs typeface="Arial" panose="020B0604020202020204" pitchFamily="34" charset="0"/>
-              </a:rPr>
-              <a:t>Avg time cost pre question: 1.4267s</a:t>
-            </a:r>
-          </a:p>
-          <a:p>
-            <a:endParaRPr lang="en-US" altLang="zh-CN" sz="2000" dirty="0">
-              <a:latin typeface="Arial" panose="020B0604020202020204" pitchFamily="34" charset="0"/>
-              <a:cs typeface="Arial" panose="020B0604020202020204" pitchFamily="34" charset="0"/>
-            </a:endParaRPr>
-          </a:p>
-          <a:p>
-            <a:r>
-              <a:rPr lang="en-US" altLang="zh-CN" sz="2000" b="1" dirty="0" err="1">
-                <a:latin typeface="Arial" panose="020B0604020202020204" pitchFamily="34" charset="0"/>
-                <a:cs typeface="Arial" panose="020B0604020202020204" pitchFamily="34" charset="0"/>
-              </a:rPr>
-              <a:t>CoT</a:t>
-            </a:r>
-            <a:r>
-              <a:rPr lang="en-US" altLang="zh-CN" sz="2000" b="1" dirty="0">
-                <a:latin typeface="Arial" panose="020B0604020202020204" pitchFamily="34" charset="0"/>
-                <a:cs typeface="Arial" panose="020B0604020202020204" pitchFamily="34" charset="0"/>
-              </a:rPr>
-              <a:t>:</a:t>
-            </a:r>
-          </a:p>
-          <a:p>
-            <a:r>
-              <a:rPr lang="en-US" altLang="zh-CN" sz="2000" dirty="0">
-                <a:latin typeface="Arial" panose="020B0604020202020204" pitchFamily="34" charset="0"/>
-                <a:cs typeface="Arial" panose="020B0604020202020204" pitchFamily="34" charset="0"/>
-              </a:rPr>
-              <a:t>Total hallucination after repair: 89/224 (50%-&gt; 39.73%)</a:t>
-            </a:r>
-          </a:p>
-          <a:p>
-            <a:r>
-              <a:rPr lang="en-US" altLang="zh-CN" sz="2000" dirty="0">
-                <a:latin typeface="Arial" panose="020B0604020202020204" pitchFamily="34" charset="0"/>
-                <a:cs typeface="Arial" panose="020B0604020202020204" pitchFamily="34" charset="0"/>
-              </a:rPr>
-              <a:t>Hallucination repair: 54/111 (48.65%), unsuccessful repair: 57/111 (51.35%)</a:t>
-            </a:r>
-          </a:p>
-          <a:p>
-            <a:r>
-              <a:rPr lang="en-US" altLang="zh-CN" sz="2000" dirty="0">
-                <a:latin typeface="Arial" panose="020B0604020202020204" pitchFamily="34" charset="0"/>
-                <a:cs typeface="Arial" panose="020B0604020202020204" pitchFamily="34" charset="0"/>
-              </a:rPr>
-              <a:t>Unnecessary repair: 32/113 (28.32%)</a:t>
-            </a:r>
-          </a:p>
-          <a:p>
-            <a:r>
-              <a:rPr lang="en-US" altLang="zh-CN" sz="2000" dirty="0">
-                <a:latin typeface="Arial" panose="020B0604020202020204" pitchFamily="34" charset="0"/>
-                <a:cs typeface="Arial" panose="020B0604020202020204" pitchFamily="34" charset="0"/>
-              </a:rPr>
-              <a:t>Avg token cost pre question: 2560.37</a:t>
-            </a:r>
-          </a:p>
-          <a:p>
-            <a:r>
-              <a:rPr lang="en-US" altLang="zh-CN" sz="2000" dirty="0">
-                <a:latin typeface="Arial" panose="020B0604020202020204" pitchFamily="34" charset="0"/>
-                <a:cs typeface="Arial" panose="020B0604020202020204" pitchFamily="34" charset="0"/>
-              </a:rPr>
-              <a:t>Avg time cost pre question: 20.6160s</a:t>
-            </a:r>
-          </a:p>
-          <a:p>
-            <a:endParaRPr lang="en-US" altLang="zh-CN" sz="2000" dirty="0">
-              <a:latin typeface="Arial" panose="020B0604020202020204" pitchFamily="34" charset="0"/>
-              <a:cs typeface="Arial" panose="020B0604020202020204" pitchFamily="34" charset="0"/>
-            </a:endParaRPr>
-          </a:p>
-          <a:p>
-            <a:r>
-              <a:rPr lang="en-US" altLang="zh-CN" sz="2000" b="1" dirty="0" err="1">
-                <a:latin typeface="Arial" panose="020B0604020202020204" pitchFamily="34" charset="0"/>
-                <a:cs typeface="Arial" panose="020B0604020202020204" pitchFamily="34" charset="0"/>
-              </a:rPr>
-              <a:t>CoVe</a:t>
-            </a:r>
-            <a:r>
-              <a:rPr lang="en-US" altLang="zh-CN" sz="2000" b="1" dirty="0">
-                <a:latin typeface="Arial" panose="020B0604020202020204" pitchFamily="34" charset="0"/>
-                <a:cs typeface="Arial" panose="020B0604020202020204" pitchFamily="34" charset="0"/>
-              </a:rPr>
-              <a:t>:</a:t>
-            </a:r>
-          </a:p>
-          <a:p>
-            <a:r>
-              <a:rPr lang="en-US" altLang="zh-CN" sz="2000" dirty="0">
-                <a:latin typeface="Arial" panose="020B0604020202020204" pitchFamily="34" charset="0"/>
-                <a:cs typeface="Arial" panose="020B0604020202020204" pitchFamily="34" charset="0"/>
-              </a:rPr>
-              <a:t>Total hallucination after repair: 92/224 (50%-&gt; 41.07%)</a:t>
-            </a:r>
-          </a:p>
-          <a:p>
-            <a:r>
-              <a:rPr lang="en-US" altLang="zh-CN" sz="2000" dirty="0">
-                <a:latin typeface="Arial" panose="020B0604020202020204" pitchFamily="34" charset="0"/>
-                <a:cs typeface="Arial" panose="020B0604020202020204" pitchFamily="34" charset="0"/>
-              </a:rPr>
-              <a:t>Hallucination repair: 45/112 (40.54%), unsuccessful repair: 66/111 (59.46%)</a:t>
-            </a:r>
-          </a:p>
-          <a:p>
-            <a:r>
-              <a:rPr lang="en-US" altLang="zh-CN" sz="2000" dirty="0">
-                <a:latin typeface="Arial" panose="020B0604020202020204" pitchFamily="34" charset="0"/>
-                <a:cs typeface="Arial" panose="020B0604020202020204" pitchFamily="34" charset="0"/>
-              </a:rPr>
-              <a:t>Unnecessary repair: 26/113 (23.01%) </a:t>
-            </a:r>
-          </a:p>
-          <a:p>
-            <a:r>
-              <a:rPr lang="en-US" altLang="zh-CN" sz="2000" dirty="0">
-                <a:latin typeface="Arial" panose="020B0604020202020204" pitchFamily="34" charset="0"/>
-                <a:cs typeface="Arial" panose="020B0604020202020204" pitchFamily="34" charset="0"/>
-              </a:rPr>
-              <a:t>Avg token cost pre question: 4182.46</a:t>
-            </a:r>
-          </a:p>
-          <a:p>
-            <a:r>
-              <a:rPr lang="en-US" altLang="zh-CN" sz="2000" dirty="0">
-                <a:latin typeface="Arial" panose="020B0604020202020204" pitchFamily="34" charset="0"/>
-                <a:cs typeface="Arial" panose="020B0604020202020204" pitchFamily="34" charset="0"/>
-              </a:rPr>
-              <a:t>Avg time cost pre question: 143.3823s</a:t>
-            </a:r>
-          </a:p>
-        </p:txBody>
-      </p:sp>
-    </p:spTree>
-    <p:extLst>
-      <p:ext uri="{BB962C8B-B14F-4D97-AF65-F5344CB8AC3E}">
-        <p14:creationId xmlns:p14="http://schemas.microsoft.com/office/powerpoint/2010/main" val="2458217212"/>
       </p:ext>
     </p:extLst>
   </p:cSld>
@@ -6005,10 +6049,10 @@
       </p:grpSpPr>
       <p:sp>
         <p:nvSpPr>
-          <p:cNvPr id="4" name="文本框 3">
-            <a:extLst>
-              <a:ext uri="{FF2B5EF4-FFF2-40B4-BE49-F238E27FC236}">
-                <a16:creationId xmlns:a16="http://schemas.microsoft.com/office/drawing/2014/main" id="{C492F690-233A-A801-D794-02C398189544}"/>
+          <p:cNvPr id="2" name="文本框 1">
+            <a:extLst>
+              <a:ext uri="{FF2B5EF4-FFF2-40B4-BE49-F238E27FC236}">
+                <a16:creationId xmlns:a16="http://schemas.microsoft.com/office/drawing/2014/main" id="{BEBDEBA0-48D9-0570-3AD8-8CC23F54EAC7}"/>
               </a:ext>
             </a:extLst>
           </p:cNvPr>
@@ -6018,7 +6062,7 @@
         <p:spPr>
           <a:xfrm>
             <a:off x="479719" y="151179"/>
-            <a:ext cx="11232562" cy="461665"/>
+            <a:ext cx="11219222" cy="4154984"/>
           </a:xfrm>
           <a:prstGeom prst="rect">
             <a:avLst/>
@@ -6032,11 +6076,140 @@
           <a:lstStyle/>
           <a:p>
             <a:r>
-              <a:rPr lang="en-US" altLang="zh-CN" sz="2400" b="1" dirty="0">
-                <a:latin typeface="Arial" panose="020B0604020202020204" pitchFamily="34" charset="0"/>
-                <a:cs typeface="Arial" panose="020B0604020202020204" pitchFamily="34" charset="0"/>
-              </a:rPr>
-              <a:t>Conclusion and TODO List:</a:t>
+              <a:rPr lang="en-US" altLang="zh-CN" sz="3200" dirty="0">
+                <a:latin typeface="Arial" panose="020B0604020202020204" pitchFamily="34" charset="0"/>
+                <a:cs typeface="Arial" panose="020B0604020202020204" pitchFamily="34" charset="0"/>
+              </a:rPr>
+              <a:t>Conclusion</a:t>
+            </a:r>
+          </a:p>
+          <a:p>
+            <a:r>
+              <a:rPr lang="en-US" altLang="zh-CN" sz="2000" dirty="0">
+                <a:latin typeface="Arial" panose="020B0604020202020204" pitchFamily="34" charset="0"/>
+                <a:cs typeface="Arial" panose="020B0604020202020204" pitchFamily="34" charset="0"/>
+              </a:rPr>
+              <a:t>1. Our approach outperformed other approaches on gpt-4o and gpt-5, when using mutations, we could even perform better.</a:t>
+            </a:r>
+          </a:p>
+          <a:p>
+            <a:r>
+              <a:rPr lang="en-US" altLang="zh-CN" sz="2000" dirty="0">
+                <a:latin typeface="Arial" panose="020B0604020202020204" pitchFamily="34" charset="0"/>
+                <a:cs typeface="Arial" panose="020B0604020202020204" pitchFamily="34" charset="0"/>
+              </a:rPr>
+              <a:t>2. Consider the usage of tokens and time, our approach spent less time and tokens than </a:t>
+            </a:r>
+            <a:r>
+              <a:rPr lang="en-US" altLang="zh-CN" sz="2000" dirty="0" err="1">
+                <a:latin typeface="Arial" panose="020B0604020202020204" pitchFamily="34" charset="0"/>
+                <a:cs typeface="Arial" panose="020B0604020202020204" pitchFamily="34" charset="0"/>
+              </a:rPr>
+              <a:t>CoVe</a:t>
+            </a:r>
+            <a:r>
+              <a:rPr lang="en-US" altLang="zh-CN" sz="2000" dirty="0">
+                <a:latin typeface="Arial" panose="020B0604020202020204" pitchFamily="34" charset="0"/>
+                <a:cs typeface="Arial" panose="020B0604020202020204" pitchFamily="34" charset="0"/>
+              </a:rPr>
+              <a:t>.</a:t>
+            </a:r>
+          </a:p>
+          <a:p>
+            <a:endParaRPr lang="en-US" altLang="zh-CN" sz="2000" dirty="0">
+              <a:latin typeface="Arial" panose="020B0604020202020204" pitchFamily="34" charset="0"/>
+              <a:cs typeface="Arial" panose="020B0604020202020204" pitchFamily="34" charset="0"/>
+            </a:endParaRPr>
+          </a:p>
+          <a:p>
+            <a:r>
+              <a:rPr lang="en-US" altLang="zh-CN" sz="3200" dirty="0">
+                <a:latin typeface="Arial" panose="020B0604020202020204" pitchFamily="34" charset="0"/>
+                <a:cs typeface="Arial" panose="020B0604020202020204" pitchFamily="34" charset="0"/>
+              </a:rPr>
+              <a:t>TODO list</a:t>
+            </a:r>
+          </a:p>
+          <a:p>
+            <a:r>
+              <a:rPr lang="en-US" altLang="zh-CN" sz="2000" dirty="0">
+                <a:latin typeface="Arial" panose="020B0604020202020204" pitchFamily="34" charset="0"/>
+                <a:cs typeface="Arial" panose="020B0604020202020204" pitchFamily="34" charset="0"/>
+              </a:rPr>
+              <a:t>1. Any other experiment parameters could be involved in?</a:t>
+            </a:r>
+          </a:p>
+          <a:p>
+            <a:r>
+              <a:rPr lang="en-US" altLang="zh-CN" sz="2000" dirty="0">
+                <a:latin typeface="Arial" panose="020B0604020202020204" pitchFamily="34" charset="0"/>
+                <a:cs typeface="Arial" panose="020B0604020202020204" pitchFamily="34" charset="0"/>
+              </a:rPr>
+              <a:t>2. Find SOTA method using </a:t>
+            </a:r>
+            <a:r>
+              <a:rPr lang="en-US" altLang="zh-CN" sz="2000" dirty="0" err="1">
+                <a:latin typeface="Arial" panose="020B0604020202020204" pitchFamily="34" charset="0"/>
+                <a:cs typeface="Arial" panose="020B0604020202020204" pitchFamily="34" charset="0"/>
+              </a:rPr>
+              <a:t>CoT</a:t>
+            </a:r>
+            <a:r>
+              <a:rPr lang="en-US" altLang="zh-CN" sz="2000" dirty="0">
+                <a:latin typeface="Arial" panose="020B0604020202020204" pitchFamily="34" charset="0"/>
+                <a:cs typeface="Arial" panose="020B0604020202020204" pitchFamily="34" charset="0"/>
+              </a:rPr>
+              <a:t>/</a:t>
+            </a:r>
+            <a:r>
+              <a:rPr lang="en-US" altLang="zh-CN" sz="2000" dirty="0" err="1">
+                <a:latin typeface="Arial" panose="020B0604020202020204" pitchFamily="34" charset="0"/>
+                <a:cs typeface="Arial" panose="020B0604020202020204" pitchFamily="34" charset="0"/>
+              </a:rPr>
+              <a:t>CoVe</a:t>
+            </a:r>
+            <a:r>
+              <a:rPr lang="en-US" altLang="zh-CN" sz="2000" dirty="0">
+                <a:latin typeface="Arial" panose="020B0604020202020204" pitchFamily="34" charset="0"/>
+                <a:cs typeface="Arial" panose="020B0604020202020204" pitchFamily="34" charset="0"/>
+              </a:rPr>
+              <a:t> + RAG</a:t>
+            </a:r>
+          </a:p>
+          <a:p>
+            <a:r>
+              <a:rPr lang="en-US" altLang="zh-CN" sz="2000" dirty="0">
+                <a:latin typeface="Arial" panose="020B0604020202020204" pitchFamily="34" charset="0"/>
+                <a:cs typeface="Arial" panose="020B0604020202020204" pitchFamily="34" charset="0"/>
+              </a:rPr>
+              <a:t>3. Discuss whether our approach should use RAG</a:t>
+            </a:r>
+          </a:p>
+          <a:p>
+            <a:r>
+              <a:rPr lang="en-US" altLang="zh-CN" sz="2000" dirty="0">
+                <a:latin typeface="Arial" panose="020B0604020202020204" pitchFamily="34" charset="0"/>
+                <a:cs typeface="Arial" panose="020B0604020202020204" pitchFamily="34" charset="0"/>
+              </a:rPr>
+              <a:t>4. Extend experiments on LlaMa3(open-sourced) and Gemini/Claude (closed-sourced)</a:t>
+            </a:r>
+          </a:p>
+          <a:p>
+            <a:r>
+              <a:rPr lang="en-US" altLang="zh-CN" sz="2000" dirty="0">
+                <a:latin typeface="Arial" panose="020B0604020202020204" pitchFamily="34" charset="0"/>
+                <a:cs typeface="Arial" panose="020B0604020202020204" pitchFamily="34" charset="0"/>
+              </a:rPr>
+              <a:t>5. Build experiments on the influence of LLM temperature in baseline (FSE25 rebuttal)</a:t>
+            </a:r>
+          </a:p>
+          <a:p>
+            <a:r>
+              <a:rPr lang="en-US" altLang="zh-CN" sz="2000" dirty="0">
+                <a:latin typeface="Arial" panose="020B0604020202020204" pitchFamily="34" charset="0"/>
+                <a:cs typeface="Arial" panose="020B0604020202020204" pitchFamily="34" charset="0"/>
+              </a:rPr>
+              <a:t>6. Build dataset of final large-scale experiments</a:t>
             </a:r>
           </a:p>
         </p:txBody>

</xml_diff>

<commit_message>
Update cove diagram and related slide
Revised the cove.drawio diagram to clarify that the process involves verification questions of entities in both question and response, replacing the previous 'background' wording. Updated the corresponding PNG and PowerPoint slide to reflect these changes for improved accuracy and presentation.
</commit_message>
<xml_diff>
--- a/slides/20251113.pptx
+++ b/slides/20251113.pptx
@@ -265,7 +265,7 @@
           <a:p>
             <a:fld id="{3F567BA6-CBC2-4FF0-810E-3ED1BF2C4381}" type="datetimeFigureOut">
               <a:rPr lang="zh-CN" altLang="en-US" smtClean="0"/>
-              <a:t>2025/11/25</a:t>
+              <a:t>2025/11/27</a:t>
             </a:fld>
             <a:endParaRPr lang="zh-CN" altLang="en-US"/>
           </a:p>
@@ -463,7 +463,7 @@
           <a:p>
             <a:fld id="{3F567BA6-CBC2-4FF0-810E-3ED1BF2C4381}" type="datetimeFigureOut">
               <a:rPr lang="zh-CN" altLang="en-US" smtClean="0"/>
-              <a:t>2025/11/25</a:t>
+              <a:t>2025/11/27</a:t>
             </a:fld>
             <a:endParaRPr lang="zh-CN" altLang="en-US"/>
           </a:p>
@@ -671,7 +671,7 @@
           <a:p>
             <a:fld id="{3F567BA6-CBC2-4FF0-810E-3ED1BF2C4381}" type="datetimeFigureOut">
               <a:rPr lang="zh-CN" altLang="en-US" smtClean="0"/>
-              <a:t>2025/11/25</a:t>
+              <a:t>2025/11/27</a:t>
             </a:fld>
             <a:endParaRPr lang="zh-CN" altLang="en-US"/>
           </a:p>
@@ -869,7 +869,7 @@
           <a:p>
             <a:fld id="{3F567BA6-CBC2-4FF0-810E-3ED1BF2C4381}" type="datetimeFigureOut">
               <a:rPr lang="zh-CN" altLang="en-US" smtClean="0"/>
-              <a:t>2025/11/25</a:t>
+              <a:t>2025/11/27</a:t>
             </a:fld>
             <a:endParaRPr lang="zh-CN" altLang="en-US"/>
           </a:p>
@@ -1144,7 +1144,7 @@
           <a:p>
             <a:fld id="{3F567BA6-CBC2-4FF0-810E-3ED1BF2C4381}" type="datetimeFigureOut">
               <a:rPr lang="zh-CN" altLang="en-US" smtClean="0"/>
-              <a:t>2025/11/25</a:t>
+              <a:t>2025/11/27</a:t>
             </a:fld>
             <a:endParaRPr lang="zh-CN" altLang="en-US"/>
           </a:p>
@@ -1409,7 +1409,7 @@
           <a:p>
             <a:fld id="{3F567BA6-CBC2-4FF0-810E-3ED1BF2C4381}" type="datetimeFigureOut">
               <a:rPr lang="zh-CN" altLang="en-US" smtClean="0"/>
-              <a:t>2025/11/25</a:t>
+              <a:t>2025/11/27</a:t>
             </a:fld>
             <a:endParaRPr lang="zh-CN" altLang="en-US"/>
           </a:p>
@@ -1821,7 +1821,7 @@
           <a:p>
             <a:fld id="{3F567BA6-CBC2-4FF0-810E-3ED1BF2C4381}" type="datetimeFigureOut">
               <a:rPr lang="zh-CN" altLang="en-US" smtClean="0"/>
-              <a:t>2025/11/25</a:t>
+              <a:t>2025/11/27</a:t>
             </a:fld>
             <a:endParaRPr lang="zh-CN" altLang="en-US"/>
           </a:p>
@@ -1962,7 +1962,7 @@
           <a:p>
             <a:fld id="{3F567BA6-CBC2-4FF0-810E-3ED1BF2C4381}" type="datetimeFigureOut">
               <a:rPr lang="zh-CN" altLang="en-US" smtClean="0"/>
-              <a:t>2025/11/25</a:t>
+              <a:t>2025/11/27</a:t>
             </a:fld>
             <a:endParaRPr lang="zh-CN" altLang="en-US"/>
           </a:p>
@@ -2075,7 +2075,7 @@
           <a:p>
             <a:fld id="{3F567BA6-CBC2-4FF0-810E-3ED1BF2C4381}" type="datetimeFigureOut">
               <a:rPr lang="zh-CN" altLang="en-US" smtClean="0"/>
-              <a:t>2025/11/25</a:t>
+              <a:t>2025/11/27</a:t>
             </a:fld>
             <a:endParaRPr lang="zh-CN" altLang="en-US"/>
           </a:p>
@@ -2386,7 +2386,7 @@
           <a:p>
             <a:fld id="{3F567BA6-CBC2-4FF0-810E-3ED1BF2C4381}" type="datetimeFigureOut">
               <a:rPr lang="zh-CN" altLang="en-US" smtClean="0"/>
-              <a:t>2025/11/25</a:t>
+              <a:t>2025/11/27</a:t>
             </a:fld>
             <a:endParaRPr lang="zh-CN" altLang="en-US"/>
           </a:p>
@@ -2674,7 +2674,7 @@
           <a:p>
             <a:fld id="{3F567BA6-CBC2-4FF0-810E-3ED1BF2C4381}" type="datetimeFigureOut">
               <a:rPr lang="zh-CN" altLang="en-US" smtClean="0"/>
-              <a:t>2025/11/25</a:t>
+              <a:t>2025/11/27</a:t>
             </a:fld>
             <a:endParaRPr lang="zh-CN" altLang="en-US"/>
           </a:p>
@@ -2915,7 +2915,7 @@
           <a:p>
             <a:fld id="{3F567BA6-CBC2-4FF0-810E-3ED1BF2C4381}" type="datetimeFigureOut">
               <a:rPr lang="zh-CN" altLang="en-US" smtClean="0"/>
-              <a:t>2025/11/25</a:t>
+              <a:t>2025/11/27</a:t>
             </a:fld>
             <a:endParaRPr lang="zh-CN" altLang="en-US"/>
           </a:p>
@@ -3592,8 +3592,20 @@
                 <a:latin typeface="Arial" panose="020B0604020202020204" pitchFamily="34" charset="0"/>
                 <a:cs typeface="Arial" panose="020B0604020202020204" pitchFamily="34" charset="0"/>
               </a:rPr>
-              <a:t> idea</a:t>
-            </a:r>
+              <a:t> idea </a:t>
+            </a:r>
+            <a:r>
+              <a:rPr lang="en-US" altLang="zh-CN" sz="2000" dirty="0">
+                <a:latin typeface="Arial" panose="020B0604020202020204" pitchFamily="34" charset="0"/>
+                <a:cs typeface="Arial" panose="020B0604020202020204" pitchFamily="34" charset="0"/>
+                <a:hlinkClick r:id="rId2"/>
+              </a:rPr>
+              <a:t>https://arxiv.org/pdf/2201.11903</a:t>
+            </a:r>
+            <a:endParaRPr lang="en-US" altLang="zh-CN" sz="2000" dirty="0">
+              <a:latin typeface="Arial" panose="020B0604020202020204" pitchFamily="34" charset="0"/>
+              <a:cs typeface="Arial" panose="020B0604020202020204" pitchFamily="34" charset="0"/>
+            </a:endParaRPr>
           </a:p>
           <a:p>
             <a:r>
@@ -3650,7 +3662,7 @@
               <a:rPr lang="en-US" altLang="zh-CN" sz="2000" dirty="0">
                 <a:latin typeface="Arial" panose="020B0604020202020204" pitchFamily="34" charset="0"/>
                 <a:cs typeface="Arial" panose="020B0604020202020204" pitchFamily="34" charset="0"/>
-                <a:hlinkClick r:id="rId2"/>
+                <a:hlinkClick r:id="rId3"/>
               </a:rPr>
               <a:t>https://arxiv.org/pdf/2309.11495</a:t>
             </a:r>
@@ -3681,10 +3693,10 @@
       </p:sp>
       <p:pic>
         <p:nvPicPr>
-          <p:cNvPr id="3" name="图片 2" descr="图示&#10;&#10;AI 生成的内容可能不正确。">
-            <a:extLst>
-              <a:ext uri="{FF2B5EF4-FFF2-40B4-BE49-F238E27FC236}">
-                <a16:creationId xmlns:a16="http://schemas.microsoft.com/office/drawing/2014/main" id="{563B55FC-64E1-8BC1-67F1-26355938CAED}"/>
+          <p:cNvPr id="5" name="图片 4" descr="图示&#10;&#10;AI 生成的内容可能不正确。">
+            <a:extLst>
+              <a:ext uri="{FF2B5EF4-FFF2-40B4-BE49-F238E27FC236}">
+                <a16:creationId xmlns:a16="http://schemas.microsoft.com/office/drawing/2014/main" id="{5386AB0F-D9EC-A301-6DDD-43BA8C70221E}"/>
               </a:ext>
             </a:extLst>
           </p:cNvPr>
@@ -3694,7 +3706,7 @@
           <p:nvPr/>
         </p:nvPicPr>
         <p:blipFill>
-          <a:blip r:embed="rId3">
+          <a:blip r:embed="rId4">
             <a:extLst>
               <a:ext uri="{28A0092B-C50C-407E-A947-70E740481C1C}">
                 <a14:useLocalDpi xmlns:a14="http://schemas.microsoft.com/office/drawing/2010/main" val="0"/>
@@ -3891,7 +3903,21 @@
                 <a:latin typeface="Arial" panose="020B0604020202020204" pitchFamily="34" charset="0"/>
                 <a:cs typeface="Arial" panose="020B0604020202020204" pitchFamily="34" charset="0"/>
               </a:rPr>
-              <a:t>(chain-of-thought), </a:t>
+              <a:t>(chain-of-thought, Google </a:t>
+            </a:r>
+            <a:r>
+              <a:rPr lang="en-US" altLang="zh-CN" sz="2000" dirty="0" err="1">
+                <a:latin typeface="Arial" panose="020B0604020202020204" pitchFamily="34" charset="0"/>
+                <a:cs typeface="Arial" panose="020B0604020202020204" pitchFamily="34" charset="0"/>
+              </a:rPr>
+              <a:t>Reseach</a:t>
+            </a:r>
+            <a:r>
+              <a:rPr lang="en-US" altLang="zh-CN" sz="2000" dirty="0">
+                <a:latin typeface="Arial" panose="020B0604020202020204" pitchFamily="34" charset="0"/>
+                <a:cs typeface="Arial" panose="020B0604020202020204" pitchFamily="34" charset="0"/>
+              </a:rPr>
+              <a:t>), </a:t>
             </a:r>
             <a:r>
               <a:rPr lang="en-US" altLang="zh-CN" sz="2000" dirty="0" err="1">
@@ -3939,11 +3965,18 @@
           </a:p>
           <a:p>
             <a:r>
-              <a:rPr lang="en-US" altLang="zh-CN" sz="2000" dirty="0">
-                <a:latin typeface="Arial" panose="020B0604020202020204" pitchFamily="34" charset="0"/>
-                <a:cs typeface="Arial" panose="020B0604020202020204" pitchFamily="34" charset="0"/>
-              </a:rPr>
-              <a:t>Total hallucination after repair: </a:t>
+              <a:rPr lang="en-US" altLang="zh-CN" sz="2000">
+                <a:latin typeface="Arial" panose="020B0604020202020204" pitchFamily="34" charset="0"/>
+                <a:cs typeface="Arial" panose="020B0604020202020204" pitchFamily="34" charset="0"/>
+              </a:rPr>
+              <a:t>hallucination rate after </a:t>
+            </a:r>
+            <a:r>
+              <a:rPr lang="en-US" altLang="zh-CN" sz="2000" dirty="0">
+                <a:latin typeface="Arial" panose="020B0604020202020204" pitchFamily="34" charset="0"/>
+                <a:cs typeface="Arial" panose="020B0604020202020204" pitchFamily="34" charset="0"/>
+              </a:rPr>
+              <a:t>repair: </a:t>
             </a:r>
             <a:r>
               <a:rPr lang="en-US" altLang="zh-CN" sz="2000" dirty="0">
@@ -4330,7 +4363,7 @@
           </a:p>
           <a:p>
             <a:r>
-              <a:rPr lang="en-US" altLang="zh-CN" sz="2400" dirty="0">
+              <a:rPr lang="en-US" altLang="zh-CN" sz="2400" b="1" dirty="0">
                 <a:latin typeface="Arial" panose="020B0604020202020204" pitchFamily="34" charset="0"/>
                 <a:cs typeface="Arial" panose="020B0604020202020204" pitchFamily="34" charset="0"/>
               </a:rPr>
@@ -4392,7 +4425,7 @@
           </a:p>
           <a:p>
             <a:r>
-              <a:rPr lang="en-US" altLang="zh-CN" sz="2400" dirty="0">
+              <a:rPr lang="en-US" altLang="zh-CN" sz="2400" b="1" dirty="0">
                 <a:latin typeface="Arial" panose="020B0604020202020204" pitchFamily="34" charset="0"/>
                 <a:cs typeface="Arial" panose="020B0604020202020204" pitchFamily="34" charset="0"/>
               </a:rPr>
@@ -4473,7 +4506,7 @@
           </a:p>
           <a:p>
             <a:r>
-              <a:rPr lang="en-US" altLang="zh-CN" sz="2400" dirty="0">
+              <a:rPr lang="en-US" altLang="zh-CN" sz="2400" b="1" dirty="0">
                 <a:latin typeface="Arial" panose="020B0604020202020204" pitchFamily="34" charset="0"/>
                 <a:cs typeface="Arial" panose="020B0604020202020204" pitchFamily="34" charset="0"/>
               </a:rPr>

</xml_diff>